<commit_message>
updated diagramms and presentation
</commit_message>
<xml_diff>
--- a/03_report/presentation/Poster_BA_A0.pptx
+++ b/03_report/presentation/Poster_BA_A0.pptx
@@ -237,7 +237,7 @@
           <a:p>
             <a:fld id="{10E8699C-A7A2-DC47-8C0B-759D24C52787}" type="datetimeFigureOut">
               <a:rPr lang="en-DE" smtClean="0"/>
-              <a:t>24.07.26</a:t>
+              <a:t>25.07.26</a:t>
             </a:fld>
             <a:endParaRPr lang="en-DE"/>
           </a:p>
@@ -414,7 +414,7 @@
           <a:p>
             <a:fld id="{8946B381-68CC-451E-A196-85699053D4FD}" type="datetimeFigureOut">
               <a:rPr lang="de-DE" smtClean="0"/>
-              <a:t>24.07.26</a:t>
+              <a:t>25.07.26</a:t>
             </a:fld>
             <a:endParaRPr lang="de-DE"/>
           </a:p>
@@ -6980,123 +6980,6 @@
       </p:grpSpPr>
       <p:pic>
         <p:nvPicPr>
-          <p:cNvPr id="4" name="Picture 3">
-            <a:extLst>
-              <a:ext uri="{FF2B5EF4-FFF2-40B4-BE49-F238E27FC236}">
-                <a16:creationId xmlns:a16="http://schemas.microsoft.com/office/drawing/2014/main" id="{3DEAB6E2-06FD-C460-888B-3F69E7EB082B}"/>
-              </a:ext>
-            </a:extLst>
-          </p:cNvPr>
-          <p:cNvPicPr>
-            <a:picLocks noChangeAspect="1"/>
-          </p:cNvPicPr>
-          <p:nvPr/>
-        </p:nvPicPr>
-        <p:blipFill>
-          <a:blip r:embed="rId3"/>
-          <a:stretch>
-            <a:fillRect/>
-          </a:stretch>
-        </p:blipFill>
-        <p:spPr>
-          <a:xfrm>
-            <a:off x="977955" y="21134738"/>
-            <a:ext cx="13251600" cy="5311821"/>
-          </a:xfrm>
-          <a:prstGeom prst="rect">
-            <a:avLst/>
-          </a:prstGeom>
-        </p:spPr>
-      </p:pic>
-      <p:sp>
-        <p:nvSpPr>
-          <p:cNvPr id="2" name="Title 1">
-            <a:extLst>
-              <a:ext uri="{FF2B5EF4-FFF2-40B4-BE49-F238E27FC236}">
-                <a16:creationId xmlns:a16="http://schemas.microsoft.com/office/drawing/2014/main" id="{53927E75-EF0C-5628-48D3-97B955A594B2}"/>
-              </a:ext>
-            </a:extLst>
-          </p:cNvPr>
-          <p:cNvSpPr>
-            <a:spLocks noGrp="1"/>
-          </p:cNvSpPr>
-          <p:nvPr>
-            <p:ph type="title"/>
-          </p:nvPr>
-        </p:nvSpPr>
-        <p:spPr>
-          <a:xfrm>
-            <a:off x="1080655" y="2478505"/>
-            <a:ext cx="20407531" cy="2894164"/>
-          </a:xfrm>
-        </p:spPr>
-        <p:txBody>
-          <a:bodyPr/>
-          <a:lstStyle/>
-          <a:p>
-            <a:r>
-              <a:rPr lang="en-GB" sz="6000" noProof="0" dirty="0"/>
-              <a:t>Shared Mental Models in Generative AI-Based Multi-Agent Systems: A Simulation Study Grounded in Human Team Cognition Theory</a:t>
-            </a:r>
-          </a:p>
-        </p:txBody>
-      </p:sp>
-      <p:sp>
-        <p:nvSpPr>
-          <p:cNvPr id="10" name="Text Placeholder 9">
-            <a:extLst>
-              <a:ext uri="{FF2B5EF4-FFF2-40B4-BE49-F238E27FC236}">
-                <a16:creationId xmlns:a16="http://schemas.microsoft.com/office/drawing/2014/main" id="{96B5322A-F80A-9A85-4CBF-BA165C091A13}"/>
-              </a:ext>
-            </a:extLst>
-          </p:cNvPr>
-          <p:cNvSpPr>
-            <a:spLocks noGrp="1"/>
-          </p:cNvSpPr>
-          <p:nvPr>
-            <p:ph type="body" sz="quarter" idx="31"/>
-          </p:nvPr>
-        </p:nvSpPr>
-        <p:spPr>
-          <a:xfrm>
-            <a:off x="3348201" y="40646451"/>
-            <a:ext cx="3817710" cy="1373419"/>
-          </a:xfrm>
-        </p:spPr>
-        <p:txBody>
-          <a:bodyPr/>
-          <a:lstStyle/>
-          <a:p>
-            <a:r>
-              <a:rPr lang="en-GB" noProof="0" dirty="0"/>
-              <a:t>Leonard Hegemann</a:t>
-            </a:r>
-          </a:p>
-          <a:p>
-            <a:r>
-              <a:rPr lang="en-GB" noProof="0" dirty="0"/>
-              <a:t>70794 </a:t>
-            </a:r>
-            <a:r>
-              <a:rPr lang="en-GB" noProof="0" dirty="0" err="1"/>
-              <a:t>Filderstadt</a:t>
-            </a:r>
-            <a:r>
-              <a:rPr lang="en-GB" noProof="0" dirty="0"/>
-              <a:t>, Germany</a:t>
-            </a:r>
-          </a:p>
-          <a:p>
-            <a:r>
-              <a:rPr lang="en-GB" noProof="0" dirty="0" err="1"/>
-              <a:t>leonard.hegemann@gmx.de</a:t>
-            </a:r>
-            <a:endParaRPr lang="en-GB" noProof="0" dirty="0"/>
-          </a:p>
-        </p:txBody>
-      </p:sp>
-      <p:pic>
-        <p:nvPicPr>
           <p:cNvPr id="23" name="Picture 22">
             <a:extLst>
               <a:ext uri="{FF2B5EF4-FFF2-40B4-BE49-F238E27FC236}">
@@ -7110,7 +6993,7 @@
           <p:nvPr/>
         </p:nvPicPr>
         <p:blipFill>
-          <a:blip r:embed="rId4"/>
+          <a:blip r:embed="rId3"/>
           <a:stretch>
             <a:fillRect/>
           </a:stretch>
@@ -7140,7 +7023,7 @@
           <p:nvPr/>
         </p:nvPicPr>
         <p:blipFill>
-          <a:blip r:embed="rId5"/>
+          <a:blip r:embed="rId4"/>
           <a:stretch>
             <a:fillRect/>
           </a:stretch>
@@ -7155,261 +7038,6 @@
           </a:prstGeom>
         </p:spPr>
       </p:pic>
-      <p:sp>
-        <p:nvSpPr>
-          <p:cNvPr id="11" name="Text Placeholder 10">
-            <a:extLst>
-              <a:ext uri="{FF2B5EF4-FFF2-40B4-BE49-F238E27FC236}">
-                <a16:creationId xmlns:a16="http://schemas.microsoft.com/office/drawing/2014/main" id="{1F26DFCC-8E7D-1978-2365-F7F9D4B55141}"/>
-              </a:ext>
-            </a:extLst>
-          </p:cNvPr>
-          <p:cNvSpPr>
-            <a:spLocks noGrp="1"/>
-          </p:cNvSpPr>
-          <p:nvPr>
-            <p:ph type="body" sz="quarter" idx="29"/>
-          </p:nvPr>
-        </p:nvSpPr>
-        <p:spPr>
-          <a:xfrm>
-            <a:off x="22276160" y="3809826"/>
-            <a:ext cx="6131740" cy="1282723"/>
-          </a:xfrm>
-        </p:spPr>
-        <p:txBody>
-          <a:bodyPr/>
-          <a:lstStyle/>
-          <a:p>
-            <a:r>
-              <a:rPr lang="en-GB" b="1" noProof="0" dirty="0"/>
-              <a:t>Leonard Hegemann</a:t>
-            </a:r>
-          </a:p>
-          <a:p>
-            <a:r>
-              <a:rPr lang="en-GB" noProof="0" dirty="0"/>
-              <a:t>CHAIR of Digital Management</a:t>
-            </a:r>
-          </a:p>
-          <a:p>
-            <a:r>
-              <a:rPr lang="en-GB" noProof="0" dirty="0"/>
-              <a:t>University of Hohenheim, Germany</a:t>
-            </a:r>
-          </a:p>
-        </p:txBody>
-      </p:sp>
-      <p:sp>
-        <p:nvSpPr>
-          <p:cNvPr id="12" name="Text Placeholder 11">
-            <a:extLst>
-              <a:ext uri="{FF2B5EF4-FFF2-40B4-BE49-F238E27FC236}">
-                <a16:creationId xmlns:a16="http://schemas.microsoft.com/office/drawing/2014/main" id="{5BAD6F67-C4FB-7F23-6C32-BCE2289A544E}"/>
-              </a:ext>
-            </a:extLst>
-          </p:cNvPr>
-          <p:cNvSpPr>
-            <a:spLocks noGrp="1"/>
-          </p:cNvSpPr>
-          <p:nvPr>
-            <p:ph type="body" sz="quarter" idx="39"/>
-          </p:nvPr>
-        </p:nvSpPr>
-        <p:spPr>
-          <a:xfrm>
-            <a:off x="8526517" y="40646451"/>
-            <a:ext cx="20192403" cy="1236655"/>
-          </a:xfrm>
-        </p:spPr>
-        <p:txBody>
-          <a:bodyPr/>
-          <a:lstStyle/>
-          <a:p>
-            <a:pPr algn="just">
-              <a:lnSpc>
-                <a:spcPts val="1200"/>
-              </a:lnSpc>
-              <a:spcAft>
-                <a:spcPts val="0"/>
-              </a:spcAft>
-            </a:pPr>
-            <a:r>
-              <a:rPr lang="en-GB" sz="1200" noProof="0" dirty="0"/>
-              <a:t>Cannon-Bowers, J. A., Salas, E., &amp; Converse, S. (1993). Shared mental models in expert team decision making. In N. J. Castellan Jr. (Ed.), Individual and group decision making: Current issues (pp. 221–246). Lawrence Erlbaum Associates.</a:t>
-            </a:r>
-          </a:p>
-          <a:p>
-            <a:pPr algn="just">
-              <a:lnSpc>
-                <a:spcPts val="1200"/>
-              </a:lnSpc>
-              <a:spcAft>
-                <a:spcPts val="0"/>
-              </a:spcAft>
-            </a:pPr>
-            <a:r>
-              <a:rPr lang="en-GB" sz="1200" noProof="0" dirty="0"/>
-              <a:t>Liu, N. F., Lin, K., Hewitt, J., Paranjape, A., Bevilacqua, M., Petroni, F., &amp; Liang, P. (2024). Lost in the middle: How language models use long contexts. Transactions of the Association for Computational Linguistics, 12, 157–173.</a:t>
-            </a:r>
-          </a:p>
-          <a:p>
-            <a:pPr algn="just">
-              <a:lnSpc>
-                <a:spcPts val="1200"/>
-              </a:lnSpc>
-              <a:spcAft>
-                <a:spcPts val="0"/>
-              </a:spcAft>
-            </a:pPr>
-            <a:r>
-              <a:rPr lang="en-GB" sz="1200" noProof="0" dirty="0"/>
-              <a:t>Mathieu, J. E., Heffner, T. S., Goodwin, G. F., Salas, E., &amp; Cannon-Bowers, J. A. (2000). The influence of shared mental models on team process and performance. Journal of Applied Psychology, 85(2), 273–283.</a:t>
-            </a:r>
-          </a:p>
-          <a:p>
-            <a:pPr algn="just">
-              <a:lnSpc>
-                <a:spcPts val="1200"/>
-              </a:lnSpc>
-              <a:spcAft>
-                <a:spcPts val="0"/>
-              </a:spcAft>
-            </a:pPr>
-            <a:r>
-              <a:rPr lang="en-GB" sz="1200" noProof="0" dirty="0"/>
-              <a:t>Schulz-Hardt, S., Brodbeck, F. C., </a:t>
-            </a:r>
-            <a:r>
-              <a:rPr lang="en-GB" sz="1200" noProof="0" dirty="0" err="1"/>
-              <a:t>Mojzisch</a:t>
-            </a:r>
-            <a:r>
-              <a:rPr lang="en-GB" sz="1200" noProof="0" dirty="0"/>
-              <a:t>, A., </a:t>
-            </a:r>
-            <a:r>
-              <a:rPr lang="en-GB" sz="1200" noProof="0" dirty="0" err="1"/>
-              <a:t>Kerschreiter</a:t>
-            </a:r>
-            <a:r>
-              <a:rPr lang="en-GB" sz="1200" noProof="0" dirty="0"/>
-              <a:t>, R., &amp; Frey, D. (2006). Group decision making in hidden profile situations: Dissent as a facilitator for decision quality. Journal of Personality and Social Psychology, 91(6), 1080–1093.</a:t>
-            </a:r>
-          </a:p>
-          <a:p>
-            <a:pPr algn="just">
-              <a:lnSpc>
-                <a:spcPts val="1200"/>
-              </a:lnSpc>
-              <a:spcAft>
-                <a:spcPts val="0"/>
-              </a:spcAft>
-            </a:pPr>
-            <a:r>
-              <a:rPr lang="en-GB" sz="1200" noProof="0" dirty="0"/>
-              <a:t>Stasser, G., &amp; Titus, W. (1985). Pooling of unshared information in group decision making: Biased information sampling during discussion. Journal of Personality and Social Psychology, 48(6), 1467–1478.</a:t>
-            </a:r>
-          </a:p>
-          <a:p>
-            <a:pPr algn="just">
-              <a:lnSpc>
-                <a:spcPts val="1200"/>
-              </a:lnSpc>
-              <a:spcAft>
-                <a:spcPts val="0"/>
-              </a:spcAft>
-            </a:pPr>
-            <a:r>
-              <a:rPr lang="en-GB" sz="1200" noProof="0" dirty="0"/>
-              <a:t>Van Ginkel, W. P., &amp; van Knippenberg, D. (2008). Group information elaboration and group decision making: The role of shared task representations. Organizational </a:t>
-            </a:r>
-            <a:r>
-              <a:rPr lang="en-GB" sz="1200" noProof="0" dirty="0" err="1"/>
-              <a:t>Behavior</a:t>
-            </a:r>
-            <a:r>
-              <a:rPr lang="en-GB" sz="1200" noProof="0" dirty="0"/>
-              <a:t> and Human Decision Processes, 105(1), 82–97.</a:t>
-            </a:r>
-          </a:p>
-          <a:p>
-            <a:pPr algn="just">
-              <a:lnSpc>
-                <a:spcPts val="1200"/>
-              </a:lnSpc>
-              <a:spcAft>
-                <a:spcPts val="0"/>
-              </a:spcAft>
-            </a:pPr>
-            <a:r>
-              <a:rPr lang="en-GB" sz="1200" noProof="0" dirty="0"/>
-              <a:t>Yen, J., Fan, X., Sun, S., Hanratty, T., &amp; </a:t>
-            </a:r>
-            <a:r>
-              <a:rPr lang="en-GB" sz="1200" noProof="0" dirty="0" err="1"/>
-              <a:t>Dumer</a:t>
-            </a:r>
-            <a:r>
-              <a:rPr lang="en-GB" sz="1200" noProof="0" dirty="0"/>
-              <a:t>, J. (2006). Agents with shared mental models for enhancing team decision makings. Decision Support Systems, 41(3), 634–653.</a:t>
-            </a:r>
-          </a:p>
-          <a:p>
-            <a:pPr algn="just">
-              <a:lnSpc>
-                <a:spcPts val="1200"/>
-              </a:lnSpc>
-              <a:spcAft>
-                <a:spcPts val="0"/>
-              </a:spcAft>
-            </a:pPr>
-            <a:r>
-              <a:rPr lang="en-GB" sz="1200" noProof="0" dirty="0"/>
-              <a:t>Zhang, Z., Dai, Q., Bo, X., Ma, C., Li, R., Chen, X., Zhu, J., Dong, Z., &amp; Wen, J.-R. (2025). A survey on the memory mechanism of large language model-based agents. ACM Transactions on Information Systems, 43(6), Article 155, 1–47.</a:t>
-            </a:r>
-          </a:p>
-        </p:txBody>
-      </p:sp>
-      <p:sp>
-        <p:nvSpPr>
-          <p:cNvPr id="13" name="TextBox 12">
-            <a:extLst>
-              <a:ext uri="{FF2B5EF4-FFF2-40B4-BE49-F238E27FC236}">
-                <a16:creationId xmlns:a16="http://schemas.microsoft.com/office/drawing/2014/main" id="{A678D1DC-1565-8F8B-F821-BB5BD5056FB9}"/>
-              </a:ext>
-            </a:extLst>
-          </p:cNvPr>
-          <p:cNvSpPr txBox="1"/>
-          <p:nvPr/>
-        </p:nvSpPr>
-        <p:spPr>
-          <a:xfrm>
-            <a:off x="979486" y="6078981"/>
-            <a:ext cx="6908165" cy="1049106"/>
-          </a:xfrm>
-          <a:prstGeom prst="rect">
-            <a:avLst/>
-          </a:prstGeom>
-          <a:noFill/>
-        </p:spPr>
-        <p:txBody>
-          <a:bodyPr wrap="square" lIns="0" tIns="72000" rIns="0" bIns="144000" rtlCol="0">
-            <a:spAutoFit/>
-          </a:bodyPr>
-          <a:lstStyle/>
-          <a:p>
-            <a:r>
-              <a:rPr lang="en-GB" sz="5400" b="1" noProof="0" dirty="0">
-                <a:solidFill>
-                  <a:schemeClr val="tx2"/>
-                </a:solidFill>
-              </a:rPr>
-              <a:t>I. Introduction</a:t>
-            </a:r>
-          </a:p>
-        </p:txBody>
-      </p:sp>
       <p:pic>
         <p:nvPicPr>
           <p:cNvPr id="19" name="Picture 18">
@@ -7425,6 +7053,36 @@
           <p:nvPr/>
         </p:nvPicPr>
         <p:blipFill>
+          <a:blip r:embed="rId5"/>
+          <a:stretch>
+            <a:fillRect/>
+          </a:stretch>
+        </p:blipFill>
+        <p:spPr>
+          <a:xfrm>
+            <a:off x="23623642" y="31905719"/>
+            <a:ext cx="6120000" cy="6475519"/>
+          </a:xfrm>
+          <a:prstGeom prst="rect">
+            <a:avLst/>
+          </a:prstGeom>
+        </p:spPr>
+      </p:pic>
+      <p:pic>
+        <p:nvPicPr>
+          <p:cNvPr id="24" name="Picture 23">
+            <a:extLst>
+              <a:ext uri="{FF2B5EF4-FFF2-40B4-BE49-F238E27FC236}">
+                <a16:creationId xmlns:a16="http://schemas.microsoft.com/office/drawing/2014/main" id="{07B020DD-A5FD-5730-4352-FAA8101E4772}"/>
+              </a:ext>
+            </a:extLst>
+          </p:cNvPr>
+          <p:cNvPicPr>
+            <a:picLocks noChangeAspect="1"/>
+          </p:cNvPicPr>
+          <p:nvPr/>
+        </p:nvPicPr>
+        <p:blipFill>
           <a:blip r:embed="rId6"/>
           <a:stretch>
             <a:fillRect/>
@@ -7432,7 +7090,7 @@
         </p:blipFill>
         <p:spPr>
           <a:xfrm>
-            <a:off x="23623642" y="31905719"/>
+            <a:off x="16075079" y="31905717"/>
             <a:ext cx="6120000" cy="6475519"/>
           </a:xfrm>
           <a:prstGeom prst="rect">
@@ -7440,6 +7098,371 @@
           </a:prstGeom>
         </p:spPr>
       </p:pic>
+      <p:pic>
+        <p:nvPicPr>
+          <p:cNvPr id="4" name="Picture 3">
+            <a:extLst>
+              <a:ext uri="{FF2B5EF4-FFF2-40B4-BE49-F238E27FC236}">
+                <a16:creationId xmlns:a16="http://schemas.microsoft.com/office/drawing/2014/main" id="{3DEAB6E2-06FD-C460-888B-3F69E7EB082B}"/>
+              </a:ext>
+            </a:extLst>
+          </p:cNvPr>
+          <p:cNvPicPr>
+            <a:picLocks noChangeAspect="1"/>
+          </p:cNvPicPr>
+          <p:nvPr/>
+        </p:nvPicPr>
+        <p:blipFill>
+          <a:blip r:embed="rId7"/>
+          <a:stretch>
+            <a:fillRect/>
+          </a:stretch>
+        </p:blipFill>
+        <p:spPr>
+          <a:xfrm>
+            <a:off x="977955" y="21134738"/>
+            <a:ext cx="13251600" cy="5311821"/>
+          </a:xfrm>
+          <a:prstGeom prst="rect">
+            <a:avLst/>
+          </a:prstGeom>
+        </p:spPr>
+      </p:pic>
+      <p:sp>
+        <p:nvSpPr>
+          <p:cNvPr id="2" name="Title 1">
+            <a:extLst>
+              <a:ext uri="{FF2B5EF4-FFF2-40B4-BE49-F238E27FC236}">
+                <a16:creationId xmlns:a16="http://schemas.microsoft.com/office/drawing/2014/main" id="{53927E75-EF0C-5628-48D3-97B955A594B2}"/>
+              </a:ext>
+            </a:extLst>
+          </p:cNvPr>
+          <p:cNvSpPr>
+            <a:spLocks noGrp="1"/>
+          </p:cNvSpPr>
+          <p:nvPr>
+            <p:ph type="title"/>
+          </p:nvPr>
+        </p:nvSpPr>
+        <p:spPr>
+          <a:xfrm>
+            <a:off x="1080655" y="2478505"/>
+            <a:ext cx="20407531" cy="2894164"/>
+          </a:xfrm>
+        </p:spPr>
+        <p:txBody>
+          <a:bodyPr/>
+          <a:lstStyle/>
+          <a:p>
+            <a:r>
+              <a:rPr lang="en-GB" sz="6000" noProof="0" dirty="0"/>
+              <a:t>Shared Mental Models in Generative AI-Based Multi-Agent Systems: A Simulation Study Grounded in Human Team Cognition Theory</a:t>
+            </a:r>
+          </a:p>
+        </p:txBody>
+      </p:sp>
+      <p:sp>
+        <p:nvSpPr>
+          <p:cNvPr id="10" name="Text Placeholder 9">
+            <a:extLst>
+              <a:ext uri="{FF2B5EF4-FFF2-40B4-BE49-F238E27FC236}">
+                <a16:creationId xmlns:a16="http://schemas.microsoft.com/office/drawing/2014/main" id="{96B5322A-F80A-9A85-4CBF-BA165C091A13}"/>
+              </a:ext>
+            </a:extLst>
+          </p:cNvPr>
+          <p:cNvSpPr>
+            <a:spLocks noGrp="1"/>
+          </p:cNvSpPr>
+          <p:nvPr>
+            <p:ph type="body" sz="quarter" idx="31"/>
+          </p:nvPr>
+        </p:nvSpPr>
+        <p:spPr>
+          <a:xfrm>
+            <a:off x="3348201" y="40646451"/>
+            <a:ext cx="3817710" cy="1373419"/>
+          </a:xfrm>
+        </p:spPr>
+        <p:txBody>
+          <a:bodyPr/>
+          <a:lstStyle/>
+          <a:p>
+            <a:r>
+              <a:rPr lang="en-GB" noProof="0" dirty="0"/>
+              <a:t>Leonard Hegemann</a:t>
+            </a:r>
+          </a:p>
+          <a:p>
+            <a:r>
+              <a:rPr lang="en-GB" noProof="0" dirty="0"/>
+              <a:t>70794 </a:t>
+            </a:r>
+            <a:r>
+              <a:rPr lang="en-GB" noProof="0" dirty="0" err="1"/>
+              <a:t>Filderstadt</a:t>
+            </a:r>
+            <a:r>
+              <a:rPr lang="en-GB" noProof="0" dirty="0"/>
+              <a:t>, Germany</a:t>
+            </a:r>
+          </a:p>
+        </p:txBody>
+      </p:sp>
+      <p:sp>
+        <p:nvSpPr>
+          <p:cNvPr id="11" name="Text Placeholder 10">
+            <a:extLst>
+              <a:ext uri="{FF2B5EF4-FFF2-40B4-BE49-F238E27FC236}">
+                <a16:creationId xmlns:a16="http://schemas.microsoft.com/office/drawing/2014/main" id="{1F26DFCC-8E7D-1978-2365-F7F9D4B55141}"/>
+              </a:ext>
+            </a:extLst>
+          </p:cNvPr>
+          <p:cNvSpPr>
+            <a:spLocks noGrp="1"/>
+          </p:cNvSpPr>
+          <p:nvPr>
+            <p:ph type="body" sz="quarter" idx="29"/>
+          </p:nvPr>
+        </p:nvSpPr>
+        <p:spPr>
+          <a:xfrm>
+            <a:off x="22276160" y="3809826"/>
+            <a:ext cx="6131740" cy="1282723"/>
+          </a:xfrm>
+        </p:spPr>
+        <p:txBody>
+          <a:bodyPr/>
+          <a:lstStyle/>
+          <a:p>
+            <a:r>
+              <a:rPr lang="en-GB" b="1" noProof="0" dirty="0"/>
+              <a:t>Leonard Hegemann</a:t>
+            </a:r>
+          </a:p>
+          <a:p>
+            <a:r>
+              <a:rPr lang="en-GB" noProof="0" dirty="0"/>
+              <a:t>CHAIR of Digital Management</a:t>
+            </a:r>
+          </a:p>
+          <a:p>
+            <a:r>
+              <a:rPr lang="en-GB" noProof="0" dirty="0"/>
+              <a:t>University of Hohenheim, Germany</a:t>
+            </a:r>
+          </a:p>
+        </p:txBody>
+      </p:sp>
+      <p:sp>
+        <p:nvSpPr>
+          <p:cNvPr id="12" name="Text Placeholder 11">
+            <a:extLst>
+              <a:ext uri="{FF2B5EF4-FFF2-40B4-BE49-F238E27FC236}">
+                <a16:creationId xmlns:a16="http://schemas.microsoft.com/office/drawing/2014/main" id="{5BAD6F67-C4FB-7F23-6C32-BCE2289A544E}"/>
+              </a:ext>
+            </a:extLst>
+          </p:cNvPr>
+          <p:cNvSpPr>
+            <a:spLocks noGrp="1"/>
+          </p:cNvSpPr>
+          <p:nvPr>
+            <p:ph type="body" sz="quarter" idx="39"/>
+          </p:nvPr>
+        </p:nvSpPr>
+        <p:spPr>
+          <a:xfrm>
+            <a:off x="8526517" y="40646451"/>
+            <a:ext cx="20192403" cy="1236655"/>
+          </a:xfrm>
+        </p:spPr>
+        <p:txBody>
+          <a:bodyPr/>
+          <a:lstStyle/>
+          <a:p>
+            <a:pPr algn="just">
+              <a:lnSpc>
+                <a:spcPts val="1200"/>
+              </a:lnSpc>
+              <a:spcAft>
+                <a:spcPts val="0"/>
+              </a:spcAft>
+            </a:pPr>
+            <a:r>
+              <a:rPr lang="en-GB" sz="1200" noProof="0" dirty="0"/>
+              <a:t>Cannon-Bowers, J. A., Salas, E., &amp; Converse, S. (1993). Shared mental models in expert team decision making. In N. J. Castellan Jr. (Ed.), Individual and group decision making: Current issues (pp. 221–246). Lawrence Erlbaum Associates.</a:t>
+            </a:r>
+          </a:p>
+          <a:p>
+            <a:pPr algn="just">
+              <a:lnSpc>
+                <a:spcPts val="1200"/>
+              </a:lnSpc>
+              <a:spcAft>
+                <a:spcPts val="0"/>
+              </a:spcAft>
+            </a:pPr>
+            <a:r>
+              <a:rPr lang="en-GB" sz="1200" noProof="0" dirty="0"/>
+              <a:t>Liu, N. F., Lin, K., Hewitt, J., Paranjape, A., Bevilacqua, M., Petroni, F., &amp; Liang, P. (2024). Lost in the middle: How language models use long contexts. Transactions of the Association for Computational Linguistics, 12, 157–173.</a:t>
+            </a:r>
+          </a:p>
+          <a:p>
+            <a:pPr algn="just">
+              <a:lnSpc>
+                <a:spcPts val="1200"/>
+              </a:lnSpc>
+              <a:spcAft>
+                <a:spcPts val="0"/>
+              </a:spcAft>
+            </a:pPr>
+            <a:r>
+              <a:rPr lang="en-GB" sz="1200" noProof="0" dirty="0"/>
+              <a:t>Mathieu, J. E., Heffner, T. S., Goodwin, G. F., Salas, E., &amp; Cannon-Bowers, J. A. (2000). The influence of shared mental models on team process and performance. Journal of Applied Psychology, 85(2), 273–283.</a:t>
+            </a:r>
+          </a:p>
+          <a:p>
+            <a:pPr algn="just">
+              <a:lnSpc>
+                <a:spcPts val="1200"/>
+              </a:lnSpc>
+              <a:spcAft>
+                <a:spcPts val="0"/>
+              </a:spcAft>
+            </a:pPr>
+            <a:r>
+              <a:rPr lang="en-GB" sz="1200" noProof="0" dirty="0"/>
+              <a:t>Schulz-Hardt, S., Brodbeck, F. C., </a:t>
+            </a:r>
+            <a:r>
+              <a:rPr lang="en-GB" sz="1200" noProof="0" dirty="0" err="1"/>
+              <a:t>Mojzisch</a:t>
+            </a:r>
+            <a:r>
+              <a:rPr lang="en-GB" sz="1200" noProof="0" dirty="0"/>
+              <a:t>, A., </a:t>
+            </a:r>
+            <a:r>
+              <a:rPr lang="en-GB" sz="1200" noProof="0" dirty="0" err="1"/>
+              <a:t>Kerschreiter</a:t>
+            </a:r>
+            <a:r>
+              <a:rPr lang="en-GB" sz="1200" noProof="0" dirty="0"/>
+              <a:t>, R., &amp; Frey, D. (2006). Group decision making in hidden profile situations: Dissent as a facilitator for decision quality. Journal of Personality and Social Psychology, 91(6), 1080–1093.</a:t>
+            </a:r>
+          </a:p>
+          <a:p>
+            <a:pPr algn="just">
+              <a:lnSpc>
+                <a:spcPts val="1200"/>
+              </a:lnSpc>
+              <a:spcAft>
+                <a:spcPts val="0"/>
+              </a:spcAft>
+            </a:pPr>
+            <a:r>
+              <a:rPr lang="en-GB" sz="1200" noProof="0" dirty="0"/>
+              <a:t>Stasser, G., &amp; Titus, W. (1985). Pooling of unshared information in group decision making: Biased information sampling during discussion. Journal of Personality and Social Psychology, 48(6), 1467–1478.</a:t>
+            </a:r>
+          </a:p>
+          <a:p>
+            <a:pPr algn="just">
+              <a:lnSpc>
+                <a:spcPts val="1200"/>
+              </a:lnSpc>
+              <a:spcAft>
+                <a:spcPts val="0"/>
+              </a:spcAft>
+            </a:pPr>
+            <a:r>
+              <a:rPr lang="en-GB" sz="1200" noProof="0" dirty="0"/>
+              <a:t>Van Ginkel, W. P., &amp; van Knippenberg, D. (2008). Group information elaboration and group decision making: The role of shared task representations. Organizational </a:t>
+            </a:r>
+            <a:r>
+              <a:rPr lang="en-GB" sz="1200" noProof="0" dirty="0" err="1"/>
+              <a:t>Behavior</a:t>
+            </a:r>
+            <a:r>
+              <a:rPr lang="en-GB" sz="1200" noProof="0" dirty="0"/>
+              <a:t> and Human Decision Processes, 105(1), 82–97.</a:t>
+            </a:r>
+          </a:p>
+          <a:p>
+            <a:pPr algn="just">
+              <a:lnSpc>
+                <a:spcPts val="1200"/>
+              </a:lnSpc>
+              <a:spcAft>
+                <a:spcPts val="0"/>
+              </a:spcAft>
+            </a:pPr>
+            <a:r>
+              <a:rPr lang="en-GB" sz="1200" noProof="0" dirty="0"/>
+              <a:t>Yen, J., Fan, X., Sun, S., Hanratty, T., &amp; </a:t>
+            </a:r>
+            <a:r>
+              <a:rPr lang="en-GB" sz="1200" noProof="0" dirty="0" err="1"/>
+              <a:t>Dumer</a:t>
+            </a:r>
+            <a:r>
+              <a:rPr lang="en-GB" sz="1200" noProof="0" dirty="0"/>
+              <a:t>, J. (2006). Agents with shared mental models for enhancing team decision makings. Decision Support Systems, 41(3), 634–653.</a:t>
+            </a:r>
+          </a:p>
+          <a:p>
+            <a:pPr algn="just">
+              <a:lnSpc>
+                <a:spcPts val="1200"/>
+              </a:lnSpc>
+              <a:spcAft>
+                <a:spcPts val="0"/>
+              </a:spcAft>
+            </a:pPr>
+            <a:r>
+              <a:rPr lang="en-GB" sz="1200" noProof="0" dirty="0"/>
+              <a:t>Zhang, Z., Dai, Q., Bo, X., Ma, C., Li, R., Chen, X., Zhu, J., Dong, Z., &amp; Wen, J.-R. (2025). A survey on the memory mechanism of large language model-based agents. ACM Transactions on Information Systems, 43(6), Article 155, 1–47.</a:t>
+            </a:r>
+          </a:p>
+        </p:txBody>
+      </p:sp>
+      <p:sp>
+        <p:nvSpPr>
+          <p:cNvPr id="13" name="TextBox 12">
+            <a:extLst>
+              <a:ext uri="{FF2B5EF4-FFF2-40B4-BE49-F238E27FC236}">
+                <a16:creationId xmlns:a16="http://schemas.microsoft.com/office/drawing/2014/main" id="{A678D1DC-1565-8F8B-F821-BB5BD5056FB9}"/>
+              </a:ext>
+            </a:extLst>
+          </p:cNvPr>
+          <p:cNvSpPr txBox="1"/>
+          <p:nvPr/>
+        </p:nvSpPr>
+        <p:spPr>
+          <a:xfrm>
+            <a:off x="979486" y="6078981"/>
+            <a:ext cx="6908165" cy="1049106"/>
+          </a:xfrm>
+          <a:prstGeom prst="rect">
+            <a:avLst/>
+          </a:prstGeom>
+          <a:noFill/>
+        </p:spPr>
+        <p:txBody>
+          <a:bodyPr wrap="square" lIns="0" tIns="72000" rIns="0" bIns="144000" rtlCol="0">
+            <a:spAutoFit/>
+          </a:bodyPr>
+          <a:lstStyle/>
+          <a:p>
+            <a:r>
+              <a:rPr lang="en-GB" sz="5400" b="1" noProof="0" dirty="0">
+                <a:solidFill>
+                  <a:schemeClr val="tx2"/>
+                </a:solidFill>
+              </a:rPr>
+              <a:t>I. Introduction</a:t>
+            </a:r>
+          </a:p>
+        </p:txBody>
+      </p:sp>
       <p:sp>
         <p:nvSpPr>
           <p:cNvPr id="14" name="TextBox 13">
@@ -7598,20 +7621,40 @@
                   </a:schemeClr>
                 </a:solidFill>
               </a:rPr>
-              <a:t>Research commonly explains team performance through the input–process–outcome (I-P-O) framework. Inputs comprise the resources and conditions available to a team, processes describe how members transform inputs into outputs, and outcomes capture the results of their collective work. One central input factor is the SMM. It provides team members with a sufficiently compatible understanding of the task, the team, and the current situation. This common cognitive basis helps members anticipate what information others need, connect individual contributions to the collective task, and coordinate their actions. Within the I-P-O framework, SMMs affect two central team processes: communication and cooperation, which in turn shape team performance.</a:t>
-            </a:r>
-          </a:p>
-          <a:p>
-            <a:pPr algn="just"/>
-            <a:r>
-              <a:rPr lang="en-GB" sz="3000" noProof="0" dirty="0">
+              <a:t>Research commonly explains team performance through the input-process</a:t>
+            </a:r>
+            <a:r>
+              <a:rPr lang="en-GB" sz="3000" dirty="0">
                 <a:solidFill>
                   <a:schemeClr val="tx1">
                     <a:lumMod val="75000"/>
                   </a:schemeClr>
                 </a:solidFill>
               </a:rPr>
-              <a:t>GenAI-based MAS face an analogous coordination problem when specialised agents must integrate distributed information into a joint decision. To address this problem, this study implements an SMM-inspired structured memory mechanism. It records candidate-specific strengths and concerns, the discussion coverage, the information distribution, agents’ current positions, and unresolved issues and is reintroduced into the agents’ context before subsequent contributions. Its effects may depend on how much prior discussion history remains accessible alongside it. This amount is termed discussion history transparency. The presence of structured memory and the level of discussion history transparency together define the system’s context configuration</a:t>
+              <a:t>-</a:t>
+            </a:r>
+            <a:r>
+              <a:rPr lang="en-GB" sz="3000" noProof="0" dirty="0">
+                <a:solidFill>
+                  <a:schemeClr val="tx1">
+                    <a:lumMod val="75000"/>
+                  </a:schemeClr>
+                </a:solidFill>
+              </a:rPr>
+              <a:t>outcome (I-P-O) framework. Inputs comprise the resources and conditions available to a team, processes describe how members transform inputs into outputs, and outcomes capture the results of their collective work. One central input factor is the SMM. It provides team members with a sufficiently compatible understanding of the task, the team, and the current situation. This common cognitive basis helps members anticipate what information others need, connect individual contributions to the collective task, and coordinate their actions. Within the I-P-O framework, SMMs affect two central team processes: communication and cooperation, which in turn shape the team performance.</a:t>
+            </a:r>
+          </a:p>
+          <a:p>
+            <a:pPr algn="just"/>
+            <a:r>
+              <a:rPr lang="en-GB" sz="3000" noProof="0" dirty="0">
+                <a:solidFill>
+                  <a:schemeClr val="tx1">
+                    <a:lumMod val="75000"/>
+                  </a:schemeClr>
+                </a:solidFill>
+              </a:rPr>
+              <a:t>GenAI-based MAS face an analogous collaboration problem when specialised agents must integrate distributed information into a joint decision. To address this problem, this study implements an SMM-inspired structured memory mechanism. It records candidate-specific strengths and concerns, the discussion coverage, the information distribution, agents’ current positions, and unresolved issues. It is then reintroduced into the agents’ context before subsequent contributions. Its effects may depend on how much prior discussion history remains accessible alongside it. This amount is termed discussion history transparency. The presence of structured memory and the level of discussion history transparency together define the system’s context configuration.</a:t>
             </a:r>
           </a:p>
         </p:txBody>
@@ -7751,7 +7794,7 @@
         <p:spPr>
           <a:xfrm>
             <a:off x="978225" y="27814568"/>
-            <a:ext cx="28765417" cy="4154984"/>
+            <a:ext cx="28765417" cy="4616648"/>
           </a:xfrm>
           <a:prstGeom prst="rect">
             <a:avLst/>
@@ -7773,28 +7816,18 @@
                   </a:schemeClr>
                 </a:solidFill>
               </a:rPr>
-              <a:t>OLS regression models with HC3 standard errors were estimated for communication quality, cooperation quality, and efficiency, while effectiveness was analysed using a logistic regression. The analyses yielded three main findings. First, the structured memory configurations achieved higher percentages of correct decisions than the baseline but required substantially more weighted tokens. Low transparency produced the highest communication and cooperation scores, and the highest percentage of correct decisions. Second, more discussion history was not necessarily beneficial. Compared with moderate transparency, high transparency increased weighted token usage and reduced decision effectiveness, suggesting that extensive discussion history may reduce the salience of relevant information. Third, communication and cooperation fulfil distinct functions in GenAI-based MAS. Greater uptake of initially private information was associated with a higher probability of a correct decision but also with greater token usage. Greater integration of others’ contributions was associated with lower token usage and was marginally positively associated with decision effectiveness. Overall, GenAI-based MAS benefit more from a compact, structured representation of the team’s evolving knowledge than from extensive access to prior discussion history. Context management therefore plays a vital role in GenAI-based MAS</a:t>
-            </a:r>
-            <a:r>
-              <a:rPr lang="en-GB" sz="3000" dirty="0">
-                <a:solidFill>
-                  <a:schemeClr val="tx1">
-                    <a:lumMod val="75000"/>
-                  </a:schemeClr>
-                </a:solidFill>
-              </a:rPr>
-              <a:t>, as </a:t>
-            </a:r>
-            <a:r>
-              <a:rPr lang="en-GB" sz="3000" noProof="0" dirty="0">
-                <a:solidFill>
-                  <a:schemeClr val="tx1">
-                    <a:lumMod val="75000"/>
-                  </a:schemeClr>
-                </a:solidFill>
-              </a:rPr>
-              <a:t>context composition is more important than context volume alone.</a:t>
-            </a:r>
+              <a:t>OLS regression models with HC3 standard errors were estimated for communication quality, cooperation quality, and efficiency, while effectiveness was analysed using a logistic regression. The analyses yielded three main findings. First, the structured memory configurations achieved higher percentages of correct decisions than the baseline but required substantially more weighted tokens. Low transparency produced the highest communication and cooperation scores, and the highest percentage of correct decisions among all context configurations. Second, more discussion history was not necessarily beneficial. Compared with moderate transparency, high transparency increased weighted token usage and reduced decision effectiveness. Third, communication and cooperation fulfil distinct functions in GenAI-based MAS. Greater uptake of initially private information was associated with a higher probability of a correct decision but also with greater token usage. Greater integration of others’ contributions was associated with lower token usage and was marginally positively associated with decision effectiveness. Overall, GenAI-based MAS benefit more from a compact, structured representation of the team’s evolving knowledge than from extensive access to prior discussion history. Designers should therefore prioritise structured memory over raw discussion history, as context composition is more important than context volume alone.</a:t>
+            </a:r>
+          </a:p>
+          <a:p>
+            <a:pPr algn="just"/>
+            <a:endParaRPr lang="en-GB" sz="3000" noProof="0" dirty="0">
+              <a:solidFill>
+                <a:schemeClr val="tx1">
+                  <a:lumMod val="75000"/>
+                </a:schemeClr>
+              </a:solidFill>
+            </a:endParaRPr>
           </a:p>
         </p:txBody>
       </p:sp>
@@ -8190,7 +8223,7 @@
           <p:nvPr/>
         </p:nvPicPr>
         <p:blipFill>
-          <a:blip r:embed="rId7"/>
+          <a:blip r:embed="rId8"/>
           <a:stretch>
             <a:fillRect/>
           </a:stretch>
@@ -8220,7 +8253,7 @@
           <p:nvPr/>
         </p:nvPicPr>
         <p:blipFill>
-          <a:blip r:embed="rId8"/>
+          <a:blip r:embed="rId9"/>
           <a:srcRect l="27758" t="10170" r="27516" b="58394"/>
           <a:stretch>
             <a:fillRect/>
@@ -8230,36 +8263,6 @@
           <a:xfrm>
             <a:off x="977954" y="39948652"/>
             <a:ext cx="1970257" cy="1959775"/>
-          </a:xfrm>
-          <a:prstGeom prst="rect">
-            <a:avLst/>
-          </a:prstGeom>
-        </p:spPr>
-      </p:pic>
-      <p:pic>
-        <p:nvPicPr>
-          <p:cNvPr id="24" name="Picture 23">
-            <a:extLst>
-              <a:ext uri="{FF2B5EF4-FFF2-40B4-BE49-F238E27FC236}">
-                <a16:creationId xmlns:a16="http://schemas.microsoft.com/office/drawing/2014/main" id="{07B020DD-A5FD-5730-4352-FAA8101E4772}"/>
-              </a:ext>
-            </a:extLst>
-          </p:cNvPr>
-          <p:cNvPicPr>
-            <a:picLocks noChangeAspect="1"/>
-          </p:cNvPicPr>
-          <p:nvPr/>
-        </p:nvPicPr>
-        <p:blipFill>
-          <a:blip r:embed="rId9"/>
-          <a:stretch>
-            <a:fillRect/>
-          </a:stretch>
-        </p:blipFill>
-        <p:spPr>
-          <a:xfrm>
-            <a:off x="16075079" y="31905717"/>
-            <a:ext cx="6120000" cy="6475519"/>
           </a:xfrm>
           <a:prstGeom prst="rect">
             <a:avLst/>

</xml_diff>

<commit_message>
Corrected plots and updated thesis pdf
</commit_message>
<xml_diff>
--- a/03_report/presentation/Poster_BA_A0.pptx
+++ b/03_report/presentation/Poster_BA_A0.pptx
@@ -13,14 +13,14 @@
   <p:sldIdLst>
     <p:sldId id="260" r:id="rId2"/>
   </p:sldIdLst>
-  <p:sldSz cx="30240288" cy="42479913"/>
+  <p:sldSz cx="30275213" cy="42803763"/>
   <p:notesSz cx="6858000" cy="9144000"/>
   <p:defaultTextStyle>
     <a:defPPr>
       <a:defRPr lang="de-DE"/>
     </a:defPPr>
-    <a:lvl1pPr marL="0" algn="l" defTabSz="3489669" rtl="0" eaLnBrk="1" latinLnBrk="0" hangingPunct="1">
-      <a:defRPr sz="6871" kern="1200">
+    <a:lvl1pPr marL="0" algn="l" defTabSz="3506768" rtl="0" eaLnBrk="1" latinLnBrk="0" hangingPunct="1">
+      <a:defRPr sz="6905" kern="1200">
         <a:solidFill>
           <a:schemeClr val="tx1"/>
         </a:solidFill>
@@ -29,8 +29,8 @@
         <a:cs typeface="+mn-cs"/>
       </a:defRPr>
     </a:lvl1pPr>
-    <a:lvl2pPr marL="1744834" algn="l" defTabSz="3489669" rtl="0" eaLnBrk="1" latinLnBrk="0" hangingPunct="1">
-      <a:defRPr sz="6871" kern="1200">
+    <a:lvl2pPr marL="1753384" algn="l" defTabSz="3506768" rtl="0" eaLnBrk="1" latinLnBrk="0" hangingPunct="1">
+      <a:defRPr sz="6905" kern="1200">
         <a:solidFill>
           <a:schemeClr val="tx1"/>
         </a:solidFill>
@@ -39,8 +39,8 @@
         <a:cs typeface="+mn-cs"/>
       </a:defRPr>
     </a:lvl2pPr>
-    <a:lvl3pPr marL="3489669" algn="l" defTabSz="3489669" rtl="0" eaLnBrk="1" latinLnBrk="0" hangingPunct="1">
-      <a:defRPr sz="6871" kern="1200">
+    <a:lvl3pPr marL="3506768" algn="l" defTabSz="3506768" rtl="0" eaLnBrk="1" latinLnBrk="0" hangingPunct="1">
+      <a:defRPr sz="6905" kern="1200">
         <a:solidFill>
           <a:schemeClr val="tx1"/>
         </a:solidFill>
@@ -49,8 +49,8 @@
         <a:cs typeface="+mn-cs"/>
       </a:defRPr>
     </a:lvl3pPr>
-    <a:lvl4pPr marL="5234503" algn="l" defTabSz="3489669" rtl="0" eaLnBrk="1" latinLnBrk="0" hangingPunct="1">
-      <a:defRPr sz="6871" kern="1200">
+    <a:lvl4pPr marL="5260152" algn="l" defTabSz="3506768" rtl="0" eaLnBrk="1" latinLnBrk="0" hangingPunct="1">
+      <a:defRPr sz="6905" kern="1200">
         <a:solidFill>
           <a:schemeClr val="tx1"/>
         </a:solidFill>
@@ -59,8 +59,8 @@
         <a:cs typeface="+mn-cs"/>
       </a:defRPr>
     </a:lvl4pPr>
-    <a:lvl5pPr marL="6979338" algn="l" defTabSz="3489669" rtl="0" eaLnBrk="1" latinLnBrk="0" hangingPunct="1">
-      <a:defRPr sz="6871" kern="1200">
+    <a:lvl5pPr marL="7013537" algn="l" defTabSz="3506768" rtl="0" eaLnBrk="1" latinLnBrk="0" hangingPunct="1">
+      <a:defRPr sz="6905" kern="1200">
         <a:solidFill>
           <a:schemeClr val="tx1"/>
         </a:solidFill>
@@ -69,8 +69,8 @@
         <a:cs typeface="+mn-cs"/>
       </a:defRPr>
     </a:lvl5pPr>
-    <a:lvl6pPr marL="8724176" algn="l" defTabSz="3489669" rtl="0" eaLnBrk="1" latinLnBrk="0" hangingPunct="1">
-      <a:defRPr sz="6871" kern="1200">
+    <a:lvl6pPr marL="8766924" algn="l" defTabSz="3506768" rtl="0" eaLnBrk="1" latinLnBrk="0" hangingPunct="1">
+      <a:defRPr sz="6905" kern="1200">
         <a:solidFill>
           <a:schemeClr val="tx1"/>
         </a:solidFill>
@@ -79,8 +79,8 @@
         <a:cs typeface="+mn-cs"/>
       </a:defRPr>
     </a:lvl6pPr>
-    <a:lvl7pPr marL="10469006" algn="l" defTabSz="3489669" rtl="0" eaLnBrk="1" latinLnBrk="0" hangingPunct="1">
-      <a:defRPr sz="6871" kern="1200">
+    <a:lvl7pPr marL="10520304" algn="l" defTabSz="3506768" rtl="0" eaLnBrk="1" latinLnBrk="0" hangingPunct="1">
+      <a:defRPr sz="6905" kern="1200">
         <a:solidFill>
           <a:schemeClr val="tx1"/>
         </a:solidFill>
@@ -89,8 +89,8 @@
         <a:cs typeface="+mn-cs"/>
       </a:defRPr>
     </a:lvl7pPr>
-    <a:lvl8pPr marL="12213845" algn="l" defTabSz="3489669" rtl="0" eaLnBrk="1" latinLnBrk="0" hangingPunct="1">
-      <a:defRPr sz="6871" kern="1200">
+    <a:lvl8pPr marL="12273693" algn="l" defTabSz="3506768" rtl="0" eaLnBrk="1" latinLnBrk="0" hangingPunct="1">
+      <a:defRPr sz="6905" kern="1200">
         <a:solidFill>
           <a:schemeClr val="tx1"/>
         </a:solidFill>
@@ -99,8 +99,8 @@
         <a:cs typeface="+mn-cs"/>
       </a:defRPr>
     </a:lvl8pPr>
-    <a:lvl9pPr marL="13958679" algn="l" defTabSz="3489669" rtl="0" eaLnBrk="1" latinLnBrk="0" hangingPunct="1">
-      <a:defRPr sz="6871" kern="1200">
+    <a:lvl9pPr marL="14027077" algn="l" defTabSz="3506768" rtl="0" eaLnBrk="1" latinLnBrk="0" hangingPunct="1">
+      <a:defRPr sz="6905" kern="1200">
         <a:solidFill>
           <a:schemeClr val="tx1"/>
         </a:solidFill>
@@ -113,12 +113,12 @@
   <p:extLst>
     <p:ext uri="{EFAFB233-063F-42B5-8137-9DF3F51BA10A}">
       <p15:sldGuideLst xmlns:p15="http://schemas.microsoft.com/office/powerpoint/2012/main">
-        <p15:guide id="1" orient="horz" pos="13380" userDrawn="1">
+        <p15:guide id="1" orient="horz" pos="13482" userDrawn="1">
           <p15:clr>
             <a:srgbClr val="A4A3A4"/>
           </p15:clr>
         </p15:guide>
-        <p15:guide id="2" pos="9525" userDrawn="1">
+        <p15:guide id="2" pos="9536" userDrawn="1">
           <p15:clr>
             <a:srgbClr val="A4A3A4"/>
           </p15:clr>
@@ -237,7 +237,7 @@
           <a:p>
             <a:fld id="{10E8699C-A7A2-DC47-8C0B-759D24C52787}" type="datetimeFigureOut">
               <a:rPr lang="en-DE" smtClean="0"/>
-              <a:t>25.07.26</a:t>
+              <a:t>27.07.26</a:t>
             </a:fld>
             <a:endParaRPr lang="en-DE"/>
           </a:p>
@@ -414,7 +414,7 @@
           <a:p>
             <a:fld id="{8946B381-68CC-451E-A196-85699053D4FD}" type="datetimeFigureOut">
               <a:rPr lang="de-DE" smtClean="0"/>
-              <a:t>25.07.26</a:t>
+              <a:t>27.07.26</a:t>
             </a:fld>
             <a:endParaRPr lang="de-DE"/>
           </a:p>
@@ -432,8 +432,8 @@
         </p:nvSpPr>
         <p:spPr>
           <a:xfrm>
-            <a:off x="2330450" y="1143000"/>
-            <a:ext cx="2197100" cy="3086100"/>
+            <a:off x="2338388" y="1143000"/>
+            <a:ext cx="2181225" cy="3086100"/>
           </a:xfrm>
           <a:prstGeom prst="rect">
             <a:avLst/>
@@ -587,8 +587,8 @@
   </p:cSld>
   <p:clrMap bg1="lt1" tx1="dk1" bg2="lt2" tx2="dk2" accent1="accent1" accent2="accent2" accent3="accent3" accent4="accent4" accent5="accent5" accent6="accent6" hlink="hlink" folHlink="folHlink"/>
   <p:notesStyle>
-    <a:lvl1pPr marL="0" algn="l" defTabSz="914400" rtl="0" eaLnBrk="1" latinLnBrk="0" hangingPunct="1">
-      <a:defRPr sz="1200" kern="1200">
+    <a:lvl1pPr marL="0" algn="l" defTabSz="918881" rtl="0" eaLnBrk="1" latinLnBrk="0" hangingPunct="1">
+      <a:defRPr sz="1206" kern="1200">
         <a:solidFill>
           <a:schemeClr val="tx1"/>
         </a:solidFill>
@@ -597,8 +597,8 @@
         <a:cs typeface="+mn-cs"/>
       </a:defRPr>
     </a:lvl1pPr>
-    <a:lvl2pPr marL="457200" algn="l" defTabSz="914400" rtl="0" eaLnBrk="1" latinLnBrk="0" hangingPunct="1">
-      <a:defRPr sz="1200" kern="1200">
+    <a:lvl2pPr marL="459440" algn="l" defTabSz="918881" rtl="0" eaLnBrk="1" latinLnBrk="0" hangingPunct="1">
+      <a:defRPr sz="1206" kern="1200">
         <a:solidFill>
           <a:schemeClr val="tx1"/>
         </a:solidFill>
@@ -607,8 +607,8 @@
         <a:cs typeface="+mn-cs"/>
       </a:defRPr>
     </a:lvl2pPr>
-    <a:lvl3pPr marL="914400" algn="l" defTabSz="914400" rtl="0" eaLnBrk="1" latinLnBrk="0" hangingPunct="1">
-      <a:defRPr sz="1200" kern="1200">
+    <a:lvl3pPr marL="918881" algn="l" defTabSz="918881" rtl="0" eaLnBrk="1" latinLnBrk="0" hangingPunct="1">
+      <a:defRPr sz="1206" kern="1200">
         <a:solidFill>
           <a:schemeClr val="tx1"/>
         </a:solidFill>
@@ -617,8 +617,8 @@
         <a:cs typeface="+mn-cs"/>
       </a:defRPr>
     </a:lvl3pPr>
-    <a:lvl4pPr marL="1371600" algn="l" defTabSz="914400" rtl="0" eaLnBrk="1" latinLnBrk="0" hangingPunct="1">
-      <a:defRPr sz="1200" kern="1200">
+    <a:lvl4pPr marL="1378321" algn="l" defTabSz="918881" rtl="0" eaLnBrk="1" latinLnBrk="0" hangingPunct="1">
+      <a:defRPr sz="1206" kern="1200">
         <a:solidFill>
           <a:schemeClr val="tx1"/>
         </a:solidFill>
@@ -627,8 +627,8 @@
         <a:cs typeface="+mn-cs"/>
       </a:defRPr>
     </a:lvl4pPr>
-    <a:lvl5pPr marL="1828800" algn="l" defTabSz="914400" rtl="0" eaLnBrk="1" latinLnBrk="0" hangingPunct="1">
-      <a:defRPr sz="1200" kern="1200">
+    <a:lvl5pPr marL="1837761" algn="l" defTabSz="918881" rtl="0" eaLnBrk="1" latinLnBrk="0" hangingPunct="1">
+      <a:defRPr sz="1206" kern="1200">
         <a:solidFill>
           <a:schemeClr val="tx1"/>
         </a:solidFill>
@@ -637,8 +637,8 @@
         <a:cs typeface="+mn-cs"/>
       </a:defRPr>
     </a:lvl5pPr>
-    <a:lvl6pPr marL="2286000" algn="l" defTabSz="914400" rtl="0" eaLnBrk="1" latinLnBrk="0" hangingPunct="1">
-      <a:defRPr sz="1200" kern="1200">
+    <a:lvl6pPr marL="2297201" algn="l" defTabSz="918881" rtl="0" eaLnBrk="1" latinLnBrk="0" hangingPunct="1">
+      <a:defRPr sz="1206" kern="1200">
         <a:solidFill>
           <a:schemeClr val="tx1"/>
         </a:solidFill>
@@ -647,8 +647,8 @@
         <a:cs typeface="+mn-cs"/>
       </a:defRPr>
     </a:lvl6pPr>
-    <a:lvl7pPr marL="2743200" algn="l" defTabSz="914400" rtl="0" eaLnBrk="1" latinLnBrk="0" hangingPunct="1">
-      <a:defRPr sz="1200" kern="1200">
+    <a:lvl7pPr marL="2756642" algn="l" defTabSz="918881" rtl="0" eaLnBrk="1" latinLnBrk="0" hangingPunct="1">
+      <a:defRPr sz="1206" kern="1200">
         <a:solidFill>
           <a:schemeClr val="tx1"/>
         </a:solidFill>
@@ -657,8 +657,8 @@
         <a:cs typeface="+mn-cs"/>
       </a:defRPr>
     </a:lvl7pPr>
-    <a:lvl8pPr marL="3200400" algn="l" defTabSz="914400" rtl="0" eaLnBrk="1" latinLnBrk="0" hangingPunct="1">
-      <a:defRPr sz="1200" kern="1200">
+    <a:lvl8pPr marL="3216082" algn="l" defTabSz="918881" rtl="0" eaLnBrk="1" latinLnBrk="0" hangingPunct="1">
+      <a:defRPr sz="1206" kern="1200">
         <a:solidFill>
           <a:schemeClr val="tx1"/>
         </a:solidFill>
@@ -667,8 +667,8 @@
         <a:cs typeface="+mn-cs"/>
       </a:defRPr>
     </a:lvl8pPr>
-    <a:lvl9pPr marL="3657600" algn="l" defTabSz="914400" rtl="0" eaLnBrk="1" latinLnBrk="0" hangingPunct="1">
-      <a:defRPr sz="1200" kern="1200">
+    <a:lvl9pPr marL="3675522" algn="l" defTabSz="918881" rtl="0" eaLnBrk="1" latinLnBrk="0" hangingPunct="1">
+      <a:defRPr sz="1206" kern="1200">
         <a:solidFill>
           <a:schemeClr val="tx1"/>
         </a:solidFill>
@@ -708,7 +708,12 @@
             <p:ph type="sldImg"/>
           </p:nvPr>
         </p:nvSpPr>
-        <p:spPr/>
+        <p:spPr>
+          <a:xfrm>
+            <a:off x="2338388" y="1143000"/>
+            <a:ext cx="2181225" cy="3086100"/>
+          </a:xfrm>
+        </p:spPr>
         <p:txBody>
           <a:bodyPr/>
           <a:lstStyle/>
@@ -797,8 +802,8 @@
         </p:nvSpPr>
         <p:spPr>
           <a:xfrm>
-            <a:off x="22276160" y="3018472"/>
-            <a:ext cx="5309419" cy="461665"/>
+            <a:off x="22301888" y="3041484"/>
+            <a:ext cx="5315551" cy="465185"/>
           </a:xfrm>
           <a:prstGeom prst="rect">
             <a:avLst/>
@@ -816,7 +821,7 @@
               <a:buNone/>
             </a:pPr>
             <a:r>
-              <a:rPr lang="de-DE" sz="3000" b="1" spc="300" dirty="0">
+              <a:rPr lang="de-DE" sz="3004" b="1" spc="300" dirty="0">
                 <a:solidFill>
                   <a:schemeClr val="accent3">
                     <a:lumMod val="60000"/>
@@ -838,8 +843,8 @@
         </p:nvCxnSpPr>
         <p:spPr>
           <a:xfrm>
-            <a:off x="15061150" y="38738175"/>
-            <a:ext cx="0" cy="3741738"/>
+            <a:off x="15078544" y="39033499"/>
+            <a:ext cx="0" cy="3770264"/>
           </a:xfrm>
           <a:prstGeom prst="line">
             <a:avLst/>
@@ -873,8 +878,8 @@
         </p:nvSpPr>
         <p:spPr>
           <a:xfrm>
-            <a:off x="15444788" y="39457313"/>
-            <a:ext cx="6105525" cy="461665"/>
+            <a:off x="15462626" y="39758120"/>
+            <a:ext cx="6112576" cy="465185"/>
           </a:xfrm>
           <a:prstGeom prst="rect">
             <a:avLst/>
@@ -892,7 +897,7 @@
               <a:buNone/>
             </a:pPr>
             <a:r>
-              <a:rPr lang="de-DE" sz="3000" b="1" cap="all" spc="300" baseline="0" dirty="0">
+              <a:rPr lang="de-DE" sz="3004" b="1" cap="all" spc="300" baseline="0" dirty="0">
                 <a:solidFill>
                   <a:schemeClr val="tx2"/>
                 </a:solidFill>
@@ -915,15 +920,15 @@
         </p:nvSpPr>
         <p:spPr>
           <a:xfrm>
-            <a:off x="15444788" y="40061091"/>
-            <a:ext cx="2160000" cy="1440000"/>
+            <a:off x="15462625" y="40366501"/>
+            <a:ext cx="2162495" cy="1028381"/>
           </a:xfrm>
           <a:noFill/>
         </p:spPr>
         <p:txBody>
           <a:bodyPr/>
           <a:lstStyle>
-            <a:lvl1pPr marL="0" marR="0" indent="0" algn="l" defTabSz="3489669" rtl="0" eaLnBrk="1" fontAlgn="auto" latinLnBrk="0" hangingPunct="1">
+            <a:lvl1pPr marL="0" marR="0" indent="0" algn="l" defTabSz="3493857" rtl="0" eaLnBrk="1" fontAlgn="auto" latinLnBrk="0" hangingPunct="1">
               <a:lnSpc>
                 <a:spcPct val="100000"/>
               </a:lnSpc>
@@ -938,7 +943,7 @@
               <a:buFontTx/>
               <a:buNone/>
               <a:tabLst/>
-              <a:defRPr sz="2000"/>
+              <a:defRPr sz="2002"/>
             </a:lvl1pPr>
             <a:lvl2pPr marL="0" indent="0">
               <a:buFontTx/>
@@ -948,7 +953,7 @@
             <a:lvl4pPr marL="0" indent="0">
               <a:buFontTx/>
               <a:buNone/>
-              <a:defRPr sz="2000">
+              <a:defRPr sz="2002">
                 <a:solidFill>
                   <a:schemeClr val="tx1">
                     <a:lumMod val="75000"/>
@@ -959,7 +964,7 @@
             </a:lvl4pPr>
           </a:lstStyle>
           <a:p>
-            <a:pPr marL="0" marR="0" lvl="0" indent="0" algn="l" defTabSz="3489669" rtl="0" eaLnBrk="1" fontAlgn="auto" latinLnBrk="0" hangingPunct="1">
+            <a:pPr marL="0" marR="0" lvl="0" indent="0" algn="l" defTabSz="3493857" rtl="0" eaLnBrk="1" fontAlgn="auto" latinLnBrk="0" hangingPunct="1">
               <a:lnSpc>
                 <a:spcPct val="100000"/>
               </a:lnSpc>
@@ -977,7 +982,7 @@
               <a:defRPr/>
             </a:pPr>
             <a:r>
-              <a:rPr kumimoji="0" lang="de-DE" sz="2000" b="0" i="0" u="none" strike="noStrike" kern="1200" cap="none" spc="0" normalizeH="0" baseline="0" noProof="0" dirty="0">
+              <a:rPr kumimoji="0" lang="de-DE" sz="2002" b="0" i="0" u="none" strike="noStrike" kern="1200" cap="none" spc="0" normalizeH="0" baseline="0" noProof="0" dirty="0">
                 <a:ln>
                   <a:noFill/>
                 </a:ln>
@@ -1014,15 +1019,15 @@
         </p:nvSpPr>
         <p:spPr>
           <a:xfrm>
-            <a:off x="19033263" y="40061091"/>
-            <a:ext cx="2160000" cy="1440000"/>
+            <a:off x="19055245" y="40366501"/>
+            <a:ext cx="2162495" cy="1028381"/>
           </a:xfrm>
           <a:noFill/>
         </p:spPr>
         <p:txBody>
           <a:bodyPr/>
           <a:lstStyle>
-            <a:lvl1pPr marL="0" marR="0" indent="0" algn="l" defTabSz="3489669" rtl="0" eaLnBrk="1" fontAlgn="auto" latinLnBrk="0" hangingPunct="1">
+            <a:lvl1pPr marL="0" marR="0" indent="0" algn="l" defTabSz="3493857" rtl="0" eaLnBrk="1" fontAlgn="auto" latinLnBrk="0" hangingPunct="1">
               <a:lnSpc>
                 <a:spcPct val="100000"/>
               </a:lnSpc>
@@ -1037,7 +1042,7 @@
               <a:buFontTx/>
               <a:buNone/>
               <a:tabLst/>
-              <a:defRPr sz="2000"/>
+              <a:defRPr sz="2002"/>
             </a:lvl1pPr>
             <a:lvl2pPr marL="0" indent="0">
               <a:buFontTx/>
@@ -1047,7 +1052,7 @@
             <a:lvl4pPr marL="0" indent="0">
               <a:buFontTx/>
               <a:buNone/>
-              <a:defRPr sz="2000">
+              <a:defRPr sz="2002">
                 <a:solidFill>
                   <a:schemeClr val="tx1">
                     <a:lumMod val="75000"/>
@@ -1058,7 +1063,7 @@
             </a:lvl4pPr>
           </a:lstStyle>
           <a:p>
-            <a:pPr marL="0" marR="0" lvl="0" indent="0" algn="l" defTabSz="3489669" rtl="0" eaLnBrk="1" fontAlgn="auto" latinLnBrk="0" hangingPunct="1">
+            <a:pPr marL="0" marR="0" lvl="0" indent="0" algn="l" defTabSz="3493857" rtl="0" eaLnBrk="1" fontAlgn="auto" latinLnBrk="0" hangingPunct="1">
               <a:lnSpc>
                 <a:spcPct val="100000"/>
               </a:lnSpc>
@@ -1076,7 +1081,7 @@
               <a:defRPr/>
             </a:pPr>
             <a:r>
-              <a:rPr kumimoji="0" lang="de-DE" sz="2000" b="0" i="0" u="none" strike="noStrike" kern="1200" cap="none" spc="0" normalizeH="0" baseline="0" noProof="0" dirty="0">
+              <a:rPr kumimoji="0" lang="de-DE" sz="2002" b="0" i="0" u="none" strike="noStrike" kern="1200" cap="none" spc="0" normalizeH="0" baseline="0" noProof="0" dirty="0">
                 <a:ln>
                   <a:noFill/>
                 </a:ln>
@@ -1113,15 +1118,15 @@
         </p:nvSpPr>
         <p:spPr>
           <a:xfrm>
-            <a:off x="22621738" y="40061091"/>
-            <a:ext cx="2160000" cy="1440000"/>
+            <a:off x="22647864" y="40366501"/>
+            <a:ext cx="2162495" cy="1028381"/>
           </a:xfrm>
           <a:noFill/>
         </p:spPr>
         <p:txBody>
           <a:bodyPr/>
           <a:lstStyle>
-            <a:lvl1pPr marL="0" marR="0" indent="0" algn="l" defTabSz="3489669" rtl="0" eaLnBrk="1" fontAlgn="auto" latinLnBrk="0" hangingPunct="1">
+            <a:lvl1pPr marL="0" marR="0" indent="0" algn="l" defTabSz="3493857" rtl="0" eaLnBrk="1" fontAlgn="auto" latinLnBrk="0" hangingPunct="1">
               <a:lnSpc>
                 <a:spcPct val="100000"/>
               </a:lnSpc>
@@ -1136,7 +1141,7 @@
               <a:buFontTx/>
               <a:buNone/>
               <a:tabLst/>
-              <a:defRPr sz="2000"/>
+              <a:defRPr sz="2002"/>
             </a:lvl1pPr>
             <a:lvl2pPr marL="0" indent="0">
               <a:buFontTx/>
@@ -1146,7 +1151,7 @@
             <a:lvl4pPr marL="0" indent="0">
               <a:buFontTx/>
               <a:buNone/>
-              <a:defRPr sz="2000">
+              <a:defRPr sz="2002">
                 <a:solidFill>
                   <a:schemeClr val="tx1">
                     <a:lumMod val="75000"/>
@@ -1157,7 +1162,7 @@
             </a:lvl4pPr>
           </a:lstStyle>
           <a:p>
-            <a:pPr marL="0" marR="0" lvl="0" indent="0" algn="l" defTabSz="3489669" rtl="0" eaLnBrk="1" fontAlgn="auto" latinLnBrk="0" hangingPunct="1">
+            <a:pPr marL="0" marR="0" lvl="0" indent="0" algn="l" defTabSz="3493857" rtl="0" eaLnBrk="1" fontAlgn="auto" latinLnBrk="0" hangingPunct="1">
               <a:lnSpc>
                 <a:spcPct val="100000"/>
               </a:lnSpc>
@@ -1175,7 +1180,7 @@
               <a:defRPr/>
             </a:pPr>
             <a:r>
-              <a:rPr kumimoji="0" lang="de-DE" sz="2000" b="0" i="0" u="none" strike="noStrike" kern="1200" cap="none" spc="0" normalizeH="0" baseline="0" noProof="0" dirty="0">
+              <a:rPr kumimoji="0" lang="de-DE" sz="2002" b="0" i="0" u="none" strike="noStrike" kern="1200" cap="none" spc="0" normalizeH="0" baseline="0" noProof="0" dirty="0">
                 <a:ln>
                   <a:noFill/>
                 </a:ln>
@@ -1212,8 +1217,8 @@
         </p:nvSpPr>
         <p:spPr>
           <a:xfrm>
-            <a:off x="1773003" y="39289704"/>
-            <a:ext cx="2563022" cy="2593294"/>
+            <a:off x="1775051" y="39589233"/>
+            <a:ext cx="2565982" cy="952770"/>
           </a:xfrm>
           <a:prstGeom prst="ellipse">
             <a:avLst/>
@@ -1232,7 +1237,7 @@
         <p:txBody>
           <a:bodyPr/>
           <a:lstStyle>
-            <a:lvl1pPr marL="0" marR="0" indent="0" algn="l" defTabSz="3489669" rtl="0" eaLnBrk="1" fontAlgn="auto" latinLnBrk="0" hangingPunct="1">
+            <a:lvl1pPr marL="0" marR="0" indent="0" algn="l" defTabSz="3493857" rtl="0" eaLnBrk="1" fontAlgn="auto" latinLnBrk="0" hangingPunct="1">
               <a:lnSpc>
                 <a:spcPct val="100000"/>
               </a:lnSpc>
@@ -1252,7 +1257,7 @@
             <a:lvl3pPr marL="0" indent="0">
               <a:buFont typeface="+mj-lt"/>
               <a:buNone/>
-              <a:defRPr sz="1800" baseline="0">
+              <a:defRPr sz="1802" baseline="0">
                 <a:solidFill>
                   <a:schemeClr val="tx1">
                     <a:lumMod val="75000"/>
@@ -1263,7 +1268,7 @@
             </a:lvl3pPr>
           </a:lstStyle>
           <a:p>
-            <a:pPr marL="0" marR="0" lvl="0" indent="0" algn="l" defTabSz="3489669" rtl="0" eaLnBrk="1" fontAlgn="auto" latinLnBrk="0" hangingPunct="1">
+            <a:pPr marL="0" marR="0" lvl="0" indent="0" algn="l" defTabSz="3493857" rtl="0" eaLnBrk="1" fontAlgn="auto" latinLnBrk="0" hangingPunct="1">
               <a:lnSpc>
                 <a:spcPct val="100000"/>
               </a:lnSpc>
@@ -1281,7 +1286,7 @@
               <a:defRPr/>
             </a:pPr>
             <a:r>
-              <a:rPr kumimoji="0" lang="de-DE" sz="2000" b="0" i="0" u="none" strike="noStrike" kern="1200" cap="none" spc="0" normalizeH="0" baseline="0" noProof="0" dirty="0">
+              <a:rPr kumimoji="0" lang="de-DE" sz="2002" b="0" i="0" u="none" strike="noStrike" kern="1200" cap="none" spc="0" normalizeH="0" baseline="0" noProof="0" dirty="0">
                 <a:ln>
                   <a:noFill/>
                 </a:ln>
@@ -1318,8 +1323,8 @@
         </p:nvSpPr>
         <p:spPr>
           <a:xfrm>
-            <a:off x="15464759" y="21873579"/>
-            <a:ext cx="12934950" cy="333425"/>
+            <a:off x="15482619" y="22040335"/>
+            <a:ext cx="12949889" cy="308226"/>
           </a:xfrm>
         </p:spPr>
         <p:txBody>
@@ -1329,14 +1334,14 @@
           <a:lstStyle>
             <a:lvl1pPr marL="0" indent="0">
               <a:lnSpc>
-                <a:spcPts val="2600"/>
+                <a:spcPts val="2603"/>
               </a:lnSpc>
               <a:spcAft>
-                <a:spcPts val="1200"/>
+                <a:spcPts val="1201"/>
               </a:spcAft>
               <a:buFontTx/>
               <a:buNone/>
-              <a:defRPr sz="2000" b="0" cap="none" baseline="0">
+              <a:defRPr sz="2002" b="0" cap="none" baseline="0">
                 <a:solidFill>
                   <a:schemeClr val="tx1">
                     <a:lumMod val="75000"/>
@@ -1348,22 +1353,22 @@
             <a:lvl2pPr marL="0" indent="0">
               <a:buFontTx/>
               <a:buNone/>
-              <a:defRPr sz="2000"/>
+              <a:defRPr sz="2002"/>
             </a:lvl2pPr>
             <a:lvl3pPr>
               <a:buFontTx/>
               <a:buNone/>
-              <a:defRPr sz="2000"/>
+              <a:defRPr sz="2002"/>
             </a:lvl3pPr>
             <a:lvl4pPr>
               <a:buFontTx/>
               <a:buNone/>
-              <a:defRPr sz="2000"/>
+              <a:defRPr sz="2002"/>
             </a:lvl4pPr>
             <a:lvl5pPr>
               <a:buFontTx/>
               <a:buNone/>
-              <a:defRPr sz="2000"/>
+              <a:defRPr sz="2002"/>
             </a:lvl5pPr>
           </a:lstStyle>
           <a:p>
@@ -1387,29 +1392,29 @@
         </p:nvSpPr>
         <p:spPr>
           <a:xfrm>
-            <a:off x="22247998" y="3739548"/>
-            <a:ext cx="6131740" cy="666849"/>
+            <a:off x="22273692" y="3768057"/>
+            <a:ext cx="6138822" cy="641651"/>
           </a:xfrm>
         </p:spPr>
         <p:txBody>
           <a:bodyPr/>
           <a:lstStyle>
-            <a:lvl1pPr marL="457200" marR="0" indent="-457200" algn="l" defTabSz="3489669" rtl="0" eaLnBrk="1" fontAlgn="auto" latinLnBrk="0" hangingPunct="1">
+            <a:lvl1pPr marL="457749" marR="0" indent="-457749" algn="l" defTabSz="3493857" rtl="0" eaLnBrk="1" fontAlgn="auto" latinLnBrk="0" hangingPunct="1">
               <a:lnSpc>
-                <a:spcPts val="2600"/>
+                <a:spcPts val="2603"/>
               </a:lnSpc>
               <a:spcBef>
                 <a:spcPts val="0"/>
               </a:spcBef>
               <a:spcAft>
-                <a:spcPts val="1200"/>
+                <a:spcPts val="1201"/>
               </a:spcAft>
               <a:buClrTx/>
               <a:buSzTx/>
               <a:buFontTx/>
               <a:buNone/>
               <a:tabLst/>
-              <a:defRPr sz="2000" b="0" cap="none" baseline="0">
+              <a:defRPr sz="2002" b="0" cap="none" baseline="0">
                 <a:solidFill>
                   <a:schemeClr val="bg1"/>
                 </a:solidFill>
@@ -1419,34 +1424,34 @@
             <a:lvl2pPr marL="0" indent="0">
               <a:buFontTx/>
               <a:buNone/>
-              <a:defRPr sz="2000"/>
+              <a:defRPr sz="2002"/>
             </a:lvl2pPr>
             <a:lvl3pPr>
               <a:buFontTx/>
               <a:buNone/>
-              <a:defRPr sz="2000"/>
+              <a:defRPr sz="2002"/>
             </a:lvl3pPr>
             <a:lvl4pPr>
               <a:buFontTx/>
               <a:buNone/>
-              <a:defRPr sz="2000"/>
+              <a:defRPr sz="2002"/>
             </a:lvl4pPr>
             <a:lvl5pPr>
               <a:buFontTx/>
               <a:buNone/>
-              <a:defRPr sz="2000"/>
+              <a:defRPr sz="2002"/>
             </a:lvl5pPr>
           </a:lstStyle>
           <a:p>
-            <a:pPr marL="0" marR="0" lvl="0" indent="0" algn="l" defTabSz="3489669" rtl="0" eaLnBrk="1" fontAlgn="auto" latinLnBrk="0" hangingPunct="1">
+            <a:pPr marL="0" marR="0" lvl="0" indent="0" algn="l" defTabSz="3493857" rtl="0" eaLnBrk="1" fontAlgn="auto" latinLnBrk="0" hangingPunct="1">
               <a:lnSpc>
-                <a:spcPts val="2600"/>
+                <a:spcPts val="2603"/>
               </a:lnSpc>
               <a:spcBef>
                 <a:spcPts val="0"/>
               </a:spcBef>
               <a:spcAft>
-                <a:spcPts val="1200"/>
+                <a:spcPts val="1201"/>
               </a:spcAft>
               <a:buClrTx/>
               <a:buSzTx/>
@@ -1456,7 +1461,7 @@
               <a:defRPr/>
             </a:pPr>
             <a:r>
-              <a:rPr kumimoji="0" lang="en-US" sz="2000" b="0" i="0" u="none" strike="noStrike" kern="1200" cap="none" spc="0" normalizeH="0" baseline="0" noProof="0" dirty="0">
+              <a:rPr kumimoji="0" lang="en-US" sz="2002" b="0" i="0" u="none" strike="noStrike" kern="1200" cap="none" spc="0" normalizeH="0" baseline="0" noProof="0" dirty="0">
                 <a:ln>
                   <a:noFill/>
                 </a:ln>
@@ -1473,7 +1478,7 @@
               <a:t>Name Author</a:t>
             </a:r>
             <a:br>
-              <a:rPr kumimoji="0" lang="en-US" sz="2000" b="0" i="0" u="none" strike="noStrike" kern="1200" cap="none" spc="0" normalizeH="0" baseline="0" noProof="0" dirty="0">
+              <a:rPr kumimoji="0" lang="en-US" sz="2002" b="0" i="0" u="none" strike="noStrike" kern="1200" cap="none" spc="0" normalizeH="0" baseline="0" noProof="0" dirty="0">
                 <a:ln>
                   <a:noFill/>
                 </a:ln>
@@ -1489,7 +1494,7 @@
               </a:rPr>
             </a:br>
             <a:r>
-              <a:rPr kumimoji="0" lang="en-US" sz="2000" b="0" i="0" u="none" strike="noStrike" kern="1200" cap="none" spc="0" normalizeH="0" baseline="0" noProof="0" dirty="0">
+              <a:rPr kumimoji="0" lang="en-US" sz="2002" b="0" i="0" u="none" strike="noStrike" kern="1200" cap="none" spc="0" normalizeH="0" baseline="0" noProof="0" dirty="0">
                 <a:ln>
                   <a:noFill/>
                 </a:ln>
@@ -1505,7 +1510,7 @@
               </a:rPr>
               <a:t>and Department</a:t>
             </a:r>
-            <a:endParaRPr kumimoji="0" lang="de-DE" sz="2000" b="0" i="0" u="none" strike="noStrike" kern="1200" cap="none" spc="0" normalizeH="0" baseline="0" noProof="0" dirty="0">
+            <a:endParaRPr kumimoji="0" lang="de-DE" sz="2002" b="0" i="0" u="none" strike="noStrike" kern="1200" cap="none" spc="0" normalizeH="0" baseline="0" noProof="0" dirty="0">
               <a:ln>
                 <a:noFill/>
               </a:ln>
@@ -1534,8 +1539,8 @@
         </p:nvSpPr>
         <p:spPr>
           <a:xfrm>
-            <a:off x="5003999" y="40175391"/>
-            <a:ext cx="9720063" cy="1707608"/>
+            <a:off x="5009779" y="40481672"/>
+            <a:ext cx="9731289" cy="1720626"/>
           </a:xfrm>
         </p:spPr>
         <p:txBody>
@@ -1545,14 +1550,14 @@
           <a:lstStyle>
             <a:lvl1pPr marL="0" indent="0">
               <a:lnSpc>
-                <a:spcPts val="2600"/>
+                <a:spcPts val="2603"/>
               </a:lnSpc>
               <a:spcAft>
-                <a:spcPts val="1200"/>
+                <a:spcPts val="1201"/>
               </a:spcAft>
               <a:buFontTx/>
               <a:buNone/>
-              <a:defRPr sz="2000" b="0" cap="none" baseline="0">
+              <a:defRPr sz="2002" b="0" cap="none" baseline="0">
                 <a:solidFill>
                   <a:schemeClr val="tx1">
                     <a:lumMod val="75000"/>
@@ -1564,7 +1569,7 @@
             <a:lvl2pPr marL="0" indent="0">
               <a:buFontTx/>
               <a:buNone/>
-              <a:defRPr sz="2000">
+              <a:defRPr sz="2002">
                 <a:solidFill>
                   <a:schemeClr val="tx1">
                     <a:lumMod val="75000"/>
@@ -1576,7 +1581,7 @@
             <a:lvl3pPr marL="0" indent="0">
               <a:buFontTx/>
               <a:buNone/>
-              <a:defRPr sz="2000">
+              <a:defRPr sz="2002">
                 <a:solidFill>
                   <a:schemeClr val="tx1">
                     <a:lumMod val="75000"/>
@@ -1588,7 +1593,7 @@
             <a:lvl4pPr marL="0" indent="0">
               <a:buFontTx/>
               <a:buNone/>
-              <a:defRPr sz="2000">
+              <a:defRPr sz="2002">
                 <a:solidFill>
                   <a:schemeClr val="tx1">
                     <a:lumMod val="75000"/>
@@ -1600,7 +1605,7 @@
             <a:lvl5pPr marL="0" indent="0">
               <a:buFontTx/>
               <a:buNone/>
-              <a:defRPr sz="2000">
+              <a:defRPr sz="2002">
                 <a:solidFill>
                   <a:schemeClr val="tx1">
                     <a:lumMod val="75000"/>
@@ -1627,8 +1632,8 @@
         </p:nvSpPr>
         <p:spPr>
           <a:xfrm>
-            <a:off x="5003999" y="39457313"/>
-            <a:ext cx="2139949" cy="461665"/>
+            <a:off x="5009779" y="39758120"/>
+            <a:ext cx="2142420" cy="465185"/>
           </a:xfrm>
           <a:prstGeom prst="rect">
             <a:avLst/>
@@ -1646,7 +1651,7 @@
               <a:buNone/>
             </a:pPr>
             <a:r>
-              <a:rPr lang="de-DE" sz="3000" b="1" cap="all" spc="300" baseline="0" dirty="0">
+              <a:rPr lang="de-DE" sz="3004" b="1" cap="all" spc="300" baseline="0" dirty="0">
                 <a:solidFill>
                   <a:schemeClr val="tx2"/>
                 </a:solidFill>
@@ -1669,8 +1674,8 @@
         </p:nvSpPr>
         <p:spPr>
           <a:xfrm>
-            <a:off x="1870074" y="10726738"/>
-            <a:ext cx="26509663" cy="3030826"/>
+            <a:off x="1872234" y="10808514"/>
+            <a:ext cx="26540279" cy="4045210"/>
           </a:xfrm>
         </p:spPr>
         <p:txBody>
@@ -1725,8 +1730,8 @@
         </p:nvSpPr>
         <p:spPr>
           <a:xfrm>
-            <a:off x="1870075" y="15247347"/>
-            <a:ext cx="12853988" cy="22893913"/>
+            <a:off x="1872235" y="15363587"/>
+            <a:ext cx="12868833" cy="4969630"/>
           </a:xfrm>
         </p:spPr>
         <p:txBody>
@@ -1781,8 +1786,8 @@
         </p:nvSpPr>
         <p:spPr>
           <a:xfrm>
-            <a:off x="15464759" y="15247347"/>
-            <a:ext cx="12934950" cy="6353595"/>
+            <a:off x="15482619" y="15363587"/>
+            <a:ext cx="12949889" cy="4969630"/>
           </a:xfrm>
         </p:spPr>
         <p:txBody>
@@ -1833,8 +1838,8 @@
         </p:nvCxnSpPr>
         <p:spPr>
           <a:xfrm>
-            <a:off x="1077913" y="38738175"/>
-            <a:ext cx="28119387" cy="0"/>
+            <a:off x="1079158" y="39033499"/>
+            <a:ext cx="28151863" cy="0"/>
           </a:xfrm>
           <a:prstGeom prst="line">
             <a:avLst/>
@@ -1872,8 +1877,8 @@
         </p:nvSpPr>
         <p:spPr>
           <a:xfrm>
-            <a:off x="15464759" y="29716957"/>
-            <a:ext cx="12934950" cy="333425"/>
+            <a:off x="15482619" y="29943508"/>
+            <a:ext cx="12949889" cy="308226"/>
           </a:xfrm>
         </p:spPr>
         <p:txBody>
@@ -1883,14 +1888,14 @@
           <a:lstStyle>
             <a:lvl1pPr marL="0" indent="0">
               <a:lnSpc>
-                <a:spcPts val="2600"/>
+                <a:spcPts val="2603"/>
               </a:lnSpc>
               <a:spcAft>
-                <a:spcPts val="1200"/>
+                <a:spcPts val="1201"/>
               </a:spcAft>
               <a:buFontTx/>
               <a:buNone/>
-              <a:defRPr sz="2000" b="0" cap="none" baseline="0">
+              <a:defRPr sz="2002" b="0" cap="none" baseline="0">
                 <a:solidFill>
                   <a:schemeClr val="tx1">
                     <a:lumMod val="75000"/>
@@ -1902,22 +1907,22 @@
             <a:lvl2pPr marL="0" indent="0">
               <a:buFontTx/>
               <a:buNone/>
-              <a:defRPr sz="2000"/>
+              <a:defRPr sz="2002"/>
             </a:lvl2pPr>
             <a:lvl3pPr>
               <a:buFontTx/>
               <a:buNone/>
-              <a:defRPr sz="2000"/>
+              <a:defRPr sz="2002"/>
             </a:lvl3pPr>
             <a:lvl4pPr>
               <a:buFontTx/>
               <a:buNone/>
-              <a:defRPr sz="2000"/>
+              <a:defRPr sz="2002"/>
             </a:lvl4pPr>
             <a:lvl5pPr>
               <a:buFontTx/>
               <a:buNone/>
-              <a:defRPr sz="2000"/>
+              <a:defRPr sz="2002"/>
             </a:lvl5pPr>
           </a:lstStyle>
           <a:p>
@@ -1941,8 +1946,8 @@
         </p:nvSpPr>
         <p:spPr>
           <a:xfrm>
-            <a:off x="15464759" y="23090725"/>
-            <a:ext cx="12934950" cy="6353595"/>
+            <a:off x="15482619" y="23266760"/>
+            <a:ext cx="12949889" cy="4969630"/>
           </a:xfrm>
         </p:spPr>
         <p:txBody>
@@ -1997,8 +2002,8 @@
         </p:nvSpPr>
         <p:spPr>
           <a:xfrm>
-            <a:off x="15464759" y="37932820"/>
-            <a:ext cx="12934950" cy="333425"/>
+            <a:off x="15482619" y="38222005"/>
+            <a:ext cx="12949889" cy="308226"/>
           </a:xfrm>
         </p:spPr>
         <p:txBody>
@@ -2008,14 +2013,14 @@
           <a:lstStyle>
             <a:lvl1pPr marL="0" indent="0">
               <a:lnSpc>
-                <a:spcPts val="2600"/>
+                <a:spcPts val="2603"/>
               </a:lnSpc>
               <a:spcAft>
-                <a:spcPts val="1200"/>
+                <a:spcPts val="1201"/>
               </a:spcAft>
               <a:buFontTx/>
               <a:buNone/>
-              <a:defRPr sz="2000" b="0" cap="none" baseline="0">
+              <a:defRPr sz="2002" b="0" cap="none" baseline="0">
                 <a:solidFill>
                   <a:schemeClr val="tx1">
                     <a:lumMod val="75000"/>
@@ -2027,22 +2032,22 @@
             <a:lvl2pPr marL="0" indent="0">
               <a:buFontTx/>
               <a:buNone/>
-              <a:defRPr sz="2000"/>
+              <a:defRPr sz="2002"/>
             </a:lvl2pPr>
             <a:lvl3pPr>
               <a:buFontTx/>
               <a:buNone/>
-              <a:defRPr sz="2000"/>
+              <a:defRPr sz="2002"/>
             </a:lvl3pPr>
             <a:lvl4pPr>
               <a:buFontTx/>
               <a:buNone/>
-              <a:defRPr sz="2000"/>
+              <a:defRPr sz="2002"/>
             </a:lvl4pPr>
             <a:lvl5pPr>
               <a:buFontTx/>
               <a:buNone/>
-              <a:defRPr sz="2000"/>
+              <a:defRPr sz="2002"/>
             </a:lvl5pPr>
           </a:lstStyle>
           <a:p>
@@ -2066,8 +2071,8 @@
         </p:nvSpPr>
         <p:spPr>
           <a:xfrm>
-            <a:off x="15464759" y="31306588"/>
-            <a:ext cx="12934950" cy="6353595"/>
+            <a:off x="15482619" y="31545258"/>
+            <a:ext cx="12949889" cy="4969630"/>
           </a:xfrm>
         </p:spPr>
         <p:txBody>
@@ -2118,8 +2123,8 @@
         </p:nvSpPr>
         <p:spPr>
           <a:xfrm>
-            <a:off x="1870075" y="2495581"/>
-            <a:ext cx="19680238" cy="2899378"/>
+            <a:off x="1872235" y="2514606"/>
+            <a:ext cx="19702967" cy="2921482"/>
           </a:xfrm>
           <a:prstGeom prst="rect">
             <a:avLst/>
@@ -2156,7 +2161,7 @@
           <a:lstStyle/>
           <a:p>
             <a:pPr algn="ctr"/>
-            <a:endParaRPr lang="de-DE"/>
+            <a:endParaRPr lang="de-DE" sz="6913"/>
           </a:p>
         </p:txBody>
       </p:sp>
@@ -2172,8 +2177,8 @@
         </p:nvSpPr>
         <p:spPr>
           <a:xfrm>
-            <a:off x="1870076" y="2495583"/>
-            <a:ext cx="19680238" cy="2899377"/>
+            <a:off x="1872236" y="2514609"/>
+            <a:ext cx="19702967" cy="2921481"/>
           </a:xfrm>
         </p:spPr>
         <p:txBody>
@@ -2225,8 +2230,8 @@
         </p:nvSpPr>
         <p:spPr>
           <a:xfrm>
-            <a:off x="979200" y="2977366"/>
-            <a:ext cx="20352343" cy="2880000"/>
+            <a:off x="980332" y="3000064"/>
+            <a:ext cx="20375848" cy="2901956"/>
           </a:xfrm>
           <a:prstGeom prst="rect">
             <a:avLst/>
@@ -2263,7 +2268,7 @@
           <a:lstStyle/>
           <a:p>
             <a:pPr algn="ctr"/>
-            <a:endParaRPr lang="de-DE"/>
+            <a:endParaRPr lang="de-DE" sz="6913"/>
           </a:p>
         </p:txBody>
       </p:sp>
@@ -2275,8 +2280,8 @@
         </p:nvSpPr>
         <p:spPr>
           <a:xfrm>
-            <a:off x="22276160" y="3208009"/>
-            <a:ext cx="5309419" cy="461665"/>
+            <a:off x="22301888" y="3232466"/>
+            <a:ext cx="5315551" cy="465185"/>
           </a:xfrm>
           <a:prstGeom prst="rect">
             <a:avLst/>
@@ -2290,7 +2295,7 @@
           <a:lstStyle/>
           <a:p>
             <a:r>
-              <a:rPr lang="de-DE" sz="3000" b="1" spc="300" dirty="0">
+              <a:rPr lang="de-DE" sz="3004" b="1" spc="300" dirty="0">
                 <a:solidFill>
                   <a:schemeClr val="accent3"/>
                 </a:solidFill>
@@ -2313,8 +2318,8 @@
         </p:nvSpPr>
         <p:spPr>
           <a:xfrm>
-            <a:off x="979200" y="2956790"/>
-            <a:ext cx="20352344" cy="2880000"/>
+            <a:off x="980331" y="2979331"/>
+            <a:ext cx="20375849" cy="2901956"/>
           </a:xfrm>
         </p:spPr>
         <p:txBody>
@@ -2340,8 +2345,8 @@
         </p:nvSpPr>
         <p:spPr>
           <a:xfrm>
-            <a:off x="1870075" y="10726739"/>
-            <a:ext cx="12853988" cy="27298704"/>
+            <a:off x="1872235" y="10808516"/>
+            <a:ext cx="12868833" cy="2402645"/>
           </a:xfrm>
         </p:spPr>
         <p:txBody>
@@ -2349,7 +2354,7 @@
           <a:lstStyle>
             <a:lvl4pPr>
               <a:lnSpc>
-                <a:spcPts val="3600"/>
+                <a:spcPts val="3604"/>
               </a:lnSpc>
               <a:defRPr/>
             </a:lvl4pPr>
@@ -2392,8 +2397,8 @@
         </p:nvSpPr>
         <p:spPr>
           <a:xfrm>
-            <a:off x="3348000" y="39886919"/>
-            <a:ext cx="2139949" cy="461665"/>
+            <a:off x="3351867" y="40191001"/>
+            <a:ext cx="2142420" cy="465185"/>
           </a:xfrm>
           <a:prstGeom prst="rect">
             <a:avLst/>
@@ -2411,7 +2416,7 @@
               <a:buNone/>
             </a:pPr>
             <a:r>
-              <a:rPr lang="de-DE" sz="3000" b="1" cap="all" spc="300" baseline="0" dirty="0">
+              <a:rPr lang="de-DE" sz="3004" b="1" cap="all" spc="300" baseline="0" dirty="0">
                 <a:solidFill>
                   <a:schemeClr val="tx2"/>
                 </a:solidFill>
@@ -2432,8 +2437,8 @@
         </p:nvCxnSpPr>
         <p:spPr>
           <a:xfrm>
-            <a:off x="979200" y="39788355"/>
-            <a:ext cx="28767600" cy="0"/>
+            <a:off x="980331" y="40091686"/>
+            <a:ext cx="28800824" cy="0"/>
           </a:xfrm>
           <a:prstGeom prst="line">
             <a:avLst/>
@@ -2471,8 +2476,8 @@
         </p:nvSpPr>
         <p:spPr>
           <a:xfrm>
-            <a:off x="15464759" y="19145286"/>
-            <a:ext cx="12934950" cy="333425"/>
+            <a:off x="15482619" y="19291243"/>
+            <a:ext cx="12949889" cy="308226"/>
           </a:xfrm>
         </p:spPr>
         <p:txBody>
@@ -2482,14 +2487,14 @@
           <a:lstStyle>
             <a:lvl1pPr marL="0" indent="0">
               <a:lnSpc>
-                <a:spcPts val="2600"/>
+                <a:spcPts val="2603"/>
               </a:lnSpc>
               <a:spcAft>
-                <a:spcPts val="1200"/>
+                <a:spcPts val="1201"/>
               </a:spcAft>
               <a:buFontTx/>
               <a:buNone/>
-              <a:defRPr sz="2000" b="0" cap="none" baseline="0">
+              <a:defRPr sz="2002" b="0" cap="none" baseline="0">
                 <a:solidFill>
                   <a:schemeClr val="tx1">
                     <a:lumMod val="75000"/>
@@ -2501,22 +2506,22 @@
             <a:lvl2pPr marL="0" indent="0">
               <a:buFontTx/>
               <a:buNone/>
-              <a:defRPr sz="2000"/>
+              <a:defRPr sz="2002"/>
             </a:lvl2pPr>
             <a:lvl3pPr>
               <a:buFontTx/>
               <a:buNone/>
-              <a:defRPr sz="2000"/>
+              <a:defRPr sz="2002"/>
             </a:lvl3pPr>
             <a:lvl4pPr>
               <a:buFontTx/>
               <a:buNone/>
-              <a:defRPr sz="2000"/>
+              <a:defRPr sz="2002"/>
             </a:lvl4pPr>
             <a:lvl5pPr>
               <a:buFontTx/>
               <a:buNone/>
-              <a:defRPr sz="2000"/>
+              <a:defRPr sz="2002"/>
             </a:lvl5pPr>
           </a:lstStyle>
           <a:p>
@@ -2540,8 +2545,8 @@
         </p:nvSpPr>
         <p:spPr>
           <a:xfrm>
-            <a:off x="15444788" y="10726739"/>
-            <a:ext cx="12934950" cy="8090515"/>
+            <a:off x="15462625" y="10808516"/>
+            <a:ext cx="12949889" cy="4969630"/>
           </a:xfrm>
         </p:spPr>
         <p:txBody>
@@ -2596,8 +2601,8 @@
         </p:nvSpPr>
         <p:spPr>
           <a:xfrm>
-            <a:off x="15484730" y="28488700"/>
-            <a:ext cx="12934950" cy="333425"/>
+            <a:off x="15502613" y="28705887"/>
+            <a:ext cx="12949889" cy="308226"/>
           </a:xfrm>
         </p:spPr>
         <p:txBody>
@@ -2607,14 +2612,14 @@
           <a:lstStyle>
             <a:lvl1pPr marL="0" indent="0">
               <a:lnSpc>
-                <a:spcPts val="2600"/>
+                <a:spcPts val="2603"/>
               </a:lnSpc>
               <a:spcAft>
-                <a:spcPts val="1200"/>
+                <a:spcPts val="1201"/>
               </a:spcAft>
               <a:buFontTx/>
               <a:buNone/>
-              <a:defRPr sz="2000" b="0" cap="none" baseline="0">
+              <a:defRPr sz="2002" b="0" cap="none" baseline="0">
                 <a:solidFill>
                   <a:schemeClr val="tx1">
                     <a:lumMod val="75000"/>
@@ -2626,22 +2631,22 @@
             <a:lvl2pPr marL="0" indent="0">
               <a:buFontTx/>
               <a:buNone/>
-              <a:defRPr sz="2000"/>
+              <a:defRPr sz="2002"/>
             </a:lvl2pPr>
             <a:lvl3pPr>
               <a:buFontTx/>
               <a:buNone/>
-              <a:defRPr sz="2000"/>
+              <a:defRPr sz="2002"/>
             </a:lvl3pPr>
             <a:lvl4pPr>
               <a:buFontTx/>
               <a:buNone/>
-              <a:defRPr sz="2000"/>
+              <a:defRPr sz="2002"/>
             </a:lvl4pPr>
             <a:lvl5pPr>
               <a:buFontTx/>
               <a:buNone/>
-              <a:defRPr sz="2000"/>
+              <a:defRPr sz="2002"/>
             </a:lvl5pPr>
           </a:lstStyle>
           <a:p>
@@ -2665,8 +2670,8 @@
         </p:nvSpPr>
         <p:spPr>
           <a:xfrm>
-            <a:off x="15464759" y="20070153"/>
-            <a:ext cx="12934950" cy="8090515"/>
+            <a:off x="15482619" y="20223160"/>
+            <a:ext cx="12949889" cy="4969630"/>
           </a:xfrm>
         </p:spPr>
         <p:txBody>
@@ -2721,8 +2726,8 @@
         </p:nvSpPr>
         <p:spPr>
           <a:xfrm>
-            <a:off x="15504701" y="37832453"/>
-            <a:ext cx="12934950" cy="333425"/>
+            <a:off x="15522608" y="38120873"/>
+            <a:ext cx="12949889" cy="308226"/>
           </a:xfrm>
         </p:spPr>
         <p:txBody>
@@ -2732,14 +2737,14 @@
           <a:lstStyle>
             <a:lvl1pPr marL="0" indent="0">
               <a:lnSpc>
-                <a:spcPts val="2600"/>
+                <a:spcPts val="2603"/>
               </a:lnSpc>
               <a:spcAft>
-                <a:spcPts val="1200"/>
+                <a:spcPts val="1201"/>
               </a:spcAft>
               <a:buFontTx/>
               <a:buNone/>
-              <a:defRPr sz="2000" b="0" cap="none" baseline="0">
+              <a:defRPr sz="2002" b="0" cap="none" baseline="0">
                 <a:solidFill>
                   <a:schemeClr val="tx1">
                     <a:lumMod val="75000"/>
@@ -2751,22 +2756,22 @@
             <a:lvl2pPr marL="0" indent="0">
               <a:buFontTx/>
               <a:buNone/>
-              <a:defRPr sz="2000"/>
+              <a:defRPr sz="2002"/>
             </a:lvl2pPr>
             <a:lvl3pPr>
               <a:buFontTx/>
               <a:buNone/>
-              <a:defRPr sz="2000"/>
+              <a:defRPr sz="2002"/>
             </a:lvl3pPr>
             <a:lvl4pPr>
               <a:buFontTx/>
               <a:buNone/>
-              <a:defRPr sz="2000"/>
+              <a:defRPr sz="2002"/>
             </a:lvl4pPr>
             <a:lvl5pPr>
               <a:buFontTx/>
               <a:buNone/>
-              <a:defRPr sz="2000"/>
+              <a:defRPr sz="2002"/>
             </a:lvl5pPr>
           </a:lstStyle>
           <a:p>
@@ -2790,8 +2795,8 @@
         </p:nvSpPr>
         <p:spPr>
           <a:xfrm>
-            <a:off x="15484730" y="29413906"/>
-            <a:ext cx="12934950" cy="8090515"/>
+            <a:off x="15502613" y="29638146"/>
+            <a:ext cx="12949889" cy="4969630"/>
           </a:xfrm>
         </p:spPr>
         <p:txBody>
@@ -2846,8 +2851,8 @@
         </p:nvSpPr>
         <p:spPr>
           <a:xfrm>
-            <a:off x="1870075" y="40646451"/>
-            <a:ext cx="9720063" cy="1707608"/>
+            <a:off x="1872235" y="40956323"/>
+            <a:ext cx="9731289" cy="1720626"/>
           </a:xfrm>
         </p:spPr>
         <p:txBody>
@@ -2857,14 +2862,14 @@
           <a:lstStyle>
             <a:lvl1pPr marL="0" indent="0">
               <a:lnSpc>
-                <a:spcPts val="2600"/>
+                <a:spcPts val="2603"/>
               </a:lnSpc>
               <a:spcAft>
-                <a:spcPts val="1200"/>
+                <a:spcPts val="1201"/>
               </a:spcAft>
               <a:buFontTx/>
               <a:buNone/>
-              <a:defRPr sz="2000" b="0" cap="none" baseline="0">
+              <a:defRPr sz="2002" b="0" cap="none" baseline="0">
                 <a:solidFill>
                   <a:schemeClr val="tx1">
                     <a:lumMod val="75000"/>
@@ -2876,7 +2881,7 @@
             <a:lvl2pPr marL="0" indent="0">
               <a:buFontTx/>
               <a:buNone/>
-              <a:defRPr sz="2000">
+              <a:defRPr sz="2002">
                 <a:solidFill>
                   <a:schemeClr val="tx1">
                     <a:lumMod val="75000"/>
@@ -2888,7 +2893,7 @@
             <a:lvl3pPr marL="0" indent="0">
               <a:buFontTx/>
               <a:buNone/>
-              <a:defRPr sz="2000">
+              <a:defRPr sz="2002">
                 <a:solidFill>
                   <a:schemeClr val="tx1">
                     <a:lumMod val="75000"/>
@@ -2900,7 +2905,7 @@
             <a:lvl4pPr marL="0" indent="0">
               <a:buFontTx/>
               <a:buNone/>
-              <a:defRPr sz="2000">
+              <a:defRPr sz="2002">
                 <a:solidFill>
                   <a:schemeClr val="tx1">
                     <a:lumMod val="75000"/>
@@ -2912,7 +2917,7 @@
             <a:lvl5pPr marL="0" indent="0">
               <a:buFontTx/>
               <a:buNone/>
-              <a:defRPr sz="2000">
+              <a:defRPr sz="2002">
                 <a:solidFill>
                   <a:schemeClr val="tx1">
                     <a:lumMod val="75000"/>
@@ -2943,29 +2948,29 @@
         </p:nvSpPr>
         <p:spPr>
           <a:xfrm>
-            <a:off x="22276160" y="3962699"/>
-            <a:ext cx="6131740" cy="666849"/>
+            <a:off x="22301887" y="3992909"/>
+            <a:ext cx="6138822" cy="641651"/>
           </a:xfrm>
         </p:spPr>
         <p:txBody>
           <a:bodyPr/>
           <a:lstStyle>
-            <a:lvl1pPr marL="457200" marR="0" indent="-457200" algn="l" defTabSz="3489669" rtl="0" eaLnBrk="1" fontAlgn="auto" latinLnBrk="0" hangingPunct="1">
+            <a:lvl1pPr marL="457749" marR="0" indent="-457749" algn="l" defTabSz="3493857" rtl="0" eaLnBrk="1" fontAlgn="auto" latinLnBrk="0" hangingPunct="1">
               <a:lnSpc>
-                <a:spcPts val="2600"/>
+                <a:spcPts val="2603"/>
               </a:lnSpc>
               <a:spcBef>
                 <a:spcPts val="0"/>
               </a:spcBef>
               <a:spcAft>
-                <a:spcPts val="1200"/>
+                <a:spcPts val="1201"/>
               </a:spcAft>
               <a:buClrTx/>
               <a:buSzTx/>
               <a:buFontTx/>
               <a:buNone/>
               <a:tabLst/>
-              <a:defRPr sz="2000" b="0" baseline="0">
+              <a:defRPr sz="2002" b="0" baseline="0">
                 <a:solidFill>
                   <a:schemeClr val="bg1"/>
                 </a:solidFill>
@@ -2975,34 +2980,34 @@
             <a:lvl2pPr marL="0" indent="0">
               <a:buFontTx/>
               <a:buNone/>
-              <a:defRPr sz="2000"/>
+              <a:defRPr sz="2002"/>
             </a:lvl2pPr>
             <a:lvl3pPr>
               <a:buFontTx/>
               <a:buNone/>
-              <a:defRPr sz="2000"/>
+              <a:defRPr sz="2002"/>
             </a:lvl3pPr>
             <a:lvl4pPr>
               <a:buFontTx/>
               <a:buNone/>
-              <a:defRPr sz="2000"/>
+              <a:defRPr sz="2002"/>
             </a:lvl4pPr>
             <a:lvl5pPr>
               <a:buFontTx/>
               <a:buNone/>
-              <a:defRPr sz="2000"/>
+              <a:defRPr sz="2002"/>
             </a:lvl5pPr>
           </a:lstStyle>
           <a:p>
-            <a:pPr marL="0" marR="0" lvl="0" indent="0" algn="l" defTabSz="3489669" rtl="0" eaLnBrk="1" fontAlgn="auto" latinLnBrk="0" hangingPunct="1">
+            <a:pPr marL="0" marR="0" lvl="0" indent="0" algn="l" defTabSz="3493857" rtl="0" eaLnBrk="1" fontAlgn="auto" latinLnBrk="0" hangingPunct="1">
               <a:lnSpc>
-                <a:spcPts val="2600"/>
+                <a:spcPts val="2603"/>
               </a:lnSpc>
               <a:spcBef>
                 <a:spcPts val="0"/>
               </a:spcBef>
               <a:spcAft>
-                <a:spcPts val="1200"/>
+                <a:spcPts val="1201"/>
               </a:spcAft>
               <a:buClrTx/>
               <a:buSzTx/>
@@ -3012,7 +3017,7 @@
               <a:defRPr/>
             </a:pPr>
             <a:r>
-              <a:rPr kumimoji="0" lang="en-US" sz="2000" b="0" i="0" u="none" strike="noStrike" kern="1200" cap="none" spc="0" normalizeH="0" baseline="0" noProof="0" dirty="0">
+              <a:rPr kumimoji="0" lang="en-US" sz="2002" b="0" i="0" u="none" strike="noStrike" kern="1200" cap="none" spc="0" normalizeH="0" baseline="0" noProof="0" dirty="0">
                 <a:ln>
                   <a:noFill/>
                 </a:ln>
@@ -3029,7 +3034,7 @@
               <a:t>Name Author</a:t>
             </a:r>
             <a:br>
-              <a:rPr kumimoji="0" lang="en-US" sz="2000" b="0" i="0" u="none" strike="noStrike" kern="1200" cap="none" spc="0" normalizeH="0" baseline="0" noProof="0" dirty="0">
+              <a:rPr kumimoji="0" lang="en-US" sz="2002" b="0" i="0" u="none" strike="noStrike" kern="1200" cap="none" spc="0" normalizeH="0" baseline="0" noProof="0" dirty="0">
                 <a:ln>
                   <a:noFill/>
                 </a:ln>
@@ -3045,7 +3050,7 @@
               </a:rPr>
             </a:br>
             <a:r>
-              <a:rPr kumimoji="0" lang="en-US" sz="2000" b="0" i="0" u="none" strike="noStrike" kern="1200" cap="none" spc="0" normalizeH="0" baseline="0" noProof="0" dirty="0">
+              <a:rPr kumimoji="0" lang="en-US" sz="2002" b="0" i="0" u="none" strike="noStrike" kern="1200" cap="none" spc="0" normalizeH="0" baseline="0" noProof="0" dirty="0">
                 <a:ln>
                   <a:noFill/>
                 </a:ln>
@@ -3061,7 +3066,7 @@
               </a:rPr>
               <a:t>and Department</a:t>
             </a:r>
-            <a:endParaRPr kumimoji="0" lang="de-DE" sz="2000" b="0" i="0" u="none" strike="noStrike" kern="1200" cap="none" spc="0" normalizeH="0" baseline="0" noProof="0" dirty="0">
+            <a:endParaRPr kumimoji="0" lang="de-DE" sz="2002" b="0" i="0" u="none" strike="noStrike" kern="1200" cap="none" spc="0" normalizeH="0" baseline="0" noProof="0" dirty="0">
               <a:ln>
                 <a:noFill/>
               </a:ln>
@@ -3092,8 +3097,8 @@
         </p:nvSpPr>
         <p:spPr>
           <a:xfrm>
-            <a:off x="8524800" y="39886919"/>
-            <a:ext cx="4017403" cy="461665"/>
+            <a:off x="8534646" y="40191001"/>
+            <a:ext cx="4022043" cy="465185"/>
           </a:xfrm>
           <a:prstGeom prst="rect">
             <a:avLst/>
@@ -3111,7 +3116,7 @@
               <a:buNone/>
             </a:pPr>
             <a:r>
-              <a:rPr lang="de-DE" sz="3000" b="1" cap="all" spc="300" baseline="0" dirty="0">
+              <a:rPr lang="de-DE" sz="3004" b="1" cap="all" spc="300" baseline="0" dirty="0">
                 <a:solidFill>
                   <a:schemeClr val="tx2"/>
                 </a:solidFill>
@@ -3140,8 +3145,8 @@
         </p:nvSpPr>
         <p:spPr>
           <a:xfrm>
-            <a:off x="12556097" y="40646451"/>
-            <a:ext cx="15883554" cy="1707608"/>
+            <a:off x="12570598" y="40956323"/>
+            <a:ext cx="15901898" cy="1720626"/>
           </a:xfrm>
         </p:spPr>
         <p:txBody>
@@ -3151,14 +3156,14 @@
           <a:lstStyle>
             <a:lvl1pPr marL="0" indent="0">
               <a:lnSpc>
-                <a:spcPts val="2600"/>
+                <a:spcPts val="2603"/>
               </a:lnSpc>
               <a:spcAft>
-                <a:spcPts val="1200"/>
+                <a:spcPts val="1201"/>
               </a:spcAft>
               <a:buFontTx/>
               <a:buNone/>
-              <a:defRPr sz="2000" b="0" cap="none" baseline="0">
+              <a:defRPr sz="2002" b="0" cap="none" baseline="0">
                 <a:solidFill>
                   <a:schemeClr val="tx1">
                     <a:lumMod val="75000"/>
@@ -3170,7 +3175,7 @@
             <a:lvl2pPr marL="0" indent="0">
               <a:buFontTx/>
               <a:buNone/>
-              <a:defRPr sz="2000">
+              <a:defRPr sz="2002">
                 <a:solidFill>
                   <a:schemeClr val="tx1">
                     <a:lumMod val="75000"/>
@@ -3182,7 +3187,7 @@
             <a:lvl3pPr marL="0" indent="0">
               <a:buFontTx/>
               <a:buNone/>
-              <a:defRPr sz="2000">
+              <a:defRPr sz="2002">
                 <a:solidFill>
                   <a:schemeClr val="tx1">
                     <a:lumMod val="75000"/>
@@ -3194,7 +3199,7 @@
             <a:lvl4pPr marL="0" indent="0">
               <a:buFontTx/>
               <a:buNone/>
-              <a:defRPr sz="2000">
+              <a:defRPr sz="2002">
                 <a:solidFill>
                   <a:schemeClr val="tx1">
                     <a:lumMod val="75000"/>
@@ -3206,7 +3211,7 @@
             <a:lvl5pPr marL="0" indent="0">
               <a:buFontTx/>
               <a:buNone/>
-              <a:defRPr sz="2000">
+              <a:defRPr sz="2002">
                 <a:solidFill>
                   <a:schemeClr val="tx1">
                     <a:lumMod val="75000"/>
@@ -3263,8 +3268,8 @@
         </p:nvCxnSpPr>
         <p:spPr>
           <a:xfrm>
-            <a:off x="22248813" y="4229100"/>
-            <a:ext cx="0" cy="3829050"/>
+            <a:off x="22274509" y="4261341"/>
+            <a:ext cx="0" cy="3858241"/>
           </a:xfrm>
           <a:prstGeom prst="line">
             <a:avLst/>
@@ -3301,8 +3306,8 @@
         </p:nvCxnSpPr>
         <p:spPr>
           <a:xfrm>
-            <a:off x="15120122" y="38738175"/>
-            <a:ext cx="0" cy="3741738"/>
+            <a:off x="15137584" y="39033499"/>
+            <a:ext cx="0" cy="3770264"/>
           </a:xfrm>
           <a:prstGeom prst="line">
             <a:avLst/>
@@ -3336,8 +3341,8 @@
         </p:nvCxnSpPr>
         <p:spPr>
           <a:xfrm>
-            <a:off x="15120122" y="38738175"/>
-            <a:ext cx="0" cy="3741738"/>
+            <a:off x="15137584" y="39033499"/>
+            <a:ext cx="0" cy="3770264"/>
           </a:xfrm>
           <a:prstGeom prst="line">
             <a:avLst/>
@@ -3375,8 +3380,8 @@
         </p:nvSpPr>
         <p:spPr>
           <a:xfrm>
-            <a:off x="1870074" y="9495365"/>
-            <a:ext cx="26509663" cy="3098421"/>
+            <a:off x="1872234" y="9567754"/>
+            <a:ext cx="26540279" cy="4045210"/>
           </a:xfrm>
         </p:spPr>
         <p:txBody>
@@ -3431,8 +3436,8 @@
         </p:nvSpPr>
         <p:spPr>
           <a:xfrm>
-            <a:off x="1870075" y="14083569"/>
-            <a:ext cx="12853988" cy="22893913"/>
+            <a:off x="1872235" y="14190937"/>
+            <a:ext cx="12868833" cy="4969630"/>
           </a:xfrm>
         </p:spPr>
         <p:txBody>
@@ -3483,8 +3488,8 @@
         </p:nvSpPr>
         <p:spPr>
           <a:xfrm>
-            <a:off x="23024312" y="4498924"/>
-            <a:ext cx="5309419" cy="461665"/>
+            <a:off x="23050904" y="4533222"/>
+            <a:ext cx="5315551" cy="465185"/>
           </a:xfrm>
           <a:prstGeom prst="rect">
             <a:avLst/>
@@ -3502,7 +3507,7 @@
               <a:buNone/>
             </a:pPr>
             <a:r>
-              <a:rPr lang="de-DE" sz="3000" b="1" spc="300" dirty="0">
+              <a:rPr lang="de-DE" sz="3004" b="1" spc="300" dirty="0">
                 <a:solidFill>
                   <a:schemeClr val="accent3">
                     <a:lumMod val="60000"/>
@@ -3528,29 +3533,29 @@
         </p:nvSpPr>
         <p:spPr>
           <a:xfrm>
-            <a:off x="22996150" y="5220000"/>
-            <a:ext cx="6131740" cy="666849"/>
+            <a:off x="23022708" y="5259796"/>
+            <a:ext cx="6138822" cy="641651"/>
           </a:xfrm>
         </p:spPr>
         <p:txBody>
           <a:bodyPr/>
           <a:lstStyle>
-            <a:lvl1pPr marL="457200" marR="0" indent="-457200" algn="l" defTabSz="3489669" rtl="0" eaLnBrk="1" fontAlgn="auto" latinLnBrk="0" hangingPunct="1">
+            <a:lvl1pPr marL="457749" marR="0" indent="-457749" algn="l" defTabSz="3493857" rtl="0" eaLnBrk="1" fontAlgn="auto" latinLnBrk="0" hangingPunct="1">
               <a:lnSpc>
-                <a:spcPts val="2600"/>
+                <a:spcPts val="2603"/>
               </a:lnSpc>
               <a:spcBef>
                 <a:spcPts val="0"/>
               </a:spcBef>
               <a:spcAft>
-                <a:spcPts val="1200"/>
+                <a:spcPts val="1201"/>
               </a:spcAft>
               <a:buClrTx/>
               <a:buSzTx/>
               <a:buFontTx/>
               <a:buNone/>
               <a:tabLst/>
-              <a:defRPr sz="2000" b="0" baseline="0">
+              <a:defRPr sz="2002" b="0" baseline="0">
                 <a:solidFill>
                   <a:schemeClr val="bg1"/>
                 </a:solidFill>
@@ -3560,34 +3565,34 @@
             <a:lvl2pPr marL="0" indent="0">
               <a:buFontTx/>
               <a:buNone/>
-              <a:defRPr sz="2000"/>
+              <a:defRPr sz="2002"/>
             </a:lvl2pPr>
             <a:lvl3pPr>
               <a:buFontTx/>
               <a:buNone/>
-              <a:defRPr sz="2000"/>
+              <a:defRPr sz="2002"/>
             </a:lvl3pPr>
             <a:lvl4pPr>
               <a:buFontTx/>
               <a:buNone/>
-              <a:defRPr sz="2000"/>
+              <a:defRPr sz="2002"/>
             </a:lvl4pPr>
             <a:lvl5pPr>
               <a:buFontTx/>
               <a:buNone/>
-              <a:defRPr sz="2000"/>
+              <a:defRPr sz="2002"/>
             </a:lvl5pPr>
           </a:lstStyle>
           <a:p>
-            <a:pPr marL="0" marR="0" lvl="0" indent="0" algn="l" defTabSz="3489669" rtl="0" eaLnBrk="1" fontAlgn="auto" latinLnBrk="0" hangingPunct="1">
+            <a:pPr marL="0" marR="0" lvl="0" indent="0" algn="l" defTabSz="3493857" rtl="0" eaLnBrk="1" fontAlgn="auto" latinLnBrk="0" hangingPunct="1">
               <a:lnSpc>
-                <a:spcPts val="2600"/>
+                <a:spcPts val="2603"/>
               </a:lnSpc>
               <a:spcBef>
                 <a:spcPts val="0"/>
               </a:spcBef>
               <a:spcAft>
-                <a:spcPts val="1200"/>
+                <a:spcPts val="1201"/>
               </a:spcAft>
               <a:buClrTx/>
               <a:buSzTx/>
@@ -3597,7 +3602,7 @@
               <a:defRPr/>
             </a:pPr>
             <a:r>
-              <a:rPr kumimoji="0" lang="en-US" sz="2000" b="0" i="0" u="none" strike="noStrike" kern="1200" cap="none" spc="0" normalizeH="0" baseline="0" noProof="0" dirty="0">
+              <a:rPr kumimoji="0" lang="en-US" sz="2002" b="0" i="0" u="none" strike="noStrike" kern="1200" cap="none" spc="0" normalizeH="0" baseline="0" noProof="0" dirty="0">
                 <a:ln>
                   <a:noFill/>
                 </a:ln>
@@ -3614,7 +3619,7 @@
               <a:t>Name Author</a:t>
             </a:r>
             <a:br>
-              <a:rPr kumimoji="0" lang="en-US" sz="2000" b="0" i="0" u="none" strike="noStrike" kern="1200" cap="none" spc="0" normalizeH="0" baseline="0" noProof="0" dirty="0">
+              <a:rPr kumimoji="0" lang="en-US" sz="2002" b="0" i="0" u="none" strike="noStrike" kern="1200" cap="none" spc="0" normalizeH="0" baseline="0" noProof="0" dirty="0">
                 <a:ln>
                   <a:noFill/>
                 </a:ln>
@@ -3630,7 +3635,7 @@
               </a:rPr>
             </a:br>
             <a:r>
-              <a:rPr kumimoji="0" lang="en-US" sz="2000" b="0" i="0" u="none" strike="noStrike" kern="1200" cap="none" spc="0" normalizeH="0" baseline="0" noProof="0" dirty="0">
+              <a:rPr kumimoji="0" lang="en-US" sz="2002" b="0" i="0" u="none" strike="noStrike" kern="1200" cap="none" spc="0" normalizeH="0" baseline="0" noProof="0" dirty="0">
                 <a:ln>
                   <a:noFill/>
                 </a:ln>
@@ -3646,7 +3651,7 @@
               </a:rPr>
               <a:t>and Department</a:t>
             </a:r>
-            <a:endParaRPr kumimoji="0" lang="de-DE" sz="2000" b="0" i="0" u="none" strike="noStrike" kern="1200" cap="none" spc="0" normalizeH="0" baseline="0" noProof="0" dirty="0">
+            <a:endParaRPr kumimoji="0" lang="de-DE" sz="2002" b="0" i="0" u="none" strike="noStrike" kern="1200" cap="none" spc="0" normalizeH="0" baseline="0" noProof="0" dirty="0">
               <a:ln>
                 <a:noFill/>
               </a:ln>
@@ -3675,8 +3680,8 @@
         </p:nvSpPr>
         <p:spPr>
           <a:xfrm>
-            <a:off x="26028128" y="1257300"/>
-            <a:ext cx="3165701" cy="1068388"/>
+            <a:off x="26058189" y="1055043"/>
+            <a:ext cx="3169357" cy="1500220"/>
           </a:xfrm>
           <a:solidFill>
             <a:schemeClr val="bg1"/>
@@ -3685,7 +3690,7 @@
         <p:txBody>
           <a:bodyPr anchor="ctr" anchorCtr="0"/>
           <a:lstStyle>
-            <a:lvl1pPr marL="0" marR="0" indent="0" algn="ctr" defTabSz="2267986" rtl="0" eaLnBrk="1" fontAlgn="auto" latinLnBrk="0" hangingPunct="1">
+            <a:lvl1pPr marL="0" marR="0" indent="0" algn="ctr" defTabSz="2270708" rtl="0" eaLnBrk="1" fontAlgn="auto" latinLnBrk="0" hangingPunct="1">
               <a:lnSpc>
                 <a:spcPct val="100000"/>
               </a:lnSpc>
@@ -3693,14 +3698,14 @@
                 <a:spcPts val="0"/>
               </a:spcBef>
               <a:spcAft>
-                <a:spcPts val="2000"/>
+                <a:spcPts val="2002"/>
               </a:spcAft>
               <a:buClrTx/>
               <a:buSzTx/>
               <a:buFontTx/>
               <a:buNone/>
               <a:tabLst/>
-              <a:defRPr sz="2000" b="0">
+              <a:defRPr sz="2002" b="0">
                 <a:solidFill>
                   <a:schemeClr val="tx1">
                     <a:lumMod val="75000"/>
@@ -3711,7 +3716,7 @@
             </a:lvl1pPr>
           </a:lstStyle>
           <a:p>
-            <a:pPr marL="0" marR="0" lvl="0" indent="0" algn="l" defTabSz="2267986" rtl="0" eaLnBrk="1" fontAlgn="auto" latinLnBrk="0" hangingPunct="1">
+            <a:pPr marL="0" marR="0" lvl="0" indent="0" algn="l" defTabSz="2270708" rtl="0" eaLnBrk="1" fontAlgn="auto" latinLnBrk="0" hangingPunct="1">
               <a:lnSpc>
                 <a:spcPct val="100000"/>
               </a:lnSpc>
@@ -3719,7 +3724,7 @@
                 <a:spcPts val="0"/>
               </a:spcBef>
               <a:spcAft>
-                <a:spcPts val="2000"/>
+                <a:spcPts val="2002"/>
               </a:spcAft>
               <a:buClrTx/>
               <a:buSzTx/>
@@ -3729,7 +3734,7 @@
               <a:defRPr/>
             </a:pPr>
             <a:r>
-              <a:rPr lang="de-DE" sz="2000" dirty="0">
+              <a:rPr lang="de-DE" sz="2002" dirty="0">
                 <a:solidFill>
                   <a:schemeClr val="tx1">
                     <a:lumMod val="75000"/>
@@ -3756,8 +3761,8 @@
         </p:nvSpPr>
         <p:spPr>
           <a:xfrm>
-            <a:off x="15464759" y="20322258"/>
-            <a:ext cx="12934950" cy="333425"/>
+            <a:off x="15482619" y="20477187"/>
+            <a:ext cx="12949889" cy="308226"/>
           </a:xfrm>
         </p:spPr>
         <p:txBody>
@@ -3767,14 +3772,14 @@
           <a:lstStyle>
             <a:lvl1pPr marL="0" indent="0">
               <a:lnSpc>
-                <a:spcPts val="2600"/>
+                <a:spcPts val="2603"/>
               </a:lnSpc>
               <a:spcAft>
-                <a:spcPts val="1200"/>
+                <a:spcPts val="1201"/>
               </a:spcAft>
               <a:buFontTx/>
               <a:buNone/>
-              <a:defRPr sz="2000" b="0" cap="none" baseline="0">
+              <a:defRPr sz="2002" b="0" cap="none" baseline="0">
                 <a:solidFill>
                   <a:schemeClr val="tx1">
                     <a:lumMod val="75000"/>
@@ -3786,22 +3791,22 @@
             <a:lvl2pPr marL="0" indent="0">
               <a:buFontTx/>
               <a:buNone/>
-              <a:defRPr sz="2000"/>
+              <a:defRPr sz="2002"/>
             </a:lvl2pPr>
             <a:lvl3pPr>
               <a:buFontTx/>
               <a:buNone/>
-              <a:defRPr sz="2000"/>
+              <a:defRPr sz="2002"/>
             </a:lvl3pPr>
             <a:lvl4pPr>
               <a:buFontTx/>
               <a:buNone/>
-              <a:defRPr sz="2000"/>
+              <a:defRPr sz="2002"/>
             </a:lvl4pPr>
             <a:lvl5pPr>
               <a:buFontTx/>
               <a:buNone/>
-              <a:defRPr sz="2000"/>
+              <a:defRPr sz="2002"/>
             </a:lvl5pPr>
           </a:lstStyle>
           <a:p>
@@ -3825,8 +3830,8 @@
         </p:nvSpPr>
         <p:spPr>
           <a:xfrm>
-            <a:off x="15444788" y="14061953"/>
-            <a:ext cx="12934950" cy="5774128"/>
+            <a:off x="15462625" y="14169156"/>
+            <a:ext cx="12949889" cy="4969630"/>
           </a:xfrm>
         </p:spPr>
         <p:txBody>
@@ -3881,8 +3886,8 @@
         </p:nvSpPr>
         <p:spPr>
           <a:xfrm>
-            <a:off x="15484730" y="28376739"/>
-            <a:ext cx="12934950" cy="333425"/>
+            <a:off x="15502613" y="28593072"/>
+            <a:ext cx="12949889" cy="308226"/>
           </a:xfrm>
         </p:spPr>
         <p:txBody>
@@ -3892,14 +3897,14 @@
           <a:lstStyle>
             <a:lvl1pPr marL="0" indent="0">
               <a:lnSpc>
-                <a:spcPts val="2600"/>
+                <a:spcPts val="2603"/>
               </a:lnSpc>
               <a:spcAft>
-                <a:spcPts val="1200"/>
+                <a:spcPts val="1201"/>
               </a:spcAft>
               <a:buFontTx/>
               <a:buNone/>
-              <a:defRPr sz="2000" b="0" cap="none" baseline="0">
+              <a:defRPr sz="2002" b="0" cap="none" baseline="0">
                 <a:solidFill>
                   <a:schemeClr val="tx1">
                     <a:lumMod val="75000"/>
@@ -3911,22 +3916,22 @@
             <a:lvl2pPr marL="0" indent="0">
               <a:buFontTx/>
               <a:buNone/>
-              <a:defRPr sz="2000"/>
+              <a:defRPr sz="2002"/>
             </a:lvl2pPr>
             <a:lvl3pPr>
               <a:buFontTx/>
               <a:buNone/>
-              <a:defRPr sz="2000"/>
+              <a:defRPr sz="2002"/>
             </a:lvl3pPr>
             <a:lvl4pPr>
               <a:buFontTx/>
               <a:buNone/>
-              <a:defRPr sz="2000"/>
+              <a:defRPr sz="2002"/>
             </a:lvl4pPr>
             <a:lvl5pPr>
               <a:buFontTx/>
               <a:buNone/>
-              <a:defRPr sz="2000"/>
+              <a:defRPr sz="2002"/>
             </a:lvl5pPr>
           </a:lstStyle>
           <a:p>
@@ -3950,8 +3955,8 @@
         </p:nvSpPr>
         <p:spPr>
           <a:xfrm>
-            <a:off x="15464759" y="22116434"/>
-            <a:ext cx="12934950" cy="5774128"/>
+            <a:off x="15482619" y="22285041"/>
+            <a:ext cx="12949889" cy="4969630"/>
           </a:xfrm>
         </p:spPr>
         <p:txBody>
@@ -4006,8 +4011,8 @@
         </p:nvSpPr>
         <p:spPr>
           <a:xfrm>
-            <a:off x="15524672" y="36498473"/>
-            <a:ext cx="12934950" cy="333425"/>
+            <a:off x="15542602" y="36776723"/>
+            <a:ext cx="12949889" cy="308226"/>
           </a:xfrm>
         </p:spPr>
         <p:txBody>
@@ -4017,14 +4022,14 @@
           <a:lstStyle>
             <a:lvl1pPr marL="0" indent="0">
               <a:lnSpc>
-                <a:spcPts val="2600"/>
+                <a:spcPts val="2603"/>
               </a:lnSpc>
               <a:spcAft>
-                <a:spcPts val="1200"/>
+                <a:spcPts val="1201"/>
               </a:spcAft>
               <a:buFontTx/>
               <a:buNone/>
-              <a:defRPr sz="2000" b="0" cap="none" baseline="0">
+              <a:defRPr sz="2002" b="0" cap="none" baseline="0">
                 <a:solidFill>
                   <a:schemeClr val="tx1">
                     <a:lumMod val="75000"/>
@@ -4036,22 +4041,22 @@
             <a:lvl2pPr marL="0" indent="0">
               <a:buFontTx/>
               <a:buNone/>
-              <a:defRPr sz="2000"/>
+              <a:defRPr sz="2002"/>
             </a:lvl2pPr>
             <a:lvl3pPr>
               <a:buFontTx/>
               <a:buNone/>
-              <a:defRPr sz="2000"/>
+              <a:defRPr sz="2002"/>
             </a:lvl3pPr>
             <a:lvl4pPr>
               <a:buFontTx/>
               <a:buNone/>
-              <a:defRPr sz="2000"/>
+              <a:defRPr sz="2002"/>
             </a:lvl4pPr>
             <a:lvl5pPr>
               <a:buFontTx/>
               <a:buNone/>
-              <a:defRPr sz="2000"/>
+              <a:defRPr sz="2002"/>
             </a:lvl5pPr>
           </a:lstStyle>
           <a:p>
@@ -4075,8 +4080,8 @@
         </p:nvSpPr>
         <p:spPr>
           <a:xfrm>
-            <a:off x="15504701" y="30238168"/>
-            <a:ext cx="12934950" cy="5774128"/>
+            <a:off x="15522608" y="30468692"/>
+            <a:ext cx="12949889" cy="4969630"/>
           </a:xfrm>
         </p:spPr>
         <p:txBody>
@@ -4131,8 +4136,8 @@
         </p:nvSpPr>
         <p:spPr>
           <a:xfrm>
-            <a:off x="15433512" y="39289704"/>
-            <a:ext cx="2563022" cy="2593294"/>
+            <a:off x="15451336" y="39589233"/>
+            <a:ext cx="2565982" cy="952770"/>
           </a:xfrm>
           <a:prstGeom prst="ellipse">
             <a:avLst/>
@@ -4151,7 +4156,7 @@
         <p:txBody>
           <a:bodyPr/>
           <a:lstStyle>
-            <a:lvl1pPr marL="0" marR="0" indent="0" algn="l" defTabSz="3489669" rtl="0" eaLnBrk="1" fontAlgn="auto" latinLnBrk="0" hangingPunct="1">
+            <a:lvl1pPr marL="0" marR="0" indent="0" algn="l" defTabSz="3493857" rtl="0" eaLnBrk="1" fontAlgn="auto" latinLnBrk="0" hangingPunct="1">
               <a:lnSpc>
                 <a:spcPct val="100000"/>
               </a:lnSpc>
@@ -4171,7 +4176,7 @@
             <a:lvl3pPr marL="0" indent="0">
               <a:buFont typeface="+mj-lt"/>
               <a:buNone/>
-              <a:defRPr sz="1800" baseline="0">
+              <a:defRPr sz="1802" baseline="0">
                 <a:solidFill>
                   <a:schemeClr val="tx1">
                     <a:lumMod val="75000"/>
@@ -4182,7 +4187,7 @@
             </a:lvl3pPr>
           </a:lstStyle>
           <a:p>
-            <a:pPr marL="0" marR="0" lvl="0" indent="0" algn="l" defTabSz="3489669" rtl="0" eaLnBrk="1" fontAlgn="auto" latinLnBrk="0" hangingPunct="1">
+            <a:pPr marL="0" marR="0" lvl="0" indent="0" algn="l" defTabSz="3493857" rtl="0" eaLnBrk="1" fontAlgn="auto" latinLnBrk="0" hangingPunct="1">
               <a:lnSpc>
                 <a:spcPct val="100000"/>
               </a:lnSpc>
@@ -4200,7 +4205,7 @@
               <a:defRPr/>
             </a:pPr>
             <a:r>
-              <a:rPr kumimoji="0" lang="de-DE" sz="2000" b="0" i="0" u="none" strike="noStrike" kern="1200" cap="none" spc="0" normalizeH="0" baseline="0" noProof="0" dirty="0">
+              <a:rPr kumimoji="0" lang="de-DE" sz="2002" b="0" i="0" u="none" strike="noStrike" kern="1200" cap="none" spc="0" normalizeH="0" baseline="0" noProof="0" dirty="0">
                 <a:ln>
                   <a:noFill/>
                 </a:ln>
@@ -4233,8 +4238,8 @@
         </p:nvSpPr>
         <p:spPr>
           <a:xfrm>
-            <a:off x="18664508" y="39457313"/>
-            <a:ext cx="2139949" cy="461665"/>
+            <a:off x="18686065" y="39758120"/>
+            <a:ext cx="2142420" cy="465185"/>
           </a:xfrm>
           <a:prstGeom prst="rect">
             <a:avLst/>
@@ -4252,7 +4257,7 @@
               <a:buNone/>
             </a:pPr>
             <a:r>
-              <a:rPr lang="de-DE" sz="3000" b="1" cap="all" spc="300" baseline="0" dirty="0">
+              <a:rPr lang="de-DE" sz="3004" b="1" cap="all" spc="300" baseline="0" dirty="0">
                 <a:solidFill>
                   <a:schemeClr val="tx2"/>
                 </a:solidFill>
@@ -4275,8 +4280,8 @@
         </p:nvSpPr>
         <p:spPr>
           <a:xfrm>
-            <a:off x="18664508" y="40175390"/>
-            <a:ext cx="9720063" cy="1707608"/>
+            <a:off x="18686064" y="40481671"/>
+            <a:ext cx="9731289" cy="1720626"/>
           </a:xfrm>
         </p:spPr>
         <p:txBody>
@@ -4286,14 +4291,14 @@
           <a:lstStyle>
             <a:lvl1pPr marL="0" indent="0">
               <a:lnSpc>
-                <a:spcPts val="2600"/>
+                <a:spcPts val="2603"/>
               </a:lnSpc>
               <a:spcAft>
-                <a:spcPts val="1200"/>
+                <a:spcPts val="1201"/>
               </a:spcAft>
               <a:buFontTx/>
               <a:buNone/>
-              <a:defRPr sz="2000" b="0" cap="none" baseline="0">
+              <a:defRPr sz="2002" b="0" cap="none" baseline="0">
                 <a:solidFill>
                   <a:schemeClr val="tx1">
                     <a:lumMod val="75000"/>
@@ -4305,7 +4310,7 @@
             <a:lvl2pPr marL="0" indent="0">
               <a:buFontTx/>
               <a:buNone/>
-              <a:defRPr sz="2000">
+              <a:defRPr sz="2002">
                 <a:solidFill>
                   <a:schemeClr val="tx1">
                     <a:lumMod val="75000"/>
@@ -4317,7 +4322,7 @@
             <a:lvl3pPr marL="0" indent="0">
               <a:buFontTx/>
               <a:buNone/>
-              <a:defRPr sz="2000">
+              <a:defRPr sz="2002">
                 <a:solidFill>
                   <a:schemeClr val="tx1">
                     <a:lumMod val="75000"/>
@@ -4329,7 +4334,7 @@
             <a:lvl4pPr marL="0" indent="0">
               <a:buFontTx/>
               <a:buNone/>
-              <a:defRPr sz="2000">
+              <a:defRPr sz="2002">
                 <a:solidFill>
                   <a:schemeClr val="tx1">
                     <a:lumMod val="75000"/>
@@ -4341,7 +4346,7 @@
             <a:lvl5pPr marL="0" indent="0">
               <a:buFontTx/>
               <a:buNone/>
-              <a:defRPr sz="2000">
+              <a:defRPr sz="2002">
                 <a:solidFill>
                   <a:schemeClr val="tx1">
                     <a:lumMod val="75000"/>
@@ -4372,8 +4377,8 @@
         </p:nvSpPr>
         <p:spPr>
           <a:xfrm>
-            <a:off x="1870074" y="3641000"/>
-            <a:ext cx="18853151" cy="4933521"/>
+            <a:off x="1872234" y="3668758"/>
+            <a:ext cx="18874925" cy="4971132"/>
           </a:xfrm>
           <a:prstGeom prst="rect">
             <a:avLst/>
@@ -4459,8 +4464,8 @@
         </p:nvCxnSpPr>
         <p:spPr>
           <a:xfrm>
-            <a:off x="15484730" y="38738175"/>
-            <a:ext cx="12914979" cy="0"/>
+            <a:off x="15502614" y="39033499"/>
+            <a:ext cx="12929895" cy="0"/>
           </a:xfrm>
           <a:prstGeom prst="line">
             <a:avLst/>
@@ -4528,8 +4533,8 @@
         </p:nvSpPr>
         <p:spPr>
           <a:xfrm>
-            <a:off x="1870074" y="3641000"/>
-            <a:ext cx="18853151" cy="4933521"/>
+            <a:off x="1872234" y="3668758"/>
+            <a:ext cx="18874925" cy="4971132"/>
           </a:xfrm>
           <a:prstGeom prst="rect">
             <a:avLst/>
@@ -4615,8 +4620,8 @@
         </p:nvCxnSpPr>
         <p:spPr>
           <a:xfrm>
-            <a:off x="22248813" y="4229100"/>
-            <a:ext cx="0" cy="3829050"/>
+            <a:off x="22274509" y="4261341"/>
+            <a:ext cx="0" cy="3858241"/>
           </a:xfrm>
           <a:prstGeom prst="line">
             <a:avLst/>
@@ -4657,8 +4662,8 @@
         </p:nvSpPr>
         <p:spPr>
           <a:xfrm>
-            <a:off x="1870075" y="9502775"/>
-            <a:ext cx="12853988" cy="31970663"/>
+            <a:off x="1872235" y="9575221"/>
+            <a:ext cx="12868833" cy="4969630"/>
           </a:xfrm>
         </p:spPr>
         <p:txBody>
@@ -4709,8 +4714,8 @@
         </p:nvSpPr>
         <p:spPr>
           <a:xfrm>
-            <a:off x="23024312" y="4498924"/>
-            <a:ext cx="5309419" cy="461665"/>
+            <a:off x="23050904" y="4533222"/>
+            <a:ext cx="5315551" cy="465185"/>
           </a:xfrm>
           <a:prstGeom prst="rect">
             <a:avLst/>
@@ -4728,7 +4733,7 @@
               <a:buNone/>
             </a:pPr>
             <a:r>
-              <a:rPr lang="de-DE" sz="3000" b="1" spc="300" dirty="0">
+              <a:rPr lang="de-DE" sz="3004" b="1" spc="300" dirty="0">
                 <a:solidFill>
                   <a:schemeClr val="accent3">
                     <a:lumMod val="60000"/>
@@ -4754,8 +4759,8 @@
         </p:nvSpPr>
         <p:spPr>
           <a:xfrm>
-            <a:off x="22248814" y="1006475"/>
-            <a:ext cx="6945016" cy="1582738"/>
+            <a:off x="22274509" y="1371886"/>
+            <a:ext cx="6953037" cy="879328"/>
           </a:xfrm>
           <a:solidFill>
             <a:schemeClr val="bg1"/>
@@ -4764,7 +4769,7 @@
         <p:txBody>
           <a:bodyPr anchor="ctr" anchorCtr="0"/>
           <a:lstStyle>
-            <a:lvl1pPr marL="0" marR="0" indent="0" algn="ctr" defTabSz="2267986" rtl="0" eaLnBrk="1" fontAlgn="auto" latinLnBrk="0" hangingPunct="1">
+            <a:lvl1pPr marL="0" marR="0" indent="0" algn="ctr" defTabSz="2270708" rtl="0" eaLnBrk="1" fontAlgn="auto" latinLnBrk="0" hangingPunct="1">
               <a:lnSpc>
                 <a:spcPct val="100000"/>
               </a:lnSpc>
@@ -4772,14 +4777,14 @@
                 <a:spcPts val="0"/>
               </a:spcBef>
               <a:spcAft>
-                <a:spcPts val="2000"/>
+                <a:spcPts val="2002"/>
               </a:spcAft>
               <a:buClrTx/>
               <a:buSzTx/>
               <a:buFontTx/>
               <a:buNone/>
               <a:tabLst/>
-              <a:defRPr sz="2000" b="0">
+              <a:defRPr sz="2002" b="0">
                 <a:solidFill>
                   <a:schemeClr val="tx1">
                     <a:lumMod val="75000"/>
@@ -4790,7 +4795,7 @@
             </a:lvl1pPr>
           </a:lstStyle>
           <a:p>
-            <a:pPr marL="0" marR="0" lvl="0" indent="0" algn="l" defTabSz="2267986" rtl="0" eaLnBrk="1" fontAlgn="auto" latinLnBrk="0" hangingPunct="1">
+            <a:pPr marL="0" marR="0" lvl="0" indent="0" algn="l" defTabSz="2270708" rtl="0" eaLnBrk="1" fontAlgn="auto" latinLnBrk="0" hangingPunct="1">
               <a:lnSpc>
                 <a:spcPct val="100000"/>
               </a:lnSpc>
@@ -4798,7 +4803,7 @@
                 <a:spcPts val="0"/>
               </a:spcBef>
               <a:spcAft>
-                <a:spcPts val="2000"/>
+                <a:spcPts val="2002"/>
               </a:spcAft>
               <a:buClrTx/>
               <a:buSzTx/>
@@ -4808,7 +4813,7 @@
               <a:defRPr/>
             </a:pPr>
             <a:r>
-              <a:rPr lang="de-DE" sz="2000" dirty="0">
+              <a:rPr lang="de-DE" sz="2002" dirty="0">
                 <a:solidFill>
                   <a:schemeClr val="tx1">
                     <a:lumMod val="75000"/>
@@ -4835,8 +4840,8 @@
         </p:nvSpPr>
         <p:spPr>
           <a:xfrm>
-            <a:off x="15464759" y="17957109"/>
-            <a:ext cx="12934950" cy="333425"/>
+            <a:off x="15482619" y="18094007"/>
+            <a:ext cx="12949889" cy="308226"/>
           </a:xfrm>
         </p:spPr>
         <p:txBody>
@@ -4846,14 +4851,14 @@
           <a:lstStyle>
             <a:lvl1pPr marL="0" indent="0">
               <a:lnSpc>
-                <a:spcPts val="2600"/>
+                <a:spcPts val="2603"/>
               </a:lnSpc>
               <a:spcAft>
-                <a:spcPts val="1200"/>
+                <a:spcPts val="1201"/>
               </a:spcAft>
               <a:buFontTx/>
               <a:buNone/>
-              <a:defRPr sz="2000" b="0" cap="none" baseline="0">
+              <a:defRPr sz="2002" b="0" cap="none" baseline="0">
                 <a:solidFill>
                   <a:schemeClr val="tx1">
                     <a:lumMod val="75000"/>
@@ -4865,22 +4870,22 @@
             <a:lvl2pPr marL="0" indent="0">
               <a:buFontTx/>
               <a:buNone/>
-              <a:defRPr sz="2000"/>
+              <a:defRPr sz="2002"/>
             </a:lvl2pPr>
             <a:lvl3pPr>
               <a:buFontTx/>
               <a:buNone/>
-              <a:defRPr sz="2000"/>
+              <a:defRPr sz="2002"/>
             </a:lvl3pPr>
             <a:lvl4pPr>
               <a:buFontTx/>
               <a:buNone/>
-              <a:defRPr sz="2000"/>
+              <a:defRPr sz="2002"/>
             </a:lvl4pPr>
             <a:lvl5pPr>
               <a:buFontTx/>
               <a:buNone/>
-              <a:defRPr sz="2000"/>
+              <a:defRPr sz="2002"/>
             </a:lvl5pPr>
           </a:lstStyle>
           <a:p>
@@ -4904,8 +4909,8 @@
         </p:nvSpPr>
         <p:spPr>
           <a:xfrm>
-            <a:off x="15444788" y="9538562"/>
-            <a:ext cx="12934950" cy="8090515"/>
+            <a:off x="15462625" y="9611281"/>
+            <a:ext cx="12949889" cy="4969630"/>
           </a:xfrm>
         </p:spPr>
         <p:txBody>
@@ -4960,8 +4965,8 @@
         </p:nvSpPr>
         <p:spPr>
           <a:xfrm>
-            <a:off x="15484730" y="27742978"/>
-            <a:ext cx="12934950" cy="333425"/>
+            <a:off x="15502613" y="27954480"/>
+            <a:ext cx="12949889" cy="308226"/>
           </a:xfrm>
         </p:spPr>
         <p:txBody>
@@ -4971,14 +4976,14 @@
           <a:lstStyle>
             <a:lvl1pPr marL="0" indent="0">
               <a:lnSpc>
-                <a:spcPts val="2600"/>
+                <a:spcPts val="2603"/>
               </a:lnSpc>
               <a:spcAft>
-                <a:spcPts val="1200"/>
+                <a:spcPts val="1201"/>
               </a:spcAft>
               <a:buFontTx/>
               <a:buNone/>
-              <a:defRPr sz="2000" b="0" cap="none" baseline="0">
+              <a:defRPr sz="2002" b="0" cap="none" baseline="0">
                 <a:solidFill>
                   <a:schemeClr val="tx1">
                     <a:lumMod val="75000"/>
@@ -4990,22 +4995,22 @@
             <a:lvl2pPr marL="0" indent="0">
               <a:buFontTx/>
               <a:buNone/>
-              <a:defRPr sz="2000"/>
+              <a:defRPr sz="2002"/>
             </a:lvl2pPr>
             <a:lvl3pPr>
               <a:buFontTx/>
               <a:buNone/>
-              <a:defRPr sz="2000"/>
+              <a:defRPr sz="2002"/>
             </a:lvl3pPr>
             <a:lvl4pPr>
               <a:buFontTx/>
               <a:buNone/>
-              <a:defRPr sz="2000"/>
+              <a:defRPr sz="2002"/>
             </a:lvl4pPr>
             <a:lvl5pPr>
               <a:buFontTx/>
               <a:buNone/>
-              <a:defRPr sz="2000"/>
+              <a:defRPr sz="2002"/>
             </a:lvl5pPr>
           </a:lstStyle>
           <a:p>
@@ -5029,8 +5034,8 @@
         </p:nvSpPr>
         <p:spPr>
           <a:xfrm>
-            <a:off x="15464759" y="19324431"/>
-            <a:ext cx="12934950" cy="8090515"/>
+            <a:off x="15482619" y="19471753"/>
+            <a:ext cx="12949889" cy="4969630"/>
           </a:xfrm>
         </p:spPr>
         <p:txBody>
@@ -5085,8 +5090,8 @@
         </p:nvSpPr>
         <p:spPr>
           <a:xfrm>
-            <a:off x="15504701" y="37529186"/>
-            <a:ext cx="12934950" cy="333425"/>
+            <a:off x="15522608" y="37815294"/>
+            <a:ext cx="12949889" cy="308226"/>
           </a:xfrm>
         </p:spPr>
         <p:txBody>
@@ -5096,14 +5101,14 @@
           <a:lstStyle>
             <a:lvl1pPr marL="0" indent="0">
               <a:lnSpc>
-                <a:spcPts val="2600"/>
+                <a:spcPts val="2603"/>
               </a:lnSpc>
               <a:spcAft>
-                <a:spcPts val="1200"/>
+                <a:spcPts val="1201"/>
               </a:spcAft>
               <a:buFontTx/>
               <a:buNone/>
-              <a:defRPr sz="2000" b="0" cap="none" baseline="0">
+              <a:defRPr sz="2002" b="0" cap="none" baseline="0">
                 <a:solidFill>
                   <a:schemeClr val="tx1">
                     <a:lumMod val="75000"/>
@@ -5115,22 +5120,22 @@
             <a:lvl2pPr marL="0" indent="0">
               <a:buFontTx/>
               <a:buNone/>
-              <a:defRPr sz="2000"/>
+              <a:defRPr sz="2002"/>
             </a:lvl2pPr>
             <a:lvl3pPr>
               <a:buFontTx/>
               <a:buNone/>
-              <a:defRPr sz="2000"/>
+              <a:defRPr sz="2002"/>
             </a:lvl3pPr>
             <a:lvl4pPr>
               <a:buFontTx/>
               <a:buNone/>
-              <a:defRPr sz="2000"/>
+              <a:defRPr sz="2002"/>
             </a:lvl4pPr>
             <a:lvl5pPr>
               <a:buFontTx/>
               <a:buNone/>
-              <a:defRPr sz="2000"/>
+              <a:defRPr sz="2002"/>
             </a:lvl5pPr>
           </a:lstStyle>
           <a:p>
@@ -5154,8 +5159,8 @@
         </p:nvSpPr>
         <p:spPr>
           <a:xfrm>
-            <a:off x="15484730" y="29110639"/>
-            <a:ext cx="12934950" cy="8090515"/>
+            <a:off x="15502613" y="29332567"/>
+            <a:ext cx="12949889" cy="4969630"/>
           </a:xfrm>
         </p:spPr>
         <p:txBody>
@@ -5210,29 +5215,29 @@
         </p:nvSpPr>
         <p:spPr>
           <a:xfrm>
-            <a:off x="22996150" y="5220000"/>
-            <a:ext cx="6131740" cy="666849"/>
+            <a:off x="23022708" y="5259796"/>
+            <a:ext cx="6138822" cy="641651"/>
           </a:xfrm>
         </p:spPr>
         <p:txBody>
           <a:bodyPr/>
           <a:lstStyle>
-            <a:lvl1pPr marL="457200" marR="0" indent="-457200" algn="l" defTabSz="3489669" rtl="0" eaLnBrk="1" fontAlgn="auto" latinLnBrk="0" hangingPunct="1">
+            <a:lvl1pPr marL="457749" marR="0" indent="-457749" algn="l" defTabSz="3493857" rtl="0" eaLnBrk="1" fontAlgn="auto" latinLnBrk="0" hangingPunct="1">
               <a:lnSpc>
-                <a:spcPts val="2600"/>
+                <a:spcPts val="2603"/>
               </a:lnSpc>
               <a:spcBef>
                 <a:spcPts val="0"/>
               </a:spcBef>
               <a:spcAft>
-                <a:spcPts val="1200"/>
+                <a:spcPts val="1201"/>
               </a:spcAft>
               <a:buClrTx/>
               <a:buSzTx/>
               <a:buFontTx/>
               <a:buNone/>
               <a:tabLst/>
-              <a:defRPr sz="2000" b="0" baseline="0">
+              <a:defRPr sz="2002" b="0" baseline="0">
                 <a:solidFill>
                   <a:schemeClr val="bg1"/>
                 </a:solidFill>
@@ -5242,34 +5247,34 @@
             <a:lvl2pPr marL="0" indent="0">
               <a:buFontTx/>
               <a:buNone/>
-              <a:defRPr sz="2000"/>
+              <a:defRPr sz="2002"/>
             </a:lvl2pPr>
             <a:lvl3pPr>
               <a:buFontTx/>
               <a:buNone/>
-              <a:defRPr sz="2000"/>
+              <a:defRPr sz="2002"/>
             </a:lvl3pPr>
             <a:lvl4pPr>
               <a:buFontTx/>
               <a:buNone/>
-              <a:defRPr sz="2000"/>
+              <a:defRPr sz="2002"/>
             </a:lvl4pPr>
             <a:lvl5pPr>
               <a:buFontTx/>
               <a:buNone/>
-              <a:defRPr sz="2000"/>
+              <a:defRPr sz="2002"/>
             </a:lvl5pPr>
           </a:lstStyle>
           <a:p>
-            <a:pPr marL="0" marR="0" lvl="0" indent="0" algn="l" defTabSz="3489669" rtl="0" eaLnBrk="1" fontAlgn="auto" latinLnBrk="0" hangingPunct="1">
+            <a:pPr marL="0" marR="0" lvl="0" indent="0" algn="l" defTabSz="3493857" rtl="0" eaLnBrk="1" fontAlgn="auto" latinLnBrk="0" hangingPunct="1">
               <a:lnSpc>
-                <a:spcPts val="2600"/>
+                <a:spcPts val="2603"/>
               </a:lnSpc>
               <a:spcBef>
                 <a:spcPts val="0"/>
               </a:spcBef>
               <a:spcAft>
-                <a:spcPts val="1200"/>
+                <a:spcPts val="1201"/>
               </a:spcAft>
               <a:buClrTx/>
               <a:buSzTx/>
@@ -5279,7 +5284,7 @@
               <a:defRPr/>
             </a:pPr>
             <a:r>
-              <a:rPr kumimoji="0" lang="en-US" sz="2000" b="0" i="0" u="none" strike="noStrike" kern="1200" cap="none" spc="0" normalizeH="0" baseline="0" noProof="0" dirty="0">
+              <a:rPr kumimoji="0" lang="en-US" sz="2002" b="0" i="0" u="none" strike="noStrike" kern="1200" cap="none" spc="0" normalizeH="0" baseline="0" noProof="0" dirty="0">
                 <a:ln>
                   <a:noFill/>
                 </a:ln>
@@ -5296,7 +5301,7 @@
               <a:t>Name Author</a:t>
             </a:r>
             <a:br>
-              <a:rPr kumimoji="0" lang="en-US" sz="2000" b="0" i="0" u="none" strike="noStrike" kern="1200" cap="none" spc="0" normalizeH="0" baseline="0" noProof="0" dirty="0">
+              <a:rPr kumimoji="0" lang="en-US" sz="2002" b="0" i="0" u="none" strike="noStrike" kern="1200" cap="none" spc="0" normalizeH="0" baseline="0" noProof="0" dirty="0">
                 <a:ln>
                   <a:noFill/>
                 </a:ln>
@@ -5312,7 +5317,7 @@
               </a:rPr>
             </a:br>
             <a:r>
-              <a:rPr kumimoji="0" lang="en-US" sz="2000" b="0" i="0" u="none" strike="noStrike" kern="1200" cap="none" spc="0" normalizeH="0" baseline="0" noProof="0" dirty="0">
+              <a:rPr kumimoji="0" lang="en-US" sz="2002" b="0" i="0" u="none" strike="noStrike" kern="1200" cap="none" spc="0" normalizeH="0" baseline="0" noProof="0" dirty="0">
                 <a:ln>
                   <a:noFill/>
                 </a:ln>
@@ -5328,7 +5333,7 @@
               </a:rPr>
               <a:t>and Department</a:t>
             </a:r>
-            <a:endParaRPr kumimoji="0" lang="de-DE" sz="2000" b="0" i="0" u="none" strike="noStrike" kern="1200" cap="none" spc="0" normalizeH="0" baseline="0" noProof="0" dirty="0">
+            <a:endParaRPr kumimoji="0" lang="de-DE" sz="2002" b="0" i="0" u="none" strike="noStrike" kern="1200" cap="none" spc="0" normalizeH="0" baseline="0" noProof="0" dirty="0">
               <a:ln>
                 <a:noFill/>
               </a:ln>
@@ -5353,8 +5358,8 @@
         </p:nvCxnSpPr>
         <p:spPr>
           <a:xfrm>
-            <a:off x="15061150" y="38738175"/>
-            <a:ext cx="0" cy="3741738"/>
+            <a:off x="15078544" y="39033499"/>
+            <a:ext cx="0" cy="3770264"/>
           </a:xfrm>
           <a:prstGeom prst="line">
             <a:avLst/>
@@ -5388,8 +5393,8 @@
         </p:nvSpPr>
         <p:spPr>
           <a:xfrm>
-            <a:off x="15444788" y="39457313"/>
-            <a:ext cx="6105525" cy="461665"/>
+            <a:off x="15462626" y="39758120"/>
+            <a:ext cx="6112576" cy="465185"/>
           </a:xfrm>
           <a:prstGeom prst="rect">
             <a:avLst/>
@@ -5407,7 +5412,7 @@
               <a:buNone/>
             </a:pPr>
             <a:r>
-              <a:rPr lang="de-DE" sz="3000" b="1" cap="all" spc="300" baseline="0" dirty="0">
+              <a:rPr lang="de-DE" sz="3004" b="1" cap="all" spc="300" baseline="0" dirty="0">
                 <a:solidFill>
                   <a:schemeClr val="tx2"/>
                 </a:solidFill>
@@ -5430,15 +5435,15 @@
         </p:nvSpPr>
         <p:spPr>
           <a:xfrm>
-            <a:off x="15444788" y="40061091"/>
-            <a:ext cx="2160000" cy="1440000"/>
+            <a:off x="15462625" y="40366501"/>
+            <a:ext cx="2162495" cy="1028381"/>
           </a:xfrm>
           <a:noFill/>
         </p:spPr>
         <p:txBody>
           <a:bodyPr/>
           <a:lstStyle>
-            <a:lvl1pPr marL="0" marR="0" indent="0" algn="l" defTabSz="3489669" rtl="0" eaLnBrk="1" fontAlgn="auto" latinLnBrk="0" hangingPunct="1">
+            <a:lvl1pPr marL="0" marR="0" indent="0" algn="l" defTabSz="3493857" rtl="0" eaLnBrk="1" fontAlgn="auto" latinLnBrk="0" hangingPunct="1">
               <a:lnSpc>
                 <a:spcPct val="100000"/>
               </a:lnSpc>
@@ -5453,7 +5458,7 @@
               <a:buFontTx/>
               <a:buNone/>
               <a:tabLst/>
-              <a:defRPr sz="2000"/>
+              <a:defRPr sz="2002"/>
             </a:lvl1pPr>
             <a:lvl2pPr marL="0" indent="0">
               <a:buFontTx/>
@@ -5463,7 +5468,7 @@
             <a:lvl4pPr marL="0" indent="0">
               <a:buFontTx/>
               <a:buNone/>
-              <a:defRPr sz="2000">
+              <a:defRPr sz="2002">
                 <a:solidFill>
                   <a:schemeClr val="tx1">
                     <a:lumMod val="75000"/>
@@ -5474,7 +5479,7 @@
             </a:lvl4pPr>
           </a:lstStyle>
           <a:p>
-            <a:pPr marL="0" marR="0" lvl="0" indent="0" algn="l" defTabSz="3489669" rtl="0" eaLnBrk="1" fontAlgn="auto" latinLnBrk="0" hangingPunct="1">
+            <a:pPr marL="0" marR="0" lvl="0" indent="0" algn="l" defTabSz="3493857" rtl="0" eaLnBrk="1" fontAlgn="auto" latinLnBrk="0" hangingPunct="1">
               <a:lnSpc>
                 <a:spcPct val="100000"/>
               </a:lnSpc>
@@ -5492,7 +5497,7 @@
               <a:defRPr/>
             </a:pPr>
             <a:r>
-              <a:rPr kumimoji="0" lang="de-DE" sz="2000" b="0" i="0" u="none" strike="noStrike" kern="1200" cap="none" spc="0" normalizeH="0" baseline="0" noProof="0" dirty="0">
+              <a:rPr kumimoji="0" lang="de-DE" sz="2002" b="0" i="0" u="none" strike="noStrike" kern="1200" cap="none" spc="0" normalizeH="0" baseline="0" noProof="0" dirty="0">
                 <a:ln>
                   <a:noFill/>
                 </a:ln>
@@ -5529,15 +5534,15 @@
         </p:nvSpPr>
         <p:spPr>
           <a:xfrm>
-            <a:off x="19033263" y="40061091"/>
-            <a:ext cx="2160000" cy="1440000"/>
+            <a:off x="19055245" y="40366501"/>
+            <a:ext cx="2162495" cy="1028381"/>
           </a:xfrm>
           <a:noFill/>
         </p:spPr>
         <p:txBody>
           <a:bodyPr/>
           <a:lstStyle>
-            <a:lvl1pPr marL="0" marR="0" indent="0" algn="l" defTabSz="3489669" rtl="0" eaLnBrk="1" fontAlgn="auto" latinLnBrk="0" hangingPunct="1">
+            <a:lvl1pPr marL="0" marR="0" indent="0" algn="l" defTabSz="3493857" rtl="0" eaLnBrk="1" fontAlgn="auto" latinLnBrk="0" hangingPunct="1">
               <a:lnSpc>
                 <a:spcPct val="100000"/>
               </a:lnSpc>
@@ -5552,7 +5557,7 @@
               <a:buFontTx/>
               <a:buNone/>
               <a:tabLst/>
-              <a:defRPr sz="2000"/>
+              <a:defRPr sz="2002"/>
             </a:lvl1pPr>
             <a:lvl2pPr marL="0" indent="0">
               <a:buFontTx/>
@@ -5562,7 +5567,7 @@
             <a:lvl4pPr marL="0" indent="0">
               <a:buFontTx/>
               <a:buNone/>
-              <a:defRPr sz="2000">
+              <a:defRPr sz="2002">
                 <a:solidFill>
                   <a:schemeClr val="tx1">
                     <a:lumMod val="75000"/>
@@ -5573,7 +5578,7 @@
             </a:lvl4pPr>
           </a:lstStyle>
           <a:p>
-            <a:pPr marL="0" marR="0" lvl="0" indent="0" algn="l" defTabSz="3489669" rtl="0" eaLnBrk="1" fontAlgn="auto" latinLnBrk="0" hangingPunct="1">
+            <a:pPr marL="0" marR="0" lvl="0" indent="0" algn="l" defTabSz="3493857" rtl="0" eaLnBrk="1" fontAlgn="auto" latinLnBrk="0" hangingPunct="1">
               <a:lnSpc>
                 <a:spcPct val="100000"/>
               </a:lnSpc>
@@ -5591,7 +5596,7 @@
               <a:defRPr/>
             </a:pPr>
             <a:r>
-              <a:rPr kumimoji="0" lang="de-DE" sz="2000" b="0" i="0" u="none" strike="noStrike" kern="1200" cap="none" spc="0" normalizeH="0" baseline="0" noProof="0" dirty="0">
+              <a:rPr kumimoji="0" lang="de-DE" sz="2002" b="0" i="0" u="none" strike="noStrike" kern="1200" cap="none" spc="0" normalizeH="0" baseline="0" noProof="0" dirty="0">
                 <a:ln>
                   <a:noFill/>
                 </a:ln>
@@ -5628,15 +5633,15 @@
         </p:nvSpPr>
         <p:spPr>
           <a:xfrm>
-            <a:off x="22621738" y="40061091"/>
-            <a:ext cx="2160000" cy="1440000"/>
+            <a:off x="22647864" y="40366501"/>
+            <a:ext cx="2162495" cy="1028381"/>
           </a:xfrm>
           <a:noFill/>
         </p:spPr>
         <p:txBody>
           <a:bodyPr/>
           <a:lstStyle>
-            <a:lvl1pPr marL="0" marR="0" indent="0" algn="l" defTabSz="3489669" rtl="0" eaLnBrk="1" fontAlgn="auto" latinLnBrk="0" hangingPunct="1">
+            <a:lvl1pPr marL="0" marR="0" indent="0" algn="l" defTabSz="3493857" rtl="0" eaLnBrk="1" fontAlgn="auto" latinLnBrk="0" hangingPunct="1">
               <a:lnSpc>
                 <a:spcPct val="100000"/>
               </a:lnSpc>
@@ -5651,7 +5656,7 @@
               <a:buFontTx/>
               <a:buNone/>
               <a:tabLst/>
-              <a:defRPr sz="2000"/>
+              <a:defRPr sz="2002"/>
             </a:lvl1pPr>
             <a:lvl2pPr marL="0" indent="0">
               <a:buFontTx/>
@@ -5661,7 +5666,7 @@
             <a:lvl4pPr marL="0" indent="0">
               <a:buFontTx/>
               <a:buNone/>
-              <a:defRPr sz="2000">
+              <a:defRPr sz="2002">
                 <a:solidFill>
                   <a:schemeClr val="tx1">
                     <a:lumMod val="75000"/>
@@ -5672,7 +5677,7 @@
             </a:lvl4pPr>
           </a:lstStyle>
           <a:p>
-            <a:pPr marL="0" marR="0" lvl="0" indent="0" algn="l" defTabSz="3489669" rtl="0" eaLnBrk="1" fontAlgn="auto" latinLnBrk="0" hangingPunct="1">
+            <a:pPr marL="0" marR="0" lvl="0" indent="0" algn="l" defTabSz="3493857" rtl="0" eaLnBrk="1" fontAlgn="auto" latinLnBrk="0" hangingPunct="1">
               <a:lnSpc>
                 <a:spcPct val="100000"/>
               </a:lnSpc>
@@ -5690,7 +5695,7 @@
               <a:defRPr/>
             </a:pPr>
             <a:r>
-              <a:rPr kumimoji="0" lang="de-DE" sz="2000" b="0" i="0" u="none" strike="noStrike" kern="1200" cap="none" spc="0" normalizeH="0" baseline="0" noProof="0" dirty="0">
+              <a:rPr kumimoji="0" lang="de-DE" sz="2002" b="0" i="0" u="none" strike="noStrike" kern="1200" cap="none" spc="0" normalizeH="0" baseline="0" noProof="0" dirty="0">
                 <a:ln>
                   <a:noFill/>
                 </a:ln>
@@ -5727,15 +5732,15 @@
         </p:nvSpPr>
         <p:spPr>
           <a:xfrm>
-            <a:off x="26210212" y="40061091"/>
-            <a:ext cx="2160000" cy="1440000"/>
+            <a:off x="26240482" y="40366501"/>
+            <a:ext cx="2162495" cy="1028381"/>
           </a:xfrm>
           <a:noFill/>
         </p:spPr>
         <p:txBody>
           <a:bodyPr/>
           <a:lstStyle>
-            <a:lvl1pPr marL="0" marR="0" indent="0" algn="l" defTabSz="3489669" rtl="0" eaLnBrk="1" fontAlgn="auto" latinLnBrk="0" hangingPunct="1">
+            <a:lvl1pPr marL="0" marR="0" indent="0" algn="l" defTabSz="3493857" rtl="0" eaLnBrk="1" fontAlgn="auto" latinLnBrk="0" hangingPunct="1">
               <a:lnSpc>
                 <a:spcPct val="100000"/>
               </a:lnSpc>
@@ -5750,7 +5755,7 @@
               <a:buFontTx/>
               <a:buNone/>
               <a:tabLst/>
-              <a:defRPr sz="2000"/>
+              <a:defRPr sz="2002"/>
             </a:lvl1pPr>
             <a:lvl2pPr marL="0" indent="0">
               <a:buFontTx/>
@@ -5760,7 +5765,7 @@
             <a:lvl4pPr marL="0" indent="0">
               <a:buFontTx/>
               <a:buNone/>
-              <a:defRPr sz="2000">
+              <a:defRPr sz="2002">
                 <a:solidFill>
                   <a:schemeClr val="tx1">
                     <a:lumMod val="75000"/>
@@ -5771,7 +5776,7 @@
             </a:lvl4pPr>
           </a:lstStyle>
           <a:p>
-            <a:pPr marL="0" marR="0" lvl="0" indent="0" algn="l" defTabSz="3489669" rtl="0" eaLnBrk="1" fontAlgn="auto" latinLnBrk="0" hangingPunct="1">
+            <a:pPr marL="0" marR="0" lvl="0" indent="0" algn="l" defTabSz="3493857" rtl="0" eaLnBrk="1" fontAlgn="auto" latinLnBrk="0" hangingPunct="1">
               <a:lnSpc>
                 <a:spcPct val="100000"/>
               </a:lnSpc>
@@ -5789,7 +5794,7 @@
               <a:defRPr/>
             </a:pPr>
             <a:r>
-              <a:rPr kumimoji="0" lang="de-DE" sz="2000" b="0" i="0" u="none" strike="noStrike" kern="1200" cap="none" spc="0" normalizeH="0" baseline="0" noProof="0" dirty="0">
+              <a:rPr kumimoji="0" lang="de-DE" sz="2002" b="0" i="0" u="none" strike="noStrike" kern="1200" cap="none" spc="0" normalizeH="0" baseline="0" noProof="0" dirty="0">
                 <a:ln>
                   <a:noFill/>
                 </a:ln>
@@ -5826,8 +5831,8 @@
         </p:nvSpPr>
         <p:spPr>
           <a:xfrm>
-            <a:off x="1773003" y="39289704"/>
-            <a:ext cx="2563022" cy="2593294"/>
+            <a:off x="1775051" y="39589233"/>
+            <a:ext cx="2565982" cy="952770"/>
           </a:xfrm>
           <a:prstGeom prst="ellipse">
             <a:avLst/>
@@ -5846,7 +5851,7 @@
         <p:txBody>
           <a:bodyPr/>
           <a:lstStyle>
-            <a:lvl1pPr marL="0" marR="0" indent="0" algn="l" defTabSz="3489669" rtl="0" eaLnBrk="1" fontAlgn="auto" latinLnBrk="0" hangingPunct="1">
+            <a:lvl1pPr marL="0" marR="0" indent="0" algn="l" defTabSz="3493857" rtl="0" eaLnBrk="1" fontAlgn="auto" latinLnBrk="0" hangingPunct="1">
               <a:lnSpc>
                 <a:spcPct val="100000"/>
               </a:lnSpc>
@@ -5866,7 +5871,7 @@
             <a:lvl3pPr marL="0" indent="0">
               <a:buFont typeface="+mj-lt"/>
               <a:buNone/>
-              <a:defRPr sz="1800" baseline="0">
+              <a:defRPr sz="1802" baseline="0">
                 <a:solidFill>
                   <a:schemeClr val="tx1">
                     <a:lumMod val="75000"/>
@@ -5877,7 +5882,7 @@
             </a:lvl3pPr>
           </a:lstStyle>
           <a:p>
-            <a:pPr marL="0" marR="0" lvl="0" indent="0" algn="l" defTabSz="3489669" rtl="0" eaLnBrk="1" fontAlgn="auto" latinLnBrk="0" hangingPunct="1">
+            <a:pPr marL="0" marR="0" lvl="0" indent="0" algn="l" defTabSz="3493857" rtl="0" eaLnBrk="1" fontAlgn="auto" latinLnBrk="0" hangingPunct="1">
               <a:lnSpc>
                 <a:spcPct val="100000"/>
               </a:lnSpc>
@@ -5895,7 +5900,7 @@
               <a:defRPr/>
             </a:pPr>
             <a:r>
-              <a:rPr kumimoji="0" lang="de-DE" sz="2000" b="0" i="0" u="none" strike="noStrike" kern="1200" cap="none" spc="0" normalizeH="0" baseline="0" noProof="0" dirty="0">
+              <a:rPr kumimoji="0" lang="de-DE" sz="2002" b="0" i="0" u="none" strike="noStrike" kern="1200" cap="none" spc="0" normalizeH="0" baseline="0" noProof="0" dirty="0">
                 <a:ln>
                   <a:noFill/>
                 </a:ln>
@@ -5932,8 +5937,8 @@
         </p:nvSpPr>
         <p:spPr>
           <a:xfrm>
-            <a:off x="5003999" y="40175391"/>
-            <a:ext cx="9720063" cy="1707608"/>
+            <a:off x="5009779" y="40481672"/>
+            <a:ext cx="9731289" cy="1720626"/>
           </a:xfrm>
         </p:spPr>
         <p:txBody>
@@ -5943,14 +5948,14 @@
           <a:lstStyle>
             <a:lvl1pPr marL="0" indent="0">
               <a:lnSpc>
-                <a:spcPts val="2600"/>
+                <a:spcPts val="2603"/>
               </a:lnSpc>
               <a:spcAft>
-                <a:spcPts val="1200"/>
+                <a:spcPts val="1201"/>
               </a:spcAft>
               <a:buFontTx/>
               <a:buNone/>
-              <a:defRPr sz="2000" b="0" cap="none" baseline="0">
+              <a:defRPr sz="2002" b="0" cap="none" baseline="0">
                 <a:solidFill>
                   <a:schemeClr val="tx1">
                     <a:lumMod val="75000"/>
@@ -5962,7 +5967,7 @@
             <a:lvl2pPr marL="0" indent="0">
               <a:buFontTx/>
               <a:buNone/>
-              <a:defRPr sz="2000">
+              <a:defRPr sz="2002">
                 <a:solidFill>
                   <a:schemeClr val="tx1">
                     <a:lumMod val="75000"/>
@@ -5974,7 +5979,7 @@
             <a:lvl3pPr marL="0" indent="0">
               <a:buFontTx/>
               <a:buNone/>
-              <a:defRPr sz="2000">
+              <a:defRPr sz="2002">
                 <a:solidFill>
                   <a:schemeClr val="tx1">
                     <a:lumMod val="75000"/>
@@ -5986,7 +5991,7 @@
             <a:lvl4pPr marL="0" indent="0">
               <a:buFontTx/>
               <a:buNone/>
-              <a:defRPr sz="2000">
+              <a:defRPr sz="2002">
                 <a:solidFill>
                   <a:schemeClr val="tx1">
                     <a:lumMod val="75000"/>
@@ -5998,7 +6003,7 @@
             <a:lvl5pPr marL="0" indent="0">
               <a:buFontTx/>
               <a:buNone/>
-              <a:defRPr sz="2000">
+              <a:defRPr sz="2002">
                 <a:solidFill>
                   <a:schemeClr val="tx1">
                     <a:lumMod val="75000"/>
@@ -6025,8 +6030,8 @@
         </p:nvSpPr>
         <p:spPr>
           <a:xfrm>
-            <a:off x="5003999" y="39457313"/>
-            <a:ext cx="2139949" cy="461665"/>
+            <a:off x="5009779" y="39758120"/>
+            <a:ext cx="2142420" cy="465185"/>
           </a:xfrm>
           <a:prstGeom prst="rect">
             <a:avLst/>
@@ -6044,7 +6049,7 @@
               <a:buNone/>
             </a:pPr>
             <a:r>
-              <a:rPr lang="de-DE" sz="3000" b="1" cap="all" spc="300" baseline="0" dirty="0">
+              <a:rPr lang="de-DE" sz="3004" b="1" cap="all" spc="300" baseline="0" dirty="0">
                 <a:solidFill>
                   <a:schemeClr val="tx2"/>
                 </a:solidFill>
@@ -6063,8 +6068,8 @@
         </p:nvCxnSpPr>
         <p:spPr>
           <a:xfrm>
-            <a:off x="1077913" y="38738175"/>
-            <a:ext cx="28119387" cy="0"/>
+            <a:off x="1079158" y="39033499"/>
+            <a:ext cx="28151863" cy="0"/>
           </a:xfrm>
           <a:prstGeom prst="line">
             <a:avLst/>
@@ -6128,8 +6133,8 @@
         </p:nvSpPr>
         <p:spPr>
           <a:xfrm>
-            <a:off x="1870075" y="16333788"/>
-            <a:ext cx="26500138" cy="5611812"/>
+            <a:off x="1872235" y="16458310"/>
+            <a:ext cx="26530743" cy="5654594"/>
           </a:xfrm>
           <a:prstGeom prst="rect">
             <a:avLst/>
@@ -6164,7 +6169,7 @@
           <a:lstStyle/>
           <a:p>
             <a:pPr algn="ctr"/>
-            <a:endParaRPr lang="de-DE"/>
+            <a:endParaRPr lang="de-DE" sz="6913"/>
           </a:p>
         </p:txBody>
       </p:sp>
@@ -6176,8 +6181,8 @@
         </p:nvCxnSpPr>
         <p:spPr>
           <a:xfrm>
-            <a:off x="1870075" y="23331948"/>
-            <a:ext cx="12853988" cy="0"/>
+            <a:off x="1872235" y="23509822"/>
+            <a:ext cx="12868833" cy="0"/>
           </a:xfrm>
           <a:prstGeom prst="line">
             <a:avLst/>
@@ -6214,8 +6219,8 @@
         </p:nvSpPr>
         <p:spPr>
           <a:xfrm>
-            <a:off x="1870075" y="25455716"/>
-            <a:ext cx="12853988" cy="461665"/>
+            <a:off x="1872235" y="25649781"/>
+            <a:ext cx="12868833" cy="465185"/>
           </a:xfrm>
           <a:prstGeom prst="rect">
             <a:avLst/>
@@ -6229,7 +6234,7 @@
           <a:lstStyle/>
           <a:p>
             <a:r>
-              <a:rPr lang="de-DE" sz="3000" dirty="0">
+              <a:rPr lang="de-DE" sz="3004" dirty="0">
                 <a:solidFill>
                   <a:schemeClr val="tx1">
                     <a:lumMod val="75000"/>
@@ -6249,8 +6254,8 @@
         </p:nvSpPr>
         <p:spPr>
           <a:xfrm rot="16200000">
-            <a:off x="15444788" y="23331948"/>
-            <a:ext cx="6105525" cy="6105525"/>
+            <a:off x="15442879" y="23529570"/>
+            <a:ext cx="6152071" cy="6112576"/>
           </a:xfrm>
           <a:prstGeom prst="teardrop">
             <a:avLst/>
@@ -6279,7 +6284,7 @@
           </a:fontRef>
         </p:style>
         <p:txBody>
-          <a:bodyPr rot="0" spcFirstLastPara="0" vertOverflow="overflow" horzOverflow="overflow" vert="horz" wrap="square" lIns="91440" tIns="45720" rIns="91440" bIns="45720" numCol="1" spcCol="0" rtlCol="0" fromWordArt="0" anchor="ctr" anchorCtr="0" forceAA="0" compatLnSpc="1">
+          <a:bodyPr rot="0" spcFirstLastPara="0" vertOverflow="overflow" horzOverflow="overflow" vert="horz" wrap="square" lIns="91546" tIns="45773" rIns="91546" bIns="45773" numCol="1" spcCol="0" rtlCol="0" fromWordArt="0" anchor="ctr" anchorCtr="0" forceAA="0" compatLnSpc="1">
             <a:prstTxWarp prst="textNoShape">
               <a:avLst/>
             </a:prstTxWarp>
@@ -6288,7 +6293,7 @@
           <a:lstStyle/>
           <a:p>
             <a:pPr algn="ctr"/>
-            <a:endParaRPr lang="de-DE"/>
+            <a:endParaRPr lang="de-DE" sz="6913"/>
           </a:p>
         </p:txBody>
       </p:sp>
@@ -6305,12 +6310,12 @@
   <p:extLst>
     <p:ext uri="{DCECCB84-F9BA-43D5-87BE-67443E8EF086}">
       <p15:sldGuideLst xmlns:p15="http://schemas.microsoft.com/office/powerpoint/2012/main">
-        <p15:guide id="1" pos="2155" userDrawn="1">
+        <p15:guide id="1" pos="2157" userDrawn="1">
           <p15:clr>
             <a:srgbClr val="FBAE40"/>
           </p15:clr>
         </p15:guide>
-        <p15:guide id="2" orient="horz" pos="10289" userDrawn="1">
+        <p15:guide id="2" orient="horz" pos="10367" userDrawn="1">
           <p15:clr>
             <a:srgbClr val="FBAE40"/>
           </p15:clr>
@@ -6351,8 +6356,8 @@
         </p:nvSpPr>
         <p:spPr>
           <a:xfrm>
-            <a:off x="0" y="2484210"/>
-            <a:ext cx="30240288" cy="2880000"/>
+            <a:off x="0" y="2503149"/>
+            <a:ext cx="30275213" cy="2901956"/>
           </a:xfrm>
           <a:prstGeom prst="rect">
             <a:avLst/>
@@ -6385,7 +6390,7 @@
           <a:lstStyle/>
           <a:p>
             <a:pPr algn="ctr"/>
-            <a:endParaRPr lang="de-DE"/>
+            <a:endParaRPr lang="de-DE" sz="6913"/>
           </a:p>
         </p:txBody>
       </p:sp>
@@ -6401,8 +6406,8 @@
         </p:nvSpPr>
         <p:spPr>
           <a:xfrm>
-            <a:off x="1870076" y="2495583"/>
-            <a:ext cx="19680238" cy="2899265"/>
+            <a:off x="1872236" y="2514609"/>
+            <a:ext cx="19702967" cy="2921368"/>
           </a:xfrm>
           <a:prstGeom prst="rect">
             <a:avLst/>
@@ -6441,8 +6446,8 @@
         </p:nvSpPr>
         <p:spPr>
           <a:xfrm>
-            <a:off x="1870076" y="10726738"/>
-            <a:ext cx="12853987" cy="4349909"/>
+            <a:off x="1872236" y="10808515"/>
+            <a:ext cx="12868832" cy="4383071"/>
           </a:xfrm>
           <a:prstGeom prst="rect">
             <a:avLst/>
@@ -6510,8 +6515,8 @@
         </p:blipFill>
         <p:spPr>
           <a:xfrm>
-            <a:off x="1160218" y="676830"/>
-            <a:ext cx="5771175" cy="1492250"/>
+            <a:off x="1161559" y="681990"/>
+            <a:ext cx="5777840" cy="1503626"/>
           </a:xfrm>
           <a:prstGeom prst="rect">
             <a:avLst/>
@@ -6535,7 +6540,7 @@
   </p:sldLayoutIdLst>
   <p:txStyles>
     <p:titleStyle>
-      <a:lvl1pPr algn="l" defTabSz="2267986" rtl="0" eaLnBrk="1" latinLnBrk="0" hangingPunct="1">
+      <a:lvl1pPr algn="l" defTabSz="2270708" rtl="0" eaLnBrk="1" latinLnBrk="0" hangingPunct="1">
         <a:lnSpc>
           <a:spcPct val="90000"/>
         </a:lnSpc>
@@ -6543,7 +6548,7 @@
           <a:spcPct val="0"/>
         </a:spcBef>
         <a:buNone/>
-        <a:defRPr sz="8000" b="1" kern="1200" spc="0" baseline="0">
+        <a:defRPr sz="8010" b="1" kern="1200" spc="0" baseline="0">
           <a:solidFill>
             <a:schemeClr val="tx2"/>
           </a:solidFill>
@@ -6554,7 +6559,7 @@
       </a:lvl1pPr>
     </p:titleStyle>
     <p:bodyStyle>
-      <a:lvl1pPr marL="720000" indent="-720000" algn="l" defTabSz="2267986" rtl="0" eaLnBrk="1" latinLnBrk="0" hangingPunct="1">
+      <a:lvl1pPr marL="720864" indent="-720864" algn="l" defTabSz="2270708" rtl="0" eaLnBrk="1" latinLnBrk="0" hangingPunct="1">
         <a:lnSpc>
           <a:spcPct val="100000"/>
         </a:lnSpc>
@@ -6562,11 +6567,11 @@
           <a:spcPts val="0"/>
         </a:spcBef>
         <a:spcAft>
-          <a:spcPts val="2000"/>
+          <a:spcPts val="2002"/>
         </a:spcAft>
         <a:buFont typeface="+mj-lt"/>
         <a:buAutoNum type="romanUcPeriod"/>
-        <a:defRPr sz="6000" b="1" kern="1200" cap="all" spc="100" baseline="0">
+        <a:defRPr sz="6007" b="1" kern="1200" cap="all" spc="100" baseline="0">
           <a:solidFill>
             <a:schemeClr val="tx2"/>
           </a:solidFill>
@@ -6575,15 +6580,15 @@
           <a:cs typeface="+mn-cs"/>
         </a:defRPr>
       </a:lvl1pPr>
-      <a:lvl2pPr marL="742950" indent="-742950" algn="l" defTabSz="2267986" rtl="0" eaLnBrk="1" latinLnBrk="0" hangingPunct="1">
+      <a:lvl2pPr marL="743842" indent="-743842" algn="l" defTabSz="2270708" rtl="0" eaLnBrk="1" latinLnBrk="0" hangingPunct="1">
         <a:lnSpc>
           <a:spcPct val="90000"/>
         </a:lnSpc>
         <a:spcBef>
-          <a:spcPts val="3600"/>
+          <a:spcPts val="3604"/>
         </a:spcBef>
         <a:spcAft>
-          <a:spcPts val="1000"/>
+          <a:spcPts val="1001"/>
         </a:spcAft>
         <a:buClr>
           <a:schemeClr val="accent3"/>
@@ -6591,7 +6596,7 @@
         <a:buSzPct val="100000"/>
         <a:buFont typeface="+mj-lt"/>
         <a:buAutoNum type="arabicPeriod"/>
-        <a:defRPr lang="de-DE" sz="4000" b="1" kern="1200" dirty="0" smtClean="0">
+        <a:defRPr lang="de-DE" sz="4005" b="1" kern="1200" dirty="0" smtClean="0">
           <a:solidFill>
             <a:schemeClr val="accent3"/>
           </a:solidFill>
@@ -6600,7 +6605,7 @@
           <a:cs typeface="+mn-cs"/>
         </a:defRPr>
       </a:lvl2pPr>
-      <a:lvl3pPr marL="0" indent="0" algn="l" defTabSz="2267986" rtl="0" eaLnBrk="1" latinLnBrk="0" hangingPunct="1">
+      <a:lvl3pPr marL="0" indent="0" algn="l" defTabSz="2270708" rtl="0" eaLnBrk="1" latinLnBrk="0" hangingPunct="1">
         <a:lnSpc>
           <a:spcPct val="150000"/>
         </a:lnSpc>
@@ -6612,7 +6617,7 @@
         </a:spcAft>
         <a:buFontTx/>
         <a:buNone/>
-        <a:defRPr sz="3000" b="1" kern="1200" baseline="0">
+        <a:defRPr sz="3004" b="1" kern="1200" baseline="0">
           <a:solidFill>
             <a:schemeClr val="tx1">
               <a:lumMod val="75000"/>
@@ -6623,19 +6628,19 @@
           <a:cs typeface="+mn-cs"/>
         </a:defRPr>
       </a:lvl3pPr>
-      <a:lvl4pPr marL="0" indent="0" algn="l" defTabSz="2267986" rtl="0" eaLnBrk="1" latinLnBrk="0" hangingPunct="1">
+      <a:lvl4pPr marL="0" indent="0" algn="l" defTabSz="2270708" rtl="0" eaLnBrk="1" latinLnBrk="0" hangingPunct="1">
         <a:lnSpc>
-          <a:spcPts val="3600"/>
+          <a:spcPts val="3604"/>
         </a:lnSpc>
         <a:spcBef>
           <a:spcPts val="0"/>
         </a:spcBef>
         <a:spcAft>
-          <a:spcPts val="2000"/>
+          <a:spcPts val="2002"/>
         </a:spcAft>
         <a:buFontTx/>
         <a:buNone/>
-        <a:defRPr sz="3000" kern="1200" baseline="0">
+        <a:defRPr sz="3004" kern="1200" baseline="0">
           <a:solidFill>
             <a:schemeClr val="tx1">
               <a:lumMod val="75000"/>
@@ -6646,7 +6651,7 @@
           <a:cs typeface="+mn-cs"/>
         </a:defRPr>
       </a:lvl4pPr>
-      <a:lvl5pPr marL="0" indent="0" algn="l" defTabSz="2267986" rtl="0" eaLnBrk="1" latinLnBrk="0" hangingPunct="1">
+      <a:lvl5pPr marL="0" indent="0" algn="l" defTabSz="2270708" rtl="0" eaLnBrk="1" latinLnBrk="0" hangingPunct="1">
         <a:lnSpc>
           <a:spcPct val="100000"/>
         </a:lnSpc>
@@ -6654,12 +6659,12 @@
           <a:spcPts val="0"/>
         </a:spcBef>
         <a:spcAft>
-          <a:spcPts val="1000"/>
+          <a:spcPts val="1001"/>
         </a:spcAft>
         <a:buSzPct val="80000"/>
         <a:buFontTx/>
         <a:buNone/>
-        <a:defRPr sz="2000" kern="1200">
+        <a:defRPr sz="2002" kern="1200">
           <a:solidFill>
             <a:schemeClr val="tx1"/>
           </a:solidFill>
@@ -6668,16 +6673,16 @@
           <a:cs typeface="+mn-cs"/>
         </a:defRPr>
       </a:lvl5pPr>
-      <a:lvl6pPr marL="6236962" indent="-566997" algn="l" defTabSz="2267986" rtl="0" eaLnBrk="1" latinLnBrk="0" hangingPunct="1">
+      <a:lvl6pPr marL="6244446" indent="-567677" algn="l" defTabSz="2270708" rtl="0" eaLnBrk="1" latinLnBrk="0" hangingPunct="1">
         <a:lnSpc>
           <a:spcPct val="90000"/>
         </a:lnSpc>
         <a:spcBef>
-          <a:spcPts val="1240"/>
+          <a:spcPts val="1241"/>
         </a:spcBef>
         <a:buFont typeface="Arial" panose="020B0604020202020204" pitchFamily="34" charset="0"/>
         <a:buChar char="•"/>
-        <a:defRPr sz="4465" kern="1200">
+        <a:defRPr sz="4470" kern="1200">
           <a:solidFill>
             <a:schemeClr val="tx1"/>
           </a:solidFill>
@@ -6686,16 +6691,16 @@
           <a:cs typeface="+mn-cs"/>
         </a:defRPr>
       </a:lvl6pPr>
-      <a:lvl7pPr marL="7370956" indent="-566997" algn="l" defTabSz="2267986" rtl="0" eaLnBrk="1" latinLnBrk="0" hangingPunct="1">
+      <a:lvl7pPr marL="7379801" indent="-567677" algn="l" defTabSz="2270708" rtl="0" eaLnBrk="1" latinLnBrk="0" hangingPunct="1">
         <a:lnSpc>
           <a:spcPct val="90000"/>
         </a:lnSpc>
         <a:spcBef>
-          <a:spcPts val="1240"/>
+          <a:spcPts val="1241"/>
         </a:spcBef>
         <a:buFont typeface="Arial" panose="020B0604020202020204" pitchFamily="34" charset="0"/>
         <a:buChar char="•"/>
-        <a:defRPr sz="4465" kern="1200">
+        <a:defRPr sz="4470" kern="1200">
           <a:solidFill>
             <a:schemeClr val="tx1"/>
           </a:solidFill>
@@ -6704,16 +6709,16 @@
           <a:cs typeface="+mn-cs"/>
         </a:defRPr>
       </a:lvl7pPr>
-      <a:lvl8pPr marL="8504949" indent="-566997" algn="l" defTabSz="2267986" rtl="0" eaLnBrk="1" latinLnBrk="0" hangingPunct="1">
+      <a:lvl8pPr marL="8515155" indent="-567677" algn="l" defTabSz="2270708" rtl="0" eaLnBrk="1" latinLnBrk="0" hangingPunct="1">
         <a:lnSpc>
           <a:spcPct val="90000"/>
         </a:lnSpc>
         <a:spcBef>
-          <a:spcPts val="1240"/>
+          <a:spcPts val="1241"/>
         </a:spcBef>
         <a:buFont typeface="Arial" panose="020B0604020202020204" pitchFamily="34" charset="0"/>
         <a:buChar char="•"/>
-        <a:defRPr sz="4465" kern="1200">
+        <a:defRPr sz="4470" kern="1200">
           <a:solidFill>
             <a:schemeClr val="tx1"/>
           </a:solidFill>
@@ -6722,16 +6727,16 @@
           <a:cs typeface="+mn-cs"/>
         </a:defRPr>
       </a:lvl8pPr>
-      <a:lvl9pPr marL="9638942" indent="-566997" algn="l" defTabSz="2267986" rtl="0" eaLnBrk="1" latinLnBrk="0" hangingPunct="1">
+      <a:lvl9pPr marL="9650509" indent="-567677" algn="l" defTabSz="2270708" rtl="0" eaLnBrk="1" latinLnBrk="0" hangingPunct="1">
         <a:lnSpc>
           <a:spcPct val="90000"/>
         </a:lnSpc>
         <a:spcBef>
-          <a:spcPts val="1240"/>
+          <a:spcPts val="1241"/>
         </a:spcBef>
         <a:buFont typeface="Arial" panose="020B0604020202020204" pitchFamily="34" charset="0"/>
         <a:buChar char="•"/>
-        <a:defRPr sz="4465" kern="1200">
+        <a:defRPr sz="4470" kern="1200">
           <a:solidFill>
             <a:schemeClr val="tx1"/>
           </a:solidFill>
@@ -6745,8 +6750,8 @@
       <a:defPPr>
         <a:defRPr lang="de-DE"/>
       </a:defPPr>
-      <a:lvl1pPr marL="0" algn="l" defTabSz="2267986" rtl="0" eaLnBrk="1" latinLnBrk="0" hangingPunct="1">
-        <a:defRPr sz="4465" kern="1200">
+      <a:lvl1pPr marL="0" algn="l" defTabSz="2270708" rtl="0" eaLnBrk="1" latinLnBrk="0" hangingPunct="1">
+        <a:defRPr sz="4470" kern="1200">
           <a:solidFill>
             <a:schemeClr val="tx1"/>
           </a:solidFill>
@@ -6755,8 +6760,8 @@
           <a:cs typeface="+mn-cs"/>
         </a:defRPr>
       </a:lvl1pPr>
-      <a:lvl2pPr marL="1133993" algn="l" defTabSz="2267986" rtl="0" eaLnBrk="1" latinLnBrk="0" hangingPunct="1">
-        <a:defRPr sz="4465" kern="1200">
+      <a:lvl2pPr marL="1135354" algn="l" defTabSz="2270708" rtl="0" eaLnBrk="1" latinLnBrk="0" hangingPunct="1">
+        <a:defRPr sz="4470" kern="1200">
           <a:solidFill>
             <a:schemeClr val="tx1"/>
           </a:solidFill>
@@ -6765,8 +6770,8 @@
           <a:cs typeface="+mn-cs"/>
         </a:defRPr>
       </a:lvl2pPr>
-      <a:lvl3pPr marL="2267986" algn="l" defTabSz="2267986" rtl="0" eaLnBrk="1" latinLnBrk="0" hangingPunct="1">
-        <a:defRPr sz="4465" kern="1200">
+      <a:lvl3pPr marL="2270708" algn="l" defTabSz="2270708" rtl="0" eaLnBrk="1" latinLnBrk="0" hangingPunct="1">
+        <a:defRPr sz="4470" kern="1200">
           <a:solidFill>
             <a:schemeClr val="tx1"/>
           </a:solidFill>
@@ -6775,8 +6780,8 @@
           <a:cs typeface="+mn-cs"/>
         </a:defRPr>
       </a:lvl3pPr>
-      <a:lvl4pPr marL="3401979" algn="l" defTabSz="2267986" rtl="0" eaLnBrk="1" latinLnBrk="0" hangingPunct="1">
-        <a:defRPr sz="4465" kern="1200">
+      <a:lvl4pPr marL="3406061" algn="l" defTabSz="2270708" rtl="0" eaLnBrk="1" latinLnBrk="0" hangingPunct="1">
+        <a:defRPr sz="4470" kern="1200">
           <a:solidFill>
             <a:schemeClr val="tx1"/>
           </a:solidFill>
@@ -6785,8 +6790,8 @@
           <a:cs typeface="+mn-cs"/>
         </a:defRPr>
       </a:lvl4pPr>
-      <a:lvl5pPr marL="4535973" algn="l" defTabSz="2267986" rtl="0" eaLnBrk="1" latinLnBrk="0" hangingPunct="1">
-        <a:defRPr sz="4465" kern="1200">
+      <a:lvl5pPr marL="4541416" algn="l" defTabSz="2270708" rtl="0" eaLnBrk="1" latinLnBrk="0" hangingPunct="1">
+        <a:defRPr sz="4470" kern="1200">
           <a:solidFill>
             <a:schemeClr val="tx1"/>
           </a:solidFill>
@@ -6795,8 +6800,8 @@
           <a:cs typeface="+mn-cs"/>
         </a:defRPr>
       </a:lvl5pPr>
-      <a:lvl6pPr marL="5669966" algn="l" defTabSz="2267986" rtl="0" eaLnBrk="1" latinLnBrk="0" hangingPunct="1">
-        <a:defRPr sz="4465" kern="1200">
+      <a:lvl6pPr marL="5676770" algn="l" defTabSz="2270708" rtl="0" eaLnBrk="1" latinLnBrk="0" hangingPunct="1">
+        <a:defRPr sz="4470" kern="1200">
           <a:solidFill>
             <a:schemeClr val="tx1"/>
           </a:solidFill>
@@ -6805,8 +6810,8 @@
           <a:cs typeface="+mn-cs"/>
         </a:defRPr>
       </a:lvl6pPr>
-      <a:lvl7pPr marL="6803959" algn="l" defTabSz="2267986" rtl="0" eaLnBrk="1" latinLnBrk="0" hangingPunct="1">
-        <a:defRPr sz="4465" kern="1200">
+      <a:lvl7pPr marL="6812124" algn="l" defTabSz="2270708" rtl="0" eaLnBrk="1" latinLnBrk="0" hangingPunct="1">
+        <a:defRPr sz="4470" kern="1200">
           <a:solidFill>
             <a:schemeClr val="tx1"/>
           </a:solidFill>
@@ -6815,8 +6820,8 @@
           <a:cs typeface="+mn-cs"/>
         </a:defRPr>
       </a:lvl7pPr>
-      <a:lvl8pPr marL="7937952" algn="l" defTabSz="2267986" rtl="0" eaLnBrk="1" latinLnBrk="0" hangingPunct="1">
-        <a:defRPr sz="4465" kern="1200">
+      <a:lvl8pPr marL="7947478" algn="l" defTabSz="2270708" rtl="0" eaLnBrk="1" latinLnBrk="0" hangingPunct="1">
+        <a:defRPr sz="4470" kern="1200">
           <a:solidFill>
             <a:schemeClr val="tx1"/>
           </a:solidFill>
@@ -6825,8 +6830,8 @@
           <a:cs typeface="+mn-cs"/>
         </a:defRPr>
       </a:lvl8pPr>
-      <a:lvl9pPr marL="9071945" algn="l" defTabSz="2267986" rtl="0" eaLnBrk="1" latinLnBrk="0" hangingPunct="1">
-        <a:defRPr sz="4465" kern="1200">
+      <a:lvl9pPr marL="9082831" algn="l" defTabSz="2270708" rtl="0" eaLnBrk="1" latinLnBrk="0" hangingPunct="1">
+        <a:defRPr sz="4470" kern="1200">
           <a:solidFill>
             <a:schemeClr val="tx1"/>
           </a:solidFill>
@@ -6840,117 +6845,117 @@
   <p:extLst>
     <p:ext uri="{27BBF7A9-308A-43DC-89C8-2F10F3537804}">
       <p15:sldGuideLst xmlns:p15="http://schemas.microsoft.com/office/powerpoint/2012/main">
-        <p15:guide id="1" pos="1178" userDrawn="1">
+        <p15:guide id="1" pos="1179" userDrawn="1">
           <p15:clr>
             <a:srgbClr val="F26B43"/>
           </p15:clr>
         </p15:guide>
-        <p15:guide id="2" pos="657" userDrawn="1">
+        <p15:guide id="2" pos="658" userDrawn="1">
           <p15:clr>
             <a:srgbClr val="F26B43"/>
           </p15:clr>
         </p15:guide>
-        <p15:guide id="3" pos="17871" userDrawn="1">
+        <p15:guide id="3" pos="17892" userDrawn="1">
           <p15:clr>
             <a:srgbClr val="F26B43"/>
           </p15:clr>
         </p15:guide>
-        <p15:guide id="4" pos="9729" userDrawn="1">
+        <p15:guide id="4" pos="9740" userDrawn="1">
           <p15:clr>
             <a:srgbClr val="F26B43"/>
           </p15:clr>
         </p15:guide>
-        <p15:guide id="5" pos="13575" userDrawn="1">
+        <p15:guide id="5" pos="13591" userDrawn="1">
           <p15:clr>
             <a:srgbClr val="F26B43"/>
           </p15:clr>
         </p15:guide>
-        <p15:guide id="6" pos="9275" userDrawn="1">
+        <p15:guide id="6" pos="9286" userDrawn="1">
           <p15:clr>
             <a:srgbClr val="F26B43"/>
           </p15:clr>
         </p15:guide>
-        <p15:guide id="7" pos="5397" userDrawn="1">
+        <p15:guide id="7" pos="5403" userDrawn="1">
           <p15:clr>
             <a:srgbClr val="F26B43"/>
           </p15:clr>
         </p15:guide>
-        <p15:guide id="8" pos="4943" userDrawn="1">
+        <p15:guide id="8" pos="4949" userDrawn="1">
           <p15:clr>
             <a:srgbClr val="F26B43"/>
           </p15:clr>
         </p15:guide>
-        <p15:guide id="9" pos="1859" userDrawn="1">
+        <p15:guide id="9" pos="1861" userDrawn="1">
           <p15:clr>
             <a:srgbClr val="F26B43"/>
           </p15:clr>
         </p15:guide>
-        <p15:guide id="10" pos="14015" userDrawn="1">
+        <p15:guide id="10" pos="14031" userDrawn="1">
           <p15:clr>
             <a:srgbClr val="F26B43"/>
           </p15:clr>
         </p15:guide>
-        <p15:guide id="11" orient="horz" pos="1473" userDrawn="1">
+        <p15:guide id="11" orient="horz" pos="1484" userDrawn="1">
           <p15:clr>
             <a:srgbClr val="F26B43"/>
           </p15:clr>
         </p15:guide>
-        <p15:guide id="12" orient="horz" pos="2833" userDrawn="1">
+        <p15:guide id="12" orient="horz" pos="2855" userDrawn="1">
           <p15:clr>
             <a:srgbClr val="F26B43"/>
           </p15:clr>
         </p15:guide>
-        <p15:guide id="13" orient="horz" pos="2266" userDrawn="1">
+        <p15:guide id="13" orient="horz" pos="2283" userDrawn="1">
           <p15:clr>
             <a:srgbClr val="F26B43"/>
           </p15:clr>
         </p15:guide>
-        <p15:guide id="14" orient="horz" pos="24402" userDrawn="1">
+        <p15:guide id="14" orient="horz" pos="24588" userDrawn="1">
           <p15:clr>
             <a:srgbClr val="F26B43"/>
           </p15:clr>
         </p15:guide>
-        <p15:guide id="17" orient="horz" pos="24855" userDrawn="1">
+        <p15:guide id="17" orient="horz" pos="25044" userDrawn="1">
           <p15:clr>
             <a:srgbClr val="F26B43"/>
           </p15:clr>
         </p15:guide>
-        <p15:guide id="18" orient="horz" pos="634" userDrawn="1">
+        <p15:guide id="18" orient="horz" pos="639" userDrawn="1">
           <p15:clr>
             <a:srgbClr val="F26B43"/>
           </p15:clr>
         </p15:guide>
-        <p15:guide id="19" orient="horz" pos="5986" userDrawn="1">
+        <p15:guide id="19" orient="horz" pos="6032" userDrawn="1">
           <p15:clr>
             <a:srgbClr val="F26B43"/>
           </p15:clr>
         </p15:guide>
-        <p15:guide id="20" orient="horz" pos="26125" userDrawn="1">
+        <p15:guide id="20" orient="horz" pos="26324" userDrawn="1">
           <p15:clr>
             <a:srgbClr val="F26B43"/>
           </p15:clr>
         </p15:guide>
-        <p15:guide id="21" pos="18392" userDrawn="1">
+        <p15:guide id="21" pos="18413" userDrawn="1">
           <p15:clr>
             <a:srgbClr val="F26B43"/>
           </p15:clr>
         </p15:guide>
-        <p15:guide id="22" pos="9502" userDrawn="1">
+        <p15:guide id="22" pos="9513" userDrawn="1">
           <p15:clr>
             <a:srgbClr val="F26B43"/>
           </p15:clr>
         </p15:guide>
-        <p15:guide id="23" orient="horz" pos="6757" userDrawn="1">
+        <p15:guide id="23" orient="horz" pos="6809" userDrawn="1">
           <p15:clr>
             <a:srgbClr val="F26B43"/>
           </p15:clr>
         </p15:guide>
-        <p15:guide id="24" orient="horz" pos="1631" userDrawn="1">
+        <p15:guide id="24" orient="horz" pos="1643" userDrawn="1">
           <p15:clr>
             <a:srgbClr val="F26B43"/>
           </p15:clr>
         </p15:guide>
-        <p15:guide id="25" orient="horz" pos="792" userDrawn="1">
+        <p15:guide id="25" orient="horz" pos="798" userDrawn="1">
           <p15:clr>
             <a:srgbClr val="F26B43"/>
           </p15:clr>
@@ -6980,10 +6985,10 @@
       </p:grpSpPr>
       <p:pic>
         <p:nvPicPr>
-          <p:cNvPr id="23" name="Picture 22">
+          <p:cNvPr id="25" name="Picture 24">
             <a:extLst>
               <a:ext uri="{FF2B5EF4-FFF2-40B4-BE49-F238E27FC236}">
-                <a16:creationId xmlns:a16="http://schemas.microsoft.com/office/drawing/2014/main" id="{FCE9608D-DEB4-34FA-5BEF-44DE5678C628}"/>
+                <a16:creationId xmlns:a16="http://schemas.microsoft.com/office/drawing/2014/main" id="{C6269578-E4E6-5B58-68C3-BB3B3E61CEA1}"/>
               </a:ext>
             </a:extLst>
           </p:cNvPr>
@@ -7000,8 +7005,8 @@
         </p:blipFill>
         <p:spPr>
           <a:xfrm>
-            <a:off x="977954" y="31905719"/>
-            <a:ext cx="6120000" cy="6475517"/>
+            <a:off x="23650272" y="32054609"/>
+            <a:ext cx="6127200" cy="6483137"/>
           </a:xfrm>
           <a:prstGeom prst="rect">
             <a:avLst/>
@@ -7010,10 +7015,10 @@
       </p:pic>
       <p:pic>
         <p:nvPicPr>
-          <p:cNvPr id="31" name="Picture 30">
+          <p:cNvPr id="32" name="Picture 31">
             <a:extLst>
               <a:ext uri="{FF2B5EF4-FFF2-40B4-BE49-F238E27FC236}">
-                <a16:creationId xmlns:a16="http://schemas.microsoft.com/office/drawing/2014/main" id="{735C30B1-3513-B91C-9EC1-56913EFD208A}"/>
+                <a16:creationId xmlns:a16="http://schemas.microsoft.com/office/drawing/2014/main" id="{46DB4559-F71B-57E9-E9EA-C486EB8AFABB}"/>
               </a:ext>
             </a:extLst>
           </p:cNvPr>
@@ -7030,8 +7035,8 @@
         </p:blipFill>
         <p:spPr>
           <a:xfrm>
-            <a:off x="8526517" y="31905719"/>
-            <a:ext cx="6120000" cy="6475517"/>
+            <a:off x="16093125" y="32054609"/>
+            <a:ext cx="6127200" cy="6483137"/>
           </a:xfrm>
           <a:prstGeom prst="rect">
             <a:avLst/>
@@ -7040,10 +7045,10 @@
       </p:pic>
       <p:pic>
         <p:nvPicPr>
-          <p:cNvPr id="19" name="Picture 18">
+          <p:cNvPr id="36" name="Picture 35">
             <a:extLst>
               <a:ext uri="{FF2B5EF4-FFF2-40B4-BE49-F238E27FC236}">
-                <a16:creationId xmlns:a16="http://schemas.microsoft.com/office/drawing/2014/main" id="{9D95C26A-C2AA-40D2-5A5E-759D2C5A7E71}"/>
+                <a16:creationId xmlns:a16="http://schemas.microsoft.com/office/drawing/2014/main" id="{B96B242E-DFDE-3313-C483-083F30357CC7}"/>
               </a:ext>
             </a:extLst>
           </p:cNvPr>
@@ -7060,8 +7065,8 @@
         </p:blipFill>
         <p:spPr>
           <a:xfrm>
-            <a:off x="23623642" y="31905719"/>
-            <a:ext cx="6120000" cy="6475519"/>
+            <a:off x="8535979" y="32054609"/>
+            <a:ext cx="6127200" cy="6483137"/>
           </a:xfrm>
           <a:prstGeom prst="rect">
             <a:avLst/>
@@ -7070,10 +7075,10 @@
       </p:pic>
       <p:pic>
         <p:nvPicPr>
-          <p:cNvPr id="24" name="Picture 23">
+          <p:cNvPr id="38" name="Picture 37">
             <a:extLst>
               <a:ext uri="{FF2B5EF4-FFF2-40B4-BE49-F238E27FC236}">
-                <a16:creationId xmlns:a16="http://schemas.microsoft.com/office/drawing/2014/main" id="{07B020DD-A5FD-5730-4352-FAA8101E4772}"/>
+                <a16:creationId xmlns:a16="http://schemas.microsoft.com/office/drawing/2014/main" id="{0F50A68D-600A-5B92-8325-159DA475FFD9}"/>
               </a:ext>
             </a:extLst>
           </p:cNvPr>
@@ -7090,20 +7095,316 @@
         </p:blipFill>
         <p:spPr>
           <a:xfrm>
-            <a:off x="16075079" y="31905717"/>
-            <a:ext cx="6120000" cy="6475519"/>
+            <a:off x="978833" y="32054609"/>
+            <a:ext cx="6127200" cy="6483137"/>
           </a:xfrm>
           <a:prstGeom prst="rect">
             <a:avLst/>
           </a:prstGeom>
         </p:spPr>
       </p:pic>
+      <p:sp>
+        <p:nvSpPr>
+          <p:cNvPr id="2" name="Title 1">
+            <a:extLst>
+              <a:ext uri="{FF2B5EF4-FFF2-40B4-BE49-F238E27FC236}">
+                <a16:creationId xmlns:a16="http://schemas.microsoft.com/office/drawing/2014/main" id="{53927E75-EF0C-5628-48D3-97B955A594B2}"/>
+              </a:ext>
+            </a:extLst>
+          </p:cNvPr>
+          <p:cNvSpPr>
+            <a:spLocks noGrp="1"/>
+          </p:cNvSpPr>
+          <p:nvPr>
+            <p:ph type="title"/>
+          </p:nvPr>
+        </p:nvSpPr>
+        <p:spPr>
+          <a:xfrm>
+            <a:off x="1081903" y="2618762"/>
+            <a:ext cx="20431100" cy="2897507"/>
+          </a:xfrm>
+        </p:spPr>
+        <p:txBody>
+          <a:bodyPr/>
+          <a:lstStyle/>
+          <a:p>
+            <a:r>
+              <a:rPr lang="en-GB" sz="6007" dirty="0"/>
+              <a:t>Shared Mental Models in Generative AI-Based Multi-Agent Systems: A Simulation Study Grounded in Human Team Cognition Theory</a:t>
+            </a:r>
+          </a:p>
+        </p:txBody>
+      </p:sp>
+      <p:sp>
+        <p:nvSpPr>
+          <p:cNvPr id="10" name="Text Placeholder 9">
+            <a:extLst>
+              <a:ext uri="{FF2B5EF4-FFF2-40B4-BE49-F238E27FC236}">
+                <a16:creationId xmlns:a16="http://schemas.microsoft.com/office/drawing/2014/main" id="{96B5322A-F80A-9A85-4CBF-BA165C091A13}"/>
+              </a:ext>
+            </a:extLst>
+          </p:cNvPr>
+          <p:cNvSpPr>
+            <a:spLocks noGrp="1"/>
+          </p:cNvSpPr>
+          <p:nvPr>
+            <p:ph type="body" sz="quarter" idx="31"/>
+          </p:nvPr>
+        </p:nvSpPr>
+        <p:spPr>
+          <a:xfrm>
+            <a:off x="3352067" y="40830789"/>
+            <a:ext cx="3822119" cy="1375005"/>
+          </a:xfrm>
+        </p:spPr>
+        <p:txBody>
+          <a:bodyPr/>
+          <a:lstStyle/>
+          <a:p>
+            <a:r>
+              <a:rPr lang="en-GB" noProof="0" dirty="0"/>
+              <a:t>Leonard Hegemann</a:t>
+            </a:r>
+          </a:p>
+          <a:p>
+            <a:r>
+              <a:rPr lang="en-GB" noProof="0" dirty="0"/>
+              <a:t>70794 </a:t>
+            </a:r>
+            <a:r>
+              <a:rPr lang="en-GB" noProof="0" dirty="0" err="1"/>
+              <a:t>Filderstadt</a:t>
+            </a:r>
+            <a:r>
+              <a:rPr lang="en-GB" noProof="0" dirty="0"/>
+              <a:t>, Germany</a:t>
+            </a:r>
+          </a:p>
+        </p:txBody>
+      </p:sp>
+      <p:sp>
+        <p:nvSpPr>
+          <p:cNvPr id="11" name="Text Placeholder 10">
+            <a:extLst>
+              <a:ext uri="{FF2B5EF4-FFF2-40B4-BE49-F238E27FC236}">
+                <a16:creationId xmlns:a16="http://schemas.microsoft.com/office/drawing/2014/main" id="{1F26DFCC-8E7D-1978-2365-F7F9D4B55141}"/>
+              </a:ext>
+            </a:extLst>
+          </p:cNvPr>
+          <p:cNvSpPr>
+            <a:spLocks noGrp="1"/>
+          </p:cNvSpPr>
+          <p:nvPr>
+            <p:ph type="body" sz="quarter" idx="29"/>
+          </p:nvPr>
+        </p:nvSpPr>
+        <p:spPr>
+          <a:xfrm>
+            <a:off x="22301886" y="3951621"/>
+            <a:ext cx="6138822" cy="1284204"/>
+          </a:xfrm>
+        </p:spPr>
+        <p:txBody>
+          <a:bodyPr/>
+          <a:lstStyle/>
+          <a:p>
+            <a:r>
+              <a:rPr lang="en-GB" b="1" noProof="0" dirty="0"/>
+              <a:t>Leonard Hegemann</a:t>
+            </a:r>
+          </a:p>
+          <a:p>
+            <a:r>
+              <a:rPr lang="en-GB" noProof="0" dirty="0"/>
+              <a:t>CHAIR of Digital Management</a:t>
+            </a:r>
+          </a:p>
+          <a:p>
+            <a:r>
+              <a:rPr lang="en-GB" noProof="0" dirty="0"/>
+              <a:t>University of Hohenheim, Germany</a:t>
+            </a:r>
+          </a:p>
+        </p:txBody>
+      </p:sp>
+      <p:sp>
+        <p:nvSpPr>
+          <p:cNvPr id="12" name="Text Placeholder 11">
+            <a:extLst>
+              <a:ext uri="{FF2B5EF4-FFF2-40B4-BE49-F238E27FC236}">
+                <a16:creationId xmlns:a16="http://schemas.microsoft.com/office/drawing/2014/main" id="{5BAD6F67-C4FB-7F23-6C32-BCE2289A544E}"/>
+              </a:ext>
+            </a:extLst>
+          </p:cNvPr>
+          <p:cNvSpPr>
+            <a:spLocks noGrp="1"/>
+          </p:cNvSpPr>
+          <p:nvPr>
+            <p:ph type="body" sz="quarter" idx="39"/>
+          </p:nvPr>
+        </p:nvSpPr>
+        <p:spPr>
+          <a:xfrm>
+            <a:off x="8536364" y="40830789"/>
+            <a:ext cx="20215724" cy="1238083"/>
+          </a:xfrm>
+        </p:spPr>
+        <p:txBody>
+          <a:bodyPr/>
+          <a:lstStyle/>
+          <a:p>
+            <a:pPr algn="just">
+              <a:lnSpc>
+                <a:spcPts val="1201"/>
+              </a:lnSpc>
+              <a:spcAft>
+                <a:spcPts val="0"/>
+              </a:spcAft>
+            </a:pPr>
+            <a:r>
+              <a:rPr lang="en-GB" sz="1201" dirty="0"/>
+              <a:t>Cannon-Bowers, J. A., Salas, E., &amp; Converse, S. (1993). Shared mental models in expert team decision making. In N. J. Castellan Jr. (Ed.), Individual and group decision making: Current issues (pp. 221–246). Lawrence Erlbaum Associates.</a:t>
+            </a:r>
+          </a:p>
+          <a:p>
+            <a:pPr algn="just">
+              <a:lnSpc>
+                <a:spcPts val="1201"/>
+              </a:lnSpc>
+              <a:spcAft>
+                <a:spcPts val="0"/>
+              </a:spcAft>
+            </a:pPr>
+            <a:r>
+              <a:rPr lang="en-GB" sz="1201" dirty="0"/>
+              <a:t>Liu, N. F., Lin, K., Hewitt, J., Paranjape, A., Bevilacqua, M., Petroni, F., &amp; Liang, P. (2024). Lost in the middle: How language models use long contexts. Transactions of the Association for Computational Linguistics, 12, 157–173.</a:t>
+            </a:r>
+          </a:p>
+          <a:p>
+            <a:pPr algn="just">
+              <a:lnSpc>
+                <a:spcPts val="1201"/>
+              </a:lnSpc>
+              <a:spcAft>
+                <a:spcPts val="0"/>
+              </a:spcAft>
+            </a:pPr>
+            <a:r>
+              <a:rPr lang="en-GB" sz="1201" dirty="0"/>
+              <a:t>Mathieu, J. E., Heffner, T. S., Goodwin, G. F., Salas, E., &amp; Cannon-Bowers, J. A. (2000). The influence of shared mental models on team process and performance. Journal of Applied Psychology, 85(2), 273–283.</a:t>
+            </a:r>
+          </a:p>
+          <a:p>
+            <a:pPr algn="just">
+              <a:lnSpc>
+                <a:spcPts val="1201"/>
+              </a:lnSpc>
+              <a:spcAft>
+                <a:spcPts val="0"/>
+              </a:spcAft>
+            </a:pPr>
+            <a:r>
+              <a:rPr lang="en-GB" sz="1201" dirty="0"/>
+              <a:t>Schulz-Hardt, S., Brodbeck, F. C., </a:t>
+            </a:r>
+            <a:r>
+              <a:rPr lang="en-GB" sz="1201" dirty="0" err="1"/>
+              <a:t>Mojzisch</a:t>
+            </a:r>
+            <a:r>
+              <a:rPr lang="en-GB" sz="1201" dirty="0"/>
+              <a:t>, A., </a:t>
+            </a:r>
+            <a:r>
+              <a:rPr lang="en-GB" sz="1201" dirty="0" err="1"/>
+              <a:t>Kerschreiter</a:t>
+            </a:r>
+            <a:r>
+              <a:rPr lang="en-GB" sz="1201" dirty="0"/>
+              <a:t>, R., &amp; Frey, D. (2006). Group decision making in hidden profile situations: Dissent as a facilitator for decision quality. Journal of Personality and Social Psychology, 91(6), 1080–1093.</a:t>
+            </a:r>
+          </a:p>
+          <a:p>
+            <a:pPr algn="just">
+              <a:lnSpc>
+                <a:spcPts val="1201"/>
+              </a:lnSpc>
+              <a:spcAft>
+                <a:spcPts val="0"/>
+              </a:spcAft>
+            </a:pPr>
+            <a:r>
+              <a:rPr lang="en-GB" sz="1201" dirty="0"/>
+              <a:t>Stasser, G., &amp; Titus, W. (1985). Pooling of unshared information in group decision making: Biased information sampling during discussion. Journal of Personality and Social Psychology, 48(6), 1467–1478.</a:t>
+            </a:r>
+          </a:p>
+          <a:p>
+            <a:pPr algn="just">
+              <a:lnSpc>
+                <a:spcPts val="1201"/>
+              </a:lnSpc>
+              <a:spcAft>
+                <a:spcPts val="0"/>
+              </a:spcAft>
+            </a:pPr>
+            <a:r>
+              <a:rPr lang="en-GB" sz="1201" dirty="0"/>
+              <a:t>Van Ginkel, W. P., &amp; van Knippenberg, D. (2008). Group information elaboration and group decision making: The role of shared task representations. Organizational </a:t>
+            </a:r>
+            <a:r>
+              <a:rPr lang="en-GB" sz="1201" dirty="0" err="1"/>
+              <a:t>Behavior</a:t>
+            </a:r>
+            <a:r>
+              <a:rPr lang="en-GB" sz="1201" dirty="0"/>
+              <a:t> and Human Decision Processes, 105(1), 82–97.</a:t>
+            </a:r>
+          </a:p>
+          <a:p>
+            <a:pPr algn="just">
+              <a:lnSpc>
+                <a:spcPts val="1201"/>
+              </a:lnSpc>
+              <a:spcAft>
+                <a:spcPts val="0"/>
+              </a:spcAft>
+            </a:pPr>
+            <a:r>
+              <a:rPr lang="en-GB" sz="1201" dirty="0"/>
+              <a:t>Yen, J., Fan, X., Sun, S., Hanratty, T., &amp; </a:t>
+            </a:r>
+            <a:r>
+              <a:rPr lang="en-GB" sz="1201" dirty="0" err="1"/>
+              <a:t>Dumer</a:t>
+            </a:r>
+            <a:r>
+              <a:rPr lang="en-GB" sz="1201" dirty="0"/>
+              <a:t>, J. (2006). Agents with shared mental models for enhancing team decision makings. Decision Support Systems, 41(3), 634–653.</a:t>
+            </a:r>
+          </a:p>
+          <a:p>
+            <a:pPr algn="just">
+              <a:lnSpc>
+                <a:spcPts val="1201"/>
+              </a:lnSpc>
+              <a:spcAft>
+                <a:spcPts val="0"/>
+              </a:spcAft>
+            </a:pPr>
+            <a:r>
+              <a:rPr lang="en-GB" sz="1201" dirty="0"/>
+              <a:t>Zhang, Z., Dai, Q., Bo, X., Ma, C., Li, R., Chen, X., Zhu, J., Dong, Z., &amp; Wen, J.-R. (2025). A survey on the memory mechanism of large language model-based agents. ACM Transactions on Information Systems, 43(6), Article 155, 1–47.</a:t>
+            </a:r>
+          </a:p>
+        </p:txBody>
+      </p:sp>
       <p:pic>
         <p:nvPicPr>
-          <p:cNvPr id="4" name="Picture 3">
+          <p:cNvPr id="9" name="Picture 8">
             <a:extLst>
               <a:ext uri="{FF2B5EF4-FFF2-40B4-BE49-F238E27FC236}">
-                <a16:creationId xmlns:a16="http://schemas.microsoft.com/office/drawing/2014/main" id="{3DEAB6E2-06FD-C460-888B-3F69E7EB082B}"/>
+                <a16:creationId xmlns:a16="http://schemas.microsoft.com/office/drawing/2014/main" id="{EC16EF00-5251-5DD0-EF6E-6C3C017865A6}"/>
               </a:ext>
             </a:extLst>
           </p:cNvPr>
@@ -7120,310 +7421,14 @@
         </p:blipFill>
         <p:spPr>
           <a:xfrm>
-            <a:off x="977955" y="21134738"/>
-            <a:ext cx="13251600" cy="5311821"/>
+            <a:off x="980303" y="21312673"/>
+            <a:ext cx="13266000" cy="5317593"/>
           </a:xfrm>
           <a:prstGeom prst="rect">
             <a:avLst/>
           </a:prstGeom>
         </p:spPr>
       </p:pic>
-      <p:sp>
-        <p:nvSpPr>
-          <p:cNvPr id="2" name="Title 1">
-            <a:extLst>
-              <a:ext uri="{FF2B5EF4-FFF2-40B4-BE49-F238E27FC236}">
-                <a16:creationId xmlns:a16="http://schemas.microsoft.com/office/drawing/2014/main" id="{53927E75-EF0C-5628-48D3-97B955A594B2}"/>
-              </a:ext>
-            </a:extLst>
-          </p:cNvPr>
-          <p:cNvSpPr>
-            <a:spLocks noGrp="1"/>
-          </p:cNvSpPr>
-          <p:nvPr>
-            <p:ph type="title"/>
-          </p:nvPr>
-        </p:nvSpPr>
-        <p:spPr>
-          <a:xfrm>
-            <a:off x="1080655" y="2478505"/>
-            <a:ext cx="20407531" cy="2894164"/>
-          </a:xfrm>
-        </p:spPr>
-        <p:txBody>
-          <a:bodyPr/>
-          <a:lstStyle/>
-          <a:p>
-            <a:r>
-              <a:rPr lang="en-GB" sz="6000" noProof="0" dirty="0"/>
-              <a:t>Shared Mental Models in Generative AI-Based Multi-Agent Systems: A Simulation Study Grounded in Human Team Cognition Theory</a:t>
-            </a:r>
-          </a:p>
-        </p:txBody>
-      </p:sp>
-      <p:sp>
-        <p:nvSpPr>
-          <p:cNvPr id="10" name="Text Placeholder 9">
-            <a:extLst>
-              <a:ext uri="{FF2B5EF4-FFF2-40B4-BE49-F238E27FC236}">
-                <a16:creationId xmlns:a16="http://schemas.microsoft.com/office/drawing/2014/main" id="{96B5322A-F80A-9A85-4CBF-BA165C091A13}"/>
-              </a:ext>
-            </a:extLst>
-          </p:cNvPr>
-          <p:cNvSpPr>
-            <a:spLocks noGrp="1"/>
-          </p:cNvSpPr>
-          <p:nvPr>
-            <p:ph type="body" sz="quarter" idx="31"/>
-          </p:nvPr>
-        </p:nvSpPr>
-        <p:spPr>
-          <a:xfrm>
-            <a:off x="3348201" y="40646451"/>
-            <a:ext cx="3817710" cy="1373419"/>
-          </a:xfrm>
-        </p:spPr>
-        <p:txBody>
-          <a:bodyPr/>
-          <a:lstStyle/>
-          <a:p>
-            <a:r>
-              <a:rPr lang="en-GB" noProof="0" dirty="0"/>
-              <a:t>Leonard Hegemann</a:t>
-            </a:r>
-          </a:p>
-          <a:p>
-            <a:r>
-              <a:rPr lang="en-GB" noProof="0" dirty="0"/>
-              <a:t>70794 </a:t>
-            </a:r>
-            <a:r>
-              <a:rPr lang="en-GB" noProof="0" dirty="0" err="1"/>
-              <a:t>Filderstadt</a:t>
-            </a:r>
-            <a:r>
-              <a:rPr lang="en-GB" noProof="0" dirty="0"/>
-              <a:t>, Germany</a:t>
-            </a:r>
-          </a:p>
-        </p:txBody>
-      </p:sp>
-      <p:sp>
-        <p:nvSpPr>
-          <p:cNvPr id="11" name="Text Placeholder 10">
-            <a:extLst>
-              <a:ext uri="{FF2B5EF4-FFF2-40B4-BE49-F238E27FC236}">
-                <a16:creationId xmlns:a16="http://schemas.microsoft.com/office/drawing/2014/main" id="{1F26DFCC-8E7D-1978-2365-F7F9D4B55141}"/>
-              </a:ext>
-            </a:extLst>
-          </p:cNvPr>
-          <p:cNvSpPr>
-            <a:spLocks noGrp="1"/>
-          </p:cNvSpPr>
-          <p:nvPr>
-            <p:ph type="body" sz="quarter" idx="29"/>
-          </p:nvPr>
-        </p:nvSpPr>
-        <p:spPr>
-          <a:xfrm>
-            <a:off x="22276160" y="3809826"/>
-            <a:ext cx="6131740" cy="1282723"/>
-          </a:xfrm>
-        </p:spPr>
-        <p:txBody>
-          <a:bodyPr/>
-          <a:lstStyle/>
-          <a:p>
-            <a:r>
-              <a:rPr lang="en-GB" b="1" noProof="0" dirty="0"/>
-              <a:t>Leonard Hegemann</a:t>
-            </a:r>
-          </a:p>
-          <a:p>
-            <a:r>
-              <a:rPr lang="en-GB" noProof="0" dirty="0"/>
-              <a:t>CHAIR of Digital Management</a:t>
-            </a:r>
-          </a:p>
-          <a:p>
-            <a:r>
-              <a:rPr lang="en-GB" noProof="0" dirty="0"/>
-              <a:t>University of Hohenheim, Germany</a:t>
-            </a:r>
-          </a:p>
-        </p:txBody>
-      </p:sp>
-      <p:sp>
-        <p:nvSpPr>
-          <p:cNvPr id="12" name="Text Placeholder 11">
-            <a:extLst>
-              <a:ext uri="{FF2B5EF4-FFF2-40B4-BE49-F238E27FC236}">
-                <a16:creationId xmlns:a16="http://schemas.microsoft.com/office/drawing/2014/main" id="{5BAD6F67-C4FB-7F23-6C32-BCE2289A544E}"/>
-              </a:ext>
-            </a:extLst>
-          </p:cNvPr>
-          <p:cNvSpPr>
-            <a:spLocks noGrp="1"/>
-          </p:cNvSpPr>
-          <p:nvPr>
-            <p:ph type="body" sz="quarter" idx="39"/>
-          </p:nvPr>
-        </p:nvSpPr>
-        <p:spPr>
-          <a:xfrm>
-            <a:off x="8526517" y="40646451"/>
-            <a:ext cx="20192403" cy="1236655"/>
-          </a:xfrm>
-        </p:spPr>
-        <p:txBody>
-          <a:bodyPr/>
-          <a:lstStyle/>
-          <a:p>
-            <a:pPr algn="just">
-              <a:lnSpc>
-                <a:spcPts val="1200"/>
-              </a:lnSpc>
-              <a:spcAft>
-                <a:spcPts val="0"/>
-              </a:spcAft>
-            </a:pPr>
-            <a:r>
-              <a:rPr lang="en-GB" sz="1200" noProof="0" dirty="0"/>
-              <a:t>Cannon-Bowers, J. A., Salas, E., &amp; Converse, S. (1993). Shared mental models in expert team decision making. In N. J. Castellan Jr. (Ed.), Individual and group decision making: Current issues (pp. 221–246). Lawrence Erlbaum Associates.</a:t>
-            </a:r>
-          </a:p>
-          <a:p>
-            <a:pPr algn="just">
-              <a:lnSpc>
-                <a:spcPts val="1200"/>
-              </a:lnSpc>
-              <a:spcAft>
-                <a:spcPts val="0"/>
-              </a:spcAft>
-            </a:pPr>
-            <a:r>
-              <a:rPr lang="en-GB" sz="1200" noProof="0" dirty="0"/>
-              <a:t>Liu, N. F., Lin, K., Hewitt, J., Paranjape, A., Bevilacqua, M., Petroni, F., &amp; Liang, P. (2024). Lost in the middle: How language models use long contexts. Transactions of the Association for Computational Linguistics, 12, 157–173.</a:t>
-            </a:r>
-          </a:p>
-          <a:p>
-            <a:pPr algn="just">
-              <a:lnSpc>
-                <a:spcPts val="1200"/>
-              </a:lnSpc>
-              <a:spcAft>
-                <a:spcPts val="0"/>
-              </a:spcAft>
-            </a:pPr>
-            <a:r>
-              <a:rPr lang="en-GB" sz="1200" noProof="0" dirty="0"/>
-              <a:t>Mathieu, J. E., Heffner, T. S., Goodwin, G. F., Salas, E., &amp; Cannon-Bowers, J. A. (2000). The influence of shared mental models on team process and performance. Journal of Applied Psychology, 85(2), 273–283.</a:t>
-            </a:r>
-          </a:p>
-          <a:p>
-            <a:pPr algn="just">
-              <a:lnSpc>
-                <a:spcPts val="1200"/>
-              </a:lnSpc>
-              <a:spcAft>
-                <a:spcPts val="0"/>
-              </a:spcAft>
-            </a:pPr>
-            <a:r>
-              <a:rPr lang="en-GB" sz="1200" noProof="0" dirty="0"/>
-              <a:t>Schulz-Hardt, S., Brodbeck, F. C., </a:t>
-            </a:r>
-            <a:r>
-              <a:rPr lang="en-GB" sz="1200" noProof="0" dirty="0" err="1"/>
-              <a:t>Mojzisch</a:t>
-            </a:r>
-            <a:r>
-              <a:rPr lang="en-GB" sz="1200" noProof="0" dirty="0"/>
-              <a:t>, A., </a:t>
-            </a:r>
-            <a:r>
-              <a:rPr lang="en-GB" sz="1200" noProof="0" dirty="0" err="1"/>
-              <a:t>Kerschreiter</a:t>
-            </a:r>
-            <a:r>
-              <a:rPr lang="en-GB" sz="1200" noProof="0" dirty="0"/>
-              <a:t>, R., &amp; Frey, D. (2006). Group decision making in hidden profile situations: Dissent as a facilitator for decision quality. Journal of Personality and Social Psychology, 91(6), 1080–1093.</a:t>
-            </a:r>
-          </a:p>
-          <a:p>
-            <a:pPr algn="just">
-              <a:lnSpc>
-                <a:spcPts val="1200"/>
-              </a:lnSpc>
-              <a:spcAft>
-                <a:spcPts val="0"/>
-              </a:spcAft>
-            </a:pPr>
-            <a:r>
-              <a:rPr lang="en-GB" sz="1200" noProof="0" dirty="0"/>
-              <a:t>Stasser, G., &amp; Titus, W. (1985). Pooling of unshared information in group decision making: Biased information sampling during discussion. Journal of Personality and Social Psychology, 48(6), 1467–1478.</a:t>
-            </a:r>
-          </a:p>
-          <a:p>
-            <a:pPr algn="just">
-              <a:lnSpc>
-                <a:spcPts val="1200"/>
-              </a:lnSpc>
-              <a:spcAft>
-                <a:spcPts val="0"/>
-              </a:spcAft>
-            </a:pPr>
-            <a:r>
-              <a:rPr lang="en-GB" sz="1200" noProof="0" dirty="0"/>
-              <a:t>Van Ginkel, W. P., &amp; van Knippenberg, D. (2008). Group information elaboration and group decision making: The role of shared task representations. Organizational </a:t>
-            </a:r>
-            <a:r>
-              <a:rPr lang="en-GB" sz="1200" noProof="0" dirty="0" err="1"/>
-              <a:t>Behavior</a:t>
-            </a:r>
-            <a:r>
-              <a:rPr lang="en-GB" sz="1200" noProof="0" dirty="0"/>
-              <a:t> and Human Decision Processes, 105(1), 82–97.</a:t>
-            </a:r>
-          </a:p>
-          <a:p>
-            <a:pPr algn="just">
-              <a:lnSpc>
-                <a:spcPts val="1200"/>
-              </a:lnSpc>
-              <a:spcAft>
-                <a:spcPts val="0"/>
-              </a:spcAft>
-            </a:pPr>
-            <a:r>
-              <a:rPr lang="en-GB" sz="1200" noProof="0" dirty="0"/>
-              <a:t>Yen, J., Fan, X., Sun, S., Hanratty, T., &amp; </a:t>
-            </a:r>
-            <a:r>
-              <a:rPr lang="en-GB" sz="1200" noProof="0" dirty="0" err="1"/>
-              <a:t>Dumer</a:t>
-            </a:r>
-            <a:r>
-              <a:rPr lang="en-GB" sz="1200" noProof="0" dirty="0"/>
-              <a:t>, J. (2006). Agents with shared mental models for enhancing team decision makings. Decision Support Systems, 41(3), 634–653.</a:t>
-            </a:r>
-          </a:p>
-          <a:p>
-            <a:pPr algn="just">
-              <a:lnSpc>
-                <a:spcPts val="1200"/>
-              </a:lnSpc>
-              <a:spcAft>
-                <a:spcPts val="0"/>
-              </a:spcAft>
-            </a:pPr>
-            <a:r>
-              <a:rPr lang="en-GB" sz="1200" noProof="0" dirty="0"/>
-              <a:t>Zhang, Z., Dai, Q., Bo, X., Ma, C., Li, R., Chen, X., Zhu, J., Dong, Z., &amp; Wen, J.-R. (2025). A survey on the memory mechanism of large language model-based agents. ACM Transactions on Information Systems, 43(6), Article 155, 1–47.</a:t>
-            </a:r>
-          </a:p>
-        </p:txBody>
-      </p:sp>
       <p:sp>
         <p:nvSpPr>
           <p:cNvPr id="13" name="TextBox 12">
@@ -7438,8 +7443,8 @@
         </p:nvSpPr>
         <p:spPr>
           <a:xfrm>
-            <a:off x="979486" y="6078981"/>
-            <a:ext cx="6908165" cy="1049106"/>
+            <a:off x="980617" y="6223396"/>
+            <a:ext cx="6916143" cy="1050318"/>
           </a:xfrm>
           <a:prstGeom prst="rect">
             <a:avLst/>
@@ -7447,13 +7452,13 @@
           <a:noFill/>
         </p:spPr>
         <p:txBody>
-          <a:bodyPr wrap="square" lIns="0" tIns="72000" rIns="0" bIns="144000" rtlCol="0">
+          <a:bodyPr wrap="square" lIns="0" tIns="72083" rIns="0" bIns="144166" rtlCol="0">
             <a:spAutoFit/>
           </a:bodyPr>
           <a:lstStyle/>
           <a:p>
             <a:r>
-              <a:rPr lang="en-GB" sz="5400" b="1" noProof="0" dirty="0">
+              <a:rPr lang="en-GB" sz="5406" b="1" dirty="0">
                 <a:solidFill>
                   <a:schemeClr val="tx2"/>
                 </a:solidFill>
@@ -7477,8 +7482,8 @@
         </p:nvSpPr>
         <p:spPr>
           <a:xfrm>
-            <a:off x="979486" y="7147362"/>
-            <a:ext cx="28765418" cy="3231654"/>
+            <a:off x="980617" y="7293011"/>
+            <a:ext cx="28798640" cy="3235386"/>
           </a:xfrm>
           <a:prstGeom prst="rect">
             <a:avLst/>
@@ -7493,54 +7498,14 @@
           <a:p>
             <a:pPr algn="just"/>
             <a:r>
-              <a:rPr lang="en-GB" sz="3000" noProof="0" dirty="0">
+              <a:rPr lang="en-GB" sz="3004" dirty="0">
                 <a:solidFill>
                   <a:schemeClr val="tx1">
                     <a:lumMod val="75000"/>
                   </a:schemeClr>
                 </a:solidFill>
               </a:rPr>
-              <a:t>Collective decision making in tasks involving distributed information depends on whether team members disclose and integrate their distributed knowledge. This challenge is central to complex knowledge work, which requires the integration of diverse cognitive skills and is therefore performed collaboratively. Generative artificial intelligence </a:t>
-            </a:r>
-            <a:r>
-              <a:rPr lang="en-GB" sz="3000" dirty="0">
-                <a:solidFill>
-                  <a:schemeClr val="tx1">
-                    <a:lumMod val="75000"/>
-                  </a:schemeClr>
-                </a:solidFill>
-              </a:rPr>
-              <a:t> (GenAI) </a:t>
-            </a:r>
-            <a:r>
-              <a:rPr lang="en-GB" sz="3000" noProof="0" dirty="0">
-                <a:solidFill>
-                  <a:schemeClr val="tx1">
-                    <a:lumMod val="75000"/>
-                  </a:schemeClr>
-                </a:solidFill>
-              </a:rPr>
-              <a:t>based multi-agent systems (MAS) offer a computational approach to such tasks by giving agents distinct roles and information profiles. However, the mere presence of multiple agents does not guarantee effective and efficient collaboration. Agents must disclose privately held knowledge, retain relevant contributions, and integrate them into a coherent representation of the evolving task. Human team research explains such coordination through the concept of a shared mental model (SMM). </a:t>
-            </a:r>
-            <a:r>
-              <a:rPr lang="en-GB" sz="3000" dirty="0">
-                <a:solidFill>
-                  <a:schemeClr val="tx1">
-                    <a:lumMod val="75000"/>
-                  </a:schemeClr>
-                </a:solidFill>
-              </a:rPr>
-              <a:t>B</a:t>
-            </a:r>
-            <a:r>
-              <a:rPr lang="en-GB" sz="3000" noProof="0" dirty="0">
-                <a:solidFill>
-                  <a:schemeClr val="tx1">
-                    <a:lumMod val="75000"/>
-                  </a:schemeClr>
-                </a:solidFill>
-              </a:rPr>
-              <a:t>y translating the functions associated with task and team mental models into a computational mechanism, this study investigates whether an SMM-inspired structured memory mechanism improves the efficiency and effectiveness of GenAI-based MAS across different levels of access to prior discussion history.</a:t>
+              <a:t>Collective decision making in tasks involving distributed information depends on whether team members disclose and integrate their distributed knowledge. This challenge is central to complex knowledge work, which requires the integration of diverse cognitive skills and is therefore performed collaboratively. Generative artificial intelligence  (GenAI) based multi-agent systems (MAS) offer a computational approach to such tasks by giving agents distinct roles and information profiles. However, the mere presence of multiple agents does not guarantee effective and efficient collaboration. Agents must disclose privately held knowledge, retain relevant contributions, and integrate them into a coherent representation of the evolving task. Human team research explains such coordination through the concept of a shared mental model (SMM). By translating the functions associated with task and team mental models into a computational mechanism, this study investigates whether an SMM-inspired structured memory mechanism improves the efficiency and effectiveness of GenAI-based MAS across different levels of access to prior discussion history.</a:t>
             </a:r>
           </a:p>
         </p:txBody>
@@ -7559,8 +7524,8 @@
         </p:nvSpPr>
         <p:spPr>
           <a:xfrm>
-            <a:off x="979486" y="10421999"/>
-            <a:ext cx="17446626" cy="1085458"/>
+            <a:off x="980617" y="10571430"/>
+            <a:ext cx="17466775" cy="1086712"/>
           </a:xfrm>
           <a:prstGeom prst="rect">
             <a:avLst/>
@@ -7568,13 +7533,13 @@
           <a:noFill/>
         </p:spPr>
         <p:txBody>
-          <a:bodyPr wrap="square" lIns="0" tIns="72000" rIns="0" bIns="144000" rtlCol="0">
+          <a:bodyPr wrap="square" lIns="0" tIns="72083" rIns="0" bIns="144166" rtlCol="0">
             <a:spAutoFit/>
           </a:bodyPr>
           <a:lstStyle/>
           <a:p>
             <a:r>
-              <a:rPr lang="en-GB" sz="5400" b="1" noProof="0" dirty="0">
+              <a:rPr lang="en-GB" sz="5406" b="1" dirty="0">
                 <a:solidFill>
                   <a:schemeClr val="tx2"/>
                 </a:solidFill>
@@ -7598,8 +7563,8 @@
         </p:nvSpPr>
         <p:spPr>
           <a:xfrm>
-            <a:off x="979486" y="11545819"/>
-            <a:ext cx="13250069" cy="10156627"/>
+            <a:off x="980617" y="11696549"/>
+            <a:ext cx="13265372" cy="10168357"/>
           </a:xfrm>
           <a:prstGeom prst="rect">
             <a:avLst/>
@@ -7614,40 +7579,20 @@
           <a:p>
             <a:pPr algn="just"/>
             <a:r>
-              <a:rPr lang="en-GB" sz="3000" noProof="0" dirty="0">
+              <a:rPr lang="en-GB" sz="3004" dirty="0">
                 <a:solidFill>
                   <a:schemeClr val="tx1">
                     <a:lumMod val="75000"/>
                   </a:schemeClr>
                 </a:solidFill>
               </a:rPr>
-              <a:t>Research commonly explains team performance through the input-process</a:t>
-            </a:r>
-            <a:r>
-              <a:rPr lang="en-GB" sz="3000" dirty="0">
-                <a:solidFill>
-                  <a:schemeClr val="tx1">
-                    <a:lumMod val="75000"/>
-                  </a:schemeClr>
-                </a:solidFill>
-              </a:rPr>
-              <a:t>-</a:t>
-            </a:r>
-            <a:r>
-              <a:rPr lang="en-GB" sz="3000" noProof="0" dirty="0">
-                <a:solidFill>
-                  <a:schemeClr val="tx1">
-                    <a:lumMod val="75000"/>
-                  </a:schemeClr>
-                </a:solidFill>
-              </a:rPr>
-              <a:t>outcome (I-P-O) framework. Inputs comprise the resources and conditions available to a team, processes describe how members transform inputs into outputs, and outcomes capture the results of their collective work. One central input factor is the SMM. It provides team members with a sufficiently compatible understanding of the task, the team, and the current situation. This common cognitive basis helps members anticipate what information others need, connect individual contributions to the collective task, and coordinate their actions. Within the I-P-O framework, SMMs affect two central team processes: communication and cooperation, which in turn shape the team performance.</a:t>
+              <a:t>Research commonly explains team performance through the input-process-outcome (I-P-O) framework. Inputs comprise the resources and conditions available to a team, processes describe how members transform inputs into outputs, and outcomes capture the results of their collective work. One central input factor is the SMM. It provides team members with a sufficiently compatible understanding of the task, the team, and the current situation. This common cognitive basis helps members anticipate what information others need, connect individual contributions to the collective task, and coordinate their actions. Within the I-P-O framework, SMMs affect two central team processes: communication and cooperation, which in turn shape team performance.</a:t>
             </a:r>
           </a:p>
           <a:p>
             <a:pPr algn="just"/>
             <a:r>
-              <a:rPr lang="en-GB" sz="3000" noProof="0" dirty="0">
+              <a:rPr lang="en-GB" sz="3004" dirty="0">
                 <a:solidFill>
                   <a:schemeClr val="tx1">
                     <a:lumMod val="75000"/>
@@ -7673,8 +7618,8 @@
         </p:nvSpPr>
         <p:spPr>
           <a:xfrm>
-            <a:off x="14526445" y="21146337"/>
-            <a:ext cx="15218459" cy="5539978"/>
+            <a:off x="14543222" y="21308154"/>
+            <a:ext cx="15236035" cy="5546376"/>
           </a:xfrm>
           <a:prstGeom prst="rect">
             <a:avLst/>
@@ -7689,14 +7634,14 @@
           <a:p>
             <a:pPr algn="just"/>
             <a:r>
-              <a:rPr lang="en-GB" sz="3000" noProof="0" dirty="0">
+              <a:rPr lang="en-GB" sz="3004" dirty="0">
                 <a:solidFill>
                   <a:schemeClr val="tx1">
                     <a:lumMod val="75000"/>
                   </a:schemeClr>
                 </a:solidFill>
               </a:rPr>
-              <a:t>The study is based on 800 independent simulations of a hidden-profile personnel-selection task. Three GenAI-based agents acted as an airline hiring panel and selected one of four candidates for a long-distance pilot position. According to the hidden profile paradigm, all agents received shared task materials, while also holding private candidate information. Candidate C was the superior choice in the complete information set and could only be identified if agents disclosed and integrated their private facts. The study compared a baseline without a structured memory mechanism with three structured memory configurations that differed in discussion history transparency: low (only the immediately preceding contribution), moderate (full public discussion history), and high (full public history plus prior reasoning traces). The study measured communication quality, cooperation quality, weighted token usage as a proxy for efficiency, and correct selection of Candidate C as a proxy for effectiveness.</a:t>
+              <a:t>The study is based on 800 independent simulations of a hidden-profile personnel-selection task. Three GenAI-based agents acted as an airline hiring panel and selected one of four candidates for a long-distance pilot position. According to the hidden profile paradigm, all agents received shared task materials, while also holding private information about the candidates. Candidate C was the superior choice in the complete information set and could only be identified if agents disclosed and integrated their private facts. The study compared a baseline without a structured memory mechanism with three structured memory configurations that differed in discussion history transparency: low (only the immediately preceding contribution), moderate (full public discussion history), and high (full public history plus prior reasoning traces). The study measured communication quality, cooperation quality, weighted token usage as an inverse proxy for efficiency, and correct selection of Candidate C as a proxy for effectiveness.</a:t>
             </a:r>
           </a:p>
         </p:txBody>
@@ -7715,8 +7660,8 @@
         </p:nvSpPr>
         <p:spPr>
           <a:xfrm>
-            <a:off x="979486" y="26731964"/>
-            <a:ext cx="17446626" cy="1049106"/>
+            <a:off x="980617" y="26900232"/>
+            <a:ext cx="17466775" cy="1050318"/>
           </a:xfrm>
           <a:prstGeom prst="rect">
             <a:avLst/>
@@ -7724,13 +7669,13 @@
           <a:noFill/>
         </p:spPr>
         <p:txBody>
-          <a:bodyPr wrap="square" lIns="0" tIns="72000" rIns="0" bIns="144000" rtlCol="0">
+          <a:bodyPr wrap="square" lIns="0" tIns="72083" rIns="0" bIns="144166" rtlCol="0">
             <a:spAutoFit/>
           </a:bodyPr>
           <a:lstStyle/>
           <a:p>
             <a:r>
-              <a:rPr lang="en-GB" sz="5400" b="1" noProof="0" dirty="0">
+              <a:rPr lang="en-GB" sz="5406" b="1" dirty="0">
                 <a:solidFill>
                   <a:schemeClr val="tx2"/>
                 </a:solidFill>
@@ -7754,8 +7699,8 @@
         </p:nvSpPr>
         <p:spPr>
           <a:xfrm>
-            <a:off x="14526443" y="20086270"/>
-            <a:ext cx="17446626" cy="1049106"/>
+            <a:off x="14543220" y="20246862"/>
+            <a:ext cx="17466775" cy="1050318"/>
           </a:xfrm>
           <a:prstGeom prst="rect">
             <a:avLst/>
@@ -7763,13 +7708,13 @@
           <a:noFill/>
         </p:spPr>
         <p:txBody>
-          <a:bodyPr wrap="square" lIns="0" tIns="72000" rIns="0" bIns="144000" rtlCol="0">
+          <a:bodyPr wrap="square" lIns="0" tIns="72083" rIns="0" bIns="144166" rtlCol="0">
             <a:spAutoFit/>
           </a:bodyPr>
           <a:lstStyle/>
           <a:p>
             <a:r>
-              <a:rPr lang="en-GB" sz="5400" b="1" noProof="0" dirty="0">
+              <a:rPr lang="en-GB" sz="5406" b="1" dirty="0">
                 <a:solidFill>
                   <a:schemeClr val="tx2"/>
                 </a:solidFill>
@@ -7793,8 +7738,8 @@
         </p:nvSpPr>
         <p:spPr>
           <a:xfrm>
-            <a:off x="978225" y="27814568"/>
-            <a:ext cx="28765417" cy="4616648"/>
+            <a:off x="978833" y="27984086"/>
+            <a:ext cx="28798639" cy="4621980"/>
           </a:xfrm>
           <a:prstGeom prst="rect">
             <a:avLst/>
@@ -7809,19 +7754,19 @@
           <a:p>
             <a:pPr algn="just"/>
             <a:r>
-              <a:rPr lang="en-GB" sz="3000" noProof="0" dirty="0">
+              <a:rPr lang="en-GB" sz="3004" dirty="0">
                 <a:solidFill>
                   <a:schemeClr val="tx1">
                     <a:lumMod val="75000"/>
                   </a:schemeClr>
                 </a:solidFill>
               </a:rPr>
-              <a:t>OLS regression models with HC3 standard errors were estimated for communication quality, cooperation quality, and efficiency, while effectiveness was analysed using a logistic regression. The analyses yielded three main findings. First, the structured memory configurations achieved higher percentages of correct decisions than the baseline but required substantially more weighted tokens. Low transparency produced the highest communication and cooperation scores, and the highest percentage of correct decisions among all context configurations. Second, more discussion history was not necessarily beneficial. Compared with moderate transparency, high transparency increased weighted token usage and reduced decision effectiveness. Third, communication and cooperation fulfil distinct functions in GenAI-based MAS. Greater uptake of initially private information was associated with a higher probability of a correct decision but also with greater token usage. Greater integration of others’ contributions was associated with lower token usage and was marginally positively associated with decision effectiveness. Overall, GenAI-based MAS benefit more from a compact, structured representation of the team’s evolving knowledge than from extensive access to prior discussion history. Designers should therefore prioritise structured memory over raw discussion history, as context composition is more important than context volume alone.</a:t>
+              <a:t>OLS regression models with HC3 standard errors were estimated for communication quality, cooperation quality, and efficiency, while effectiveness was analysed using a logistic regression. The analyses yielded three main findings. First, the structured memory configurations achieved higher percentages of correct decisions than the baseline but required substantially more weighted tokens. Low discussion history transparency produced the highest communication and cooperation scores, and the highest percentage of correct decisions among all context configurations. Second, greater access to discussion history was not necessarily beneficial. Compared with moderate discussion history transparency, high transparency increased weighted token usage and reduced effectiveness. Third, communication and cooperation fulfil distinct functions in GenAI-based MAS. Greater communication quality was associated with a higher probability of a correct decision but also with greater token usage. Greater cooperation quality was associated with lower token usage and showed a marginal positive association with effectiveness. Overall, GenAI-based MAS benefit more from a compact, structured representation of the team’s evolving knowledge than from extensive access to prior discussion history. Designers should therefore prioritise structured memory over raw discussion history, as context composition is more important than context volume alone.</a:t>
             </a:r>
           </a:p>
           <a:p>
             <a:pPr algn="just"/>
-            <a:endParaRPr lang="en-GB" sz="3000" noProof="0" dirty="0">
+            <a:endParaRPr lang="en-GB" sz="3004" dirty="0">
               <a:solidFill>
                 <a:schemeClr val="tx1">
                   <a:lumMod val="75000"/>
@@ -7845,8 +7790,8 @@
         </p:nvSpPr>
         <p:spPr>
           <a:xfrm>
-            <a:off x="14526444" y="19700301"/>
-            <a:ext cx="14400000" cy="369332"/>
+            <a:off x="14543220" y="19860448"/>
+            <a:ext cx="14416631" cy="369759"/>
           </a:xfrm>
           <a:prstGeom prst="rect">
             <a:avLst/>
@@ -7860,7 +7805,7 @@
           <a:lstStyle/>
           <a:p>
             <a:r>
-              <a:rPr lang="en-GB" sz="2400" i="1" noProof="0" dirty="0">
+              <a:rPr lang="en-GB" sz="2403" i="1" dirty="0">
                 <a:solidFill>
                   <a:schemeClr val="tx1">
                     <a:lumMod val="75000"/>
@@ -7886,8 +7831,8 @@
         </p:nvSpPr>
         <p:spPr>
           <a:xfrm>
-            <a:off x="977954" y="38384786"/>
-            <a:ext cx="6909697" cy="738664"/>
+            <a:off x="979084" y="38774039"/>
+            <a:ext cx="6917677" cy="739517"/>
           </a:xfrm>
           <a:prstGeom prst="rect">
             <a:avLst/>
@@ -7901,7 +7846,7 @@
           <a:lstStyle/>
           <a:p>
             <a:r>
-              <a:rPr lang="en-GB" sz="2400" i="1" noProof="0" dirty="0">
+              <a:rPr lang="en-GB" sz="2403" i="1" dirty="0">
                 <a:solidFill>
                   <a:schemeClr val="tx1">
                     <a:lumMod val="75000"/>
@@ -7927,8 +7872,8 @@
         </p:nvSpPr>
         <p:spPr>
           <a:xfrm>
-            <a:off x="8526517" y="38384786"/>
-            <a:ext cx="6909697" cy="1107996"/>
+            <a:off x="16093125" y="38774039"/>
+            <a:ext cx="6917677" cy="1109276"/>
           </a:xfrm>
           <a:prstGeom prst="rect">
             <a:avLst/>
@@ -7942,32 +7887,15 @@
           <a:lstStyle/>
           <a:p>
             <a:r>
-              <a:rPr lang="en-GB" sz="2400" i="1" noProof="0" dirty="0">
+              <a:rPr lang="en-GB" sz="2403" i="1" dirty="0">
                 <a:solidFill>
                   <a:schemeClr val="tx1">
                     <a:lumMod val="75000"/>
                   </a:schemeClr>
                 </a:solidFill>
               </a:rPr>
-              <a:t>Figure 4: Mean cooperation quality scores (ranging from 0 to 1) across experimental </a:t>
-            </a:r>
-            <a:r>
-              <a:rPr lang="en-GB" sz="2400" i="1" dirty="0">
-                <a:solidFill>
-                  <a:schemeClr val="tx1">
-                    <a:lumMod val="75000"/>
-                  </a:schemeClr>
-                </a:solidFill>
-              </a:rPr>
-              <a:t>conditions with 95% confidence intervals</a:t>
-            </a:r>
-            <a:endParaRPr lang="en-GB" sz="2400" i="1" noProof="0" dirty="0">
-              <a:solidFill>
-                <a:schemeClr val="tx1">
-                  <a:lumMod val="75000"/>
-                </a:schemeClr>
-              </a:solidFill>
-            </a:endParaRPr>
+              <a:t>Figure 5: Mean cooperation quality scores (ranging from 0 to 1) across experimental conditions with 95% confidence intervals</a:t>
+            </a:r>
           </a:p>
         </p:txBody>
       </p:sp>
@@ -7985,8 +7913,8 @@
         </p:nvSpPr>
         <p:spPr>
           <a:xfrm>
-            <a:off x="16075080" y="38384786"/>
-            <a:ext cx="6909697" cy="1107996"/>
+            <a:off x="8535979" y="38774039"/>
+            <a:ext cx="6917677" cy="1109276"/>
           </a:xfrm>
           <a:prstGeom prst="rect">
             <a:avLst/>
@@ -8000,32 +7928,15 @@
           <a:lstStyle/>
           <a:p>
             <a:r>
-              <a:rPr lang="en-GB" sz="2400" i="1" noProof="0" dirty="0">
+              <a:rPr lang="en-GB" sz="2403" i="1" dirty="0">
                 <a:solidFill>
                   <a:schemeClr val="tx1">
                     <a:lumMod val="75000"/>
                   </a:schemeClr>
                 </a:solidFill>
               </a:rPr>
-              <a:t>Figure 5: Mean communication quality scores (ranging from 0 to 1) across experimental </a:t>
-            </a:r>
-            <a:r>
-              <a:rPr lang="en-GB" sz="2400" i="1" dirty="0">
-                <a:solidFill>
-                  <a:schemeClr val="tx1">
-                    <a:lumMod val="75000"/>
-                  </a:schemeClr>
-                </a:solidFill>
-              </a:rPr>
-              <a:t>conditions with 95% confidence intervals</a:t>
-            </a:r>
-            <a:endParaRPr lang="en-GB" sz="2400" i="1" noProof="0" dirty="0">
-              <a:solidFill>
-                <a:schemeClr val="tx1">
-                  <a:lumMod val="75000"/>
-                </a:schemeClr>
-              </a:solidFill>
-            </a:endParaRPr>
+              <a:t>Figure 4: Mean communication quality scores (ranging from 0 to 1) across experimental conditions with 95% confidence intervals</a:t>
+            </a:r>
           </a:p>
         </p:txBody>
       </p:sp>
@@ -8043,8 +7954,8 @@
         </p:nvSpPr>
         <p:spPr>
           <a:xfrm>
-            <a:off x="979486" y="26302717"/>
-            <a:ext cx="13148900" cy="383598"/>
+            <a:off x="980617" y="26470489"/>
+            <a:ext cx="13164086" cy="384041"/>
           </a:xfrm>
           <a:prstGeom prst="rect">
             <a:avLst/>
@@ -8058,7 +7969,7 @@
           <a:lstStyle/>
           <a:p>
             <a:r>
-              <a:rPr lang="en-GB" sz="2400" i="1" noProof="0" dirty="0">
+              <a:rPr lang="en-GB" sz="2403" i="1" dirty="0">
                 <a:solidFill>
                   <a:schemeClr val="tx1">
                     <a:lumMod val="75000"/>
@@ -8084,8 +7995,8 @@
         </p:nvSpPr>
         <p:spPr>
           <a:xfrm>
-            <a:off x="14526444" y="11545819"/>
-            <a:ext cx="15218459" cy="3693319"/>
+            <a:off x="14543221" y="11696549"/>
+            <a:ext cx="15236035" cy="3697584"/>
           </a:xfrm>
           <a:prstGeom prst="rect">
             <a:avLst/>
@@ -8100,7 +8011,7 @@
           <a:p>
             <a:pPr algn="just"/>
             <a:r>
-              <a:rPr lang="en-GB" sz="3000" noProof="0" dirty="0">
+              <a:rPr lang="en-GB" sz="3004" dirty="0">
                 <a:solidFill>
                   <a:schemeClr val="tx1">
                     <a:lumMod val="75000"/>
@@ -8126,8 +8037,8 @@
         </p:nvSpPr>
         <p:spPr>
           <a:xfrm>
-            <a:off x="30710459" y="34501873"/>
-            <a:ext cx="65" cy="461665"/>
+            <a:off x="30745927" y="34679115"/>
+            <a:ext cx="65" cy="462198"/>
           </a:xfrm>
           <a:prstGeom prst="rect">
             <a:avLst/>
@@ -8140,7 +8051,7 @@
           </a:bodyPr>
           <a:lstStyle/>
           <a:p>
-            <a:endParaRPr lang="en-GB" sz="3000" noProof="0" dirty="0">
+            <a:endParaRPr lang="en-GB" sz="3004" dirty="0">
               <a:solidFill>
                 <a:schemeClr val="tx1">
                   <a:lumMod val="75000"/>
@@ -8164,8 +8075,8 @@
         </p:nvSpPr>
         <p:spPr>
           <a:xfrm>
-            <a:off x="23623642" y="38384786"/>
-            <a:ext cx="6119998" cy="1107996"/>
+            <a:off x="23650272" y="38774039"/>
+            <a:ext cx="6127066" cy="1109276"/>
           </a:xfrm>
           <a:prstGeom prst="rect">
             <a:avLst/>
@@ -8179,41 +8090,24 @@
           <a:lstStyle/>
           <a:p>
             <a:r>
-              <a:rPr lang="en-GB" sz="2400" i="1" noProof="0" dirty="0">
+              <a:rPr lang="en-GB" sz="2403" i="1" dirty="0">
                 <a:solidFill>
                   <a:schemeClr val="tx1">
                     <a:lumMod val="75000"/>
                   </a:schemeClr>
                 </a:solidFill>
               </a:rPr>
-              <a:t>Figure 6: Mean weighted token usage across experimental </a:t>
-            </a:r>
-            <a:r>
-              <a:rPr lang="en-GB" sz="2400" i="1" dirty="0">
-                <a:solidFill>
-                  <a:schemeClr val="tx1">
-                    <a:lumMod val="75000"/>
-                  </a:schemeClr>
-                </a:solidFill>
-              </a:rPr>
-              <a:t>conditions with 95% confidence intervals</a:t>
-            </a:r>
-            <a:endParaRPr lang="en-GB" sz="2400" i="1" noProof="0" dirty="0">
-              <a:solidFill>
-                <a:schemeClr val="tx1">
-                  <a:lumMod val="75000"/>
-                </a:schemeClr>
-              </a:solidFill>
-            </a:endParaRPr>
+              <a:t>Figure 6: Mean weighted token usage across experimental conditions with 95% confidence intervals</a:t>
+            </a:r>
           </a:p>
         </p:txBody>
       </p:sp>
       <p:pic>
         <p:nvPicPr>
-          <p:cNvPr id="5" name="Picture 4">
+          <p:cNvPr id="6" name="Picture 5">
             <a:extLst>
               <a:ext uri="{FF2B5EF4-FFF2-40B4-BE49-F238E27FC236}">
-                <a16:creationId xmlns:a16="http://schemas.microsoft.com/office/drawing/2014/main" id="{FF0BAE38-FF8C-E9E7-9E65-50695E1C36C6}"/>
+                <a16:creationId xmlns:a16="http://schemas.microsoft.com/office/drawing/2014/main" id="{081193B4-E7B3-B46B-A7A4-1A01E2139A33}"/>
               </a:ext>
             </a:extLst>
           </p:cNvPr>
@@ -8230,8 +8124,8 @@
         </p:blipFill>
         <p:spPr>
           <a:xfrm>
-            <a:off x="14526442" y="15463128"/>
-            <a:ext cx="15217199" cy="4093831"/>
+            <a:off x="979083" y="40163230"/>
+            <a:ext cx="1883871" cy="1883871"/>
           </a:xfrm>
           <a:prstGeom prst="rect">
             <a:avLst/>
@@ -8240,10 +8134,10 @@
       </p:pic>
       <p:pic>
         <p:nvPicPr>
-          <p:cNvPr id="8" name="Picture 7">
+          <p:cNvPr id="16" name="Picture 15">
             <a:extLst>
               <a:ext uri="{FF2B5EF4-FFF2-40B4-BE49-F238E27FC236}">
-                <a16:creationId xmlns:a16="http://schemas.microsoft.com/office/drawing/2014/main" id="{0260EEC3-C1AD-0DCC-184A-02872223880D}"/>
+                <a16:creationId xmlns:a16="http://schemas.microsoft.com/office/drawing/2014/main" id="{B93CC0F5-7A3E-820E-6A66-9A77C83E8CCE}"/>
               </a:ext>
             </a:extLst>
           </p:cNvPr>
@@ -8254,15 +8148,14 @@
         </p:nvPicPr>
         <p:blipFill>
           <a:blip r:embed="rId9"/>
-          <a:srcRect l="27758" t="10170" r="27516" b="58394"/>
           <a:stretch>
             <a:fillRect/>
           </a:stretch>
         </p:blipFill>
         <p:spPr>
           <a:xfrm>
-            <a:off x="977954" y="39948652"/>
-            <a:ext cx="1970257" cy="1959775"/>
+            <a:off x="14543220" y="15471394"/>
+            <a:ext cx="15234771" cy="4098558"/>
           </a:xfrm>
           <a:prstGeom prst="rect">
             <a:avLst/>

</xml_diff>